<commit_message>
deck: rewrite Module 1 slide prose in the author's voice
Plain spoken register per the book voice spec: one fact per sentence, no
aphorisms or metaphors, kill list applied, em dashes cut back. The prompt slide
is now structured with CRAFT (Context, Role, Action, Format, Tone), matching the
book's prompt framework, and the checks slide carries the standing framing that
an LLM works on language rather than arithmetic, so numbers get a Python
validation layer. Lab prompt.txt restructured to the same CRAFT headings.

Co-Authored-By: Claude Opus 5 <noreply@anthropic.com>
</commit_message>
<xml_diff>
--- a/slides/Module-01-Foundations-of-Agentic-AI.pptx
+++ b/slides/Module-01-Foundations-of-Agentic-AI.pptx
@@ -8561,7 +8561,7 @@
                 </a:solidFill>
                 <a:latin typeface="Georgia"/>
               </a:rPr>
-              <a:t>Three hours: understand it, then architect it, then build it</a:t>
+              <a:t>What we do in these three hours</a:t>
             </a:r>
           </a:p>
         </p:txBody>
@@ -9859,7 +9859,7 @@
                 </a:solidFill>
                 <a:latin typeface="Calibri"/>
               </a:rPr>
-              <a:t>You leave with one thing that runs:  </a:t>
+              <a:t>Our goal for today:  </a:t>
             </a:r>
             <a:r>
               <a:rPr sz="1250" b="0">
@@ -9868,7 +9868,7 @@
                 </a:solidFill>
                 <a:latin typeface="Calibri"/>
               </a:rPr>
-              <a:t>a prompt and a Python script that read a filing and return clean, checkable numbers.</a:t>
+              <a:t>a prompt and a Python script that read a filing and return numbers you can check. You build it in Hour 3.</a:t>
             </a:r>
           </a:p>
         </p:txBody>
@@ -10106,7 +10106,7 @@
                 </a:solidFill>
                 <a:latin typeface="Georgia"/>
               </a:rPr>
-              <a:t>Four eras of AI in finance — and banks run all four today</a:t>
+              <a:t>Four eras of AI in finance. Banks run all four today.</a:t>
             </a:r>
           </a:p>
         </p:txBody>
@@ -11286,7 +11286,7 @@
                 </a:solidFill>
                 <a:latin typeface="Georgia"/>
               </a:rPr>
-              <a:t>The point most people miss</a:t>
+              <a:t>What to take from this</a:t>
             </a:r>
           </a:p>
           <a:p>
@@ -11305,7 +11305,7 @@
                 </a:solidFill>
                 <a:latin typeface="Calibri"/>
               </a:rPr>
-              <a:t>No era replaced the one before it. Your bank still runs a hard-coded limit rule from era one, a logistic-regression scorecard from era two, an OCR model from era three and a pilot agent from era four — on the same customer, on the same day. Knowing which tool belongs to which job is half of this course.</a:t>
+              <a:t>No era replaced the one before it. A bank today runs a hard-coded limit rule from era one, a scorecard from era two, an OCR model from era three, and a pilot agent from era four. All four can touch the same customer on the same day. Your job is to know which tool fits which task.</a:t>
             </a:r>
           </a:p>
         </p:txBody>
@@ -11543,7 +11543,7 @@
                 </a:solidFill>
                 <a:latin typeface="Georgia"/>
               </a:rPr>
-              <a:t>Inside the model — tokens, attention, and what it costs</a:t>
+              <a:t>How the model reads: tokens, attention, cost</a:t>
             </a:r>
           </a:p>
         </p:txBody>
@@ -11648,7 +11648,7 @@
                 </a:solidFill>
                 <a:latin typeface="Calibri"/>
               </a:rPr>
-              <a:t>It does not read words. It reads pieces of words called tokens, each turned into numbers. "Revenue" is one token; "₹1,48,320" becomes several.</a:t>
+              <a:t>The model does not read words. It reads pieces of words called tokens. Each token becomes a list of numbers. "Revenue" is one token. "₹1,48,320" becomes several.</a:t>
             </a:r>
           </a:p>
         </p:txBody>
@@ -11753,7 +11753,7 @@
                 </a:solidFill>
                 <a:latin typeface="Calibri"/>
               </a:rPr>
-              <a:t>For every token it weighs which earlier tokens matter. In "the fund cut its fee", attention is what links "its" to "the fund" and not to "fee".</a:t>
+              <a:t>For every token the model decides which earlier tokens matter. In "the fund cut its fee", attention links "its" to "the fund" and not to "fee".</a:t>
             </a:r>
           </a:p>
         </p:txBody>
@@ -11858,7 +11858,7 @@
                 </a:solidFill>
                 <a:latin typeface="Calibri"/>
               </a:rPr>
-              <a:t>The architecture that runs attention across the whole passage at once, layer after layer. That is why it can hold a 200-page filing in view.</a:t>
+              <a:t>The transformer runs attention across the whole passage at once, layer after layer. That is how a model holds a 200-page filing in view.</a:t>
             </a:r>
           </a:p>
         </p:txBody>
@@ -12303,7 +12303,7 @@
                 </a:solidFill>
                 <a:latin typeface="Georgia"/>
               </a:rPr>
-              <a:t>What this means at your desk</a:t>
+              <a:t>What this means for your work</a:t>
             </a:r>
           </a:p>
         </p:txBody>
@@ -12345,7 +12345,7 @@
                 </a:solidFill>
                 <a:latin typeface="Calibri"/>
               </a:rPr>
-              <a:t>▪  It predicts. It does not look up.</a:t>
+              <a:t>▪  The model predicts. It does not look anything up.</a:t>
             </a:r>
           </a:p>
           <a:p>
@@ -12364,7 +12364,7 @@
                 </a:solidFill>
                 <a:latin typeface="Calibri"/>
               </a:rPr>
-              <a:t>There is no database inside the model. It generates the next token that fits the pattern, which is how it can be fluent and wrong at the same time.</a:t>
+              <a:t>There is no database inside the model. It generates the next token that fits the pattern it learned. That is why a wrong answer can still read well.</a:t>
             </a:r>
           </a:p>
         </p:txBody>
@@ -12425,7 +12425,7 @@
                 </a:solidFill>
                 <a:latin typeface="Calibri"/>
               </a:rPr>
-              <a:t>The same question asked two ways gets two answers. That is why prompt design is a skill, not a formality.</a:t>
+              <a:t>Ask the same question two ways and you get two answers. Prompt design is part of the work, not a formality.</a:t>
             </a:r>
           </a:p>
         </p:txBody>
@@ -12486,7 +12486,7 @@
                 </a:solidFill>
                 <a:latin typeface="Calibri"/>
               </a:rPr>
-              <a:t>Every token in and out is billed. A 200-page annual report is about a lakh tokens before the model writes a word of reply.</a:t>
+              <a:t>You are billed for tokens in and tokens out. A 200-page annual report is about one lakh tokens before the model writes a word.</a:t>
             </a:r>
           </a:p>
         </p:txBody>
@@ -12528,7 +12528,7 @@
                 </a:solidFill>
                 <a:latin typeface="Calibri"/>
               </a:rPr>
-              <a:t>▪  Numbers are the weak spot.</a:t>
+              <a:t>▪  Numbers are where it fails.</a:t>
             </a:r>
           </a:p>
           <a:p>
@@ -12547,7 +12547,7 @@
                 </a:solidFill>
                 <a:latin typeface="Calibri"/>
               </a:rPr>
-              <a:t>Digits split into odd pieces, so ₹1,48,320 crore can come back with a digit missing. Always make it return fields you can check.</a:t>
+              <a:t>Digits split into pieces the model has seen less often. A figure like ₹1,48,320 crore can come back with a digit missing. Ask for fields you can check.</a:t>
             </a:r>
           </a:p>
         </p:txBody>
@@ -12785,7 +12785,7 @@
                 </a:solidFill>
                 <a:latin typeface="Georgia"/>
               </a:rPr>
-              <a:t>The agent loop — Observe, Plan, Act, Reflect</a:t>
+              <a:t>The agent loop: Observe, Plan, Act, Reflect</a:t>
             </a:r>
           </a:p>
         </p:txBody>
@@ -13885,7 +13885,7 @@
                 </a:solidFill>
                 <a:latin typeface="Calibri"/>
               </a:rPr>
-              <a:t>↺  The loop restarts at OBSERVE until the goal is met — or until a limit you set stops it.</a:t>
+              <a:t>The loop restarts at OBSERVE until the goal is met, or until a limit you set stops it.</a:t>
             </a:r>
           </a:p>
         </p:txBody>
@@ -13990,7 +13990,7 @@
                 </a:solidFill>
                 <a:latin typeface="Calibri"/>
               </a:rPr>
-              <a:t>Stop after N loops. Without it, a confused agent runs all night.</a:t>
+              <a:t>Stop after a fixed number of loops. Without this, an agent that cannot solve the task keeps trying.</a:t>
             </a:r>
           </a:p>
         </p:txBody>
@@ -14095,7 +14095,7 @@
                 </a:solidFill>
                 <a:latin typeface="Calibri"/>
               </a:rPr>
-              <a:t>A rupee ceiling per task. Cost is what surprises new teams first.</a:t>
+              <a:t>A rupee ceiling per task. Check the cost of one run before you schedule a thousand.</a:t>
             </a:r>
           </a:p>
         </p:txBody>
@@ -14305,7 +14305,7 @@
                 </a:solidFill>
                 <a:latin typeface="Calibri"/>
               </a:rPr>
-              <a:t>Every plan, call and result stored. If you cannot replay it, you cannot defend it.</a:t>
+              <a:t>Store every plan, tool call and result. You need the replay when someone questions the output.</a:t>
             </a:r>
           </a:p>
         </p:txBody>
@@ -14347,7 +14347,7 @@
                 </a:solidFill>
                 <a:latin typeface="Calibri"/>
               </a:rPr>
-              <a:t>Those four boxes are not extras. In a regulated firm they are the difference between a pilot and a production system.</a:t>
+              <a:t>These four are not optional. A regulated firm will not put an agent into production without them.</a:t>
             </a:r>
           </a:p>
         </p:txBody>
@@ -14585,7 +14585,7 @@
                 </a:solidFill>
                 <a:latin typeface="Georgia"/>
               </a:rPr>
-              <a:t>What you hand the model: a tool definition, and a memory</a:t>
+              <a:t>What you give the model: tools and memory</a:t>
             </a:r>
           </a:p>
         </p:txBody>
@@ -14945,7 +14945,7 @@
                 </a:solidFill>
                 <a:latin typeface="Calibri"/>
               </a:rPr>
-              <a:t>You describe the button. The model decides when to press it.</a:t>
+              <a:t>You write the tool definition. The model decides when to call it.</a:t>
             </a:r>
           </a:p>
           <a:p>
@@ -14964,7 +14964,7 @@
                 </a:solidFill>
                 <a:latin typeface="Calibri"/>
               </a:rPr>
-              <a:t>That description is the only manual it gets, so a vague one produces a wrongly-called tool. Your code executes the call, under your credentials and your logging — which is exactly where every governance question a bank asks gets answered.</a:t>
+              <a:t>The description is the only instruction the model gets. Write it vaguely and the tool gets called at the wrong time. Your code runs the call, under your credentials, with your logging. That is where a bank puts its governance controls.</a:t>
             </a:r>
           </a:p>
         </p:txBody>
@@ -15422,7 +15422,7 @@
                 </a:solidFill>
                 <a:latin typeface="Calibri"/>
               </a:rPr>
-              <a:t>A model remembers nothing between calls. All three are plumbing you design — and in a regulated firm, plumbing you must be able to audit.</a:t>
+              <a:t>A model remembers nothing between calls. You build all three. In a regulated firm you must also be able to show what was stored and when it was used.</a:t>
             </a:r>
           </a:p>
         </p:txBody>
@@ -15660,7 +15660,7 @@
                 </a:solidFill>
                 <a:latin typeface="Georgia"/>
               </a:rPr>
-              <a:t>Where the numbers come from — the sources an Indian desk uses</a:t>
+              <a:t>Where the numbers come from: sources an Indian desk uses</a:t>
             </a:r>
           </a:p>
         </p:txBody>
@@ -15912,7 +15912,7 @@
                 </a:solidFill>
                 <a:latin typeface="Calibri"/>
               </a:rPr>
-              <a:t>Public website endpoints are unofficial and rate-limited. Fetch politely, cache locally, never build production on them.</a:t>
+              <a:t>The public website endpoints are unofficial and rate-limited. Fetch slowly, cache what you pull, and do not run production on them.</a:t>
             </a:r>
           </a:p>
         </p:txBody>
@@ -16164,7 +16164,7 @@
                 </a:solidFill>
                 <a:latin typeface="Calibri"/>
               </a:rPr>
-              <a:t>Fine for teaching, prototypes and backtests. Adjustments are imperfect; do not price a book off it.</a:t>
+              <a:t>Good for teaching, prototypes and backtests. Price adjustments are imperfect, so do not value a book with it.</a:t>
             </a:r>
           </a:p>
         </p:txBody>
@@ -16416,7 +16416,7 @@
                 </a:solidFill>
                 <a:latin typeface="Calibri"/>
               </a:rPr>
-              <a:t>Excel and CSV downloads. Slow, awkward and authoritative — the source you cite in a report.</a:t>
+              <a:t>Excel and CSV downloads. It is slow to use, and it is the official source, so cite it in a report.</a:t>
             </a:r>
           </a:p>
         </p:txBody>
@@ -16668,7 +16668,7 @@
                 </a:solidFill>
                 <a:latin typeface="Calibri"/>
               </a:rPr>
-              <a:t>What a real desk pays for. Know the difference between free data and data you can defend.</a:t>
+              <a:t>This is what a desk pays for. Know the difference between free data and data you can defend to a regulator.</a:t>
             </a:r>
           </a:p>
         </p:txBody>
@@ -16773,7 +16773,7 @@
                 </a:solidFill>
                 <a:latin typeface="Calibri"/>
               </a:rPr>
-              <a:t>Keys live in a .env file that git never sees. This is how people get fired.</a:t>
+              <a:t>Keys go in a .env file that git never sees. A key pushed to a public repository is a reportable incident at a bank.</a:t>
             </a:r>
           </a:p>
         </p:txBody>
@@ -16983,7 +16983,7 @@
                 </a:solidFill>
                 <a:latin typeface="Calibri"/>
               </a:rPr>
-              <a:t>“Price at 15:30 IST, 6 Aug 2026” is data. “Price” is an argument waiting to happen.</a:t>
+              <a:t>Record when you pulled the data. “Price at 15:30 IST on 6 Aug 2026” is checkable. “Price” is not.</a:t>
             </a:r>
           </a:p>
         </p:txBody>
@@ -17221,7 +17221,7 @@
                 </a:solidFill>
                 <a:latin typeface="Georgia"/>
               </a:rPr>
-              <a:t>Morgan Stanley — a GPT-4 assistant on the wealth advisor's desk</a:t>
+              <a:t>Morgan Stanley: a GPT-4 assistant on the advisor's desk</a:t>
             </a:r>
           </a:p>
         </p:txBody>
@@ -17370,7 +17370,7 @@
                 </a:solidFill>
                 <a:latin typeface="Calibri"/>
               </a:rPr>
-              <a:t>Morgan Stanley Wealth Management holds a research library of hundreds of thousands of documents. Advisors could not find the right page fast enough during a client call, so the firm's best thinking went unread.</a:t>
+              <a:t>Morgan Stanley Wealth Management holds a research library of hundreds of thousands of documents. An advisor could not find the right page during a client call. The research existed and went unread.</a:t>
             </a:r>
           </a:p>
         </p:txBody>
@@ -17519,7 +17519,7 @@
                 </a:solidFill>
                 <a:latin typeface="Calibri"/>
               </a:rPr>
-              <a:t>“AI @ Morgan Stanley Assistant”, launched September 2023 on OpenAI's GPT-4. It answers advisor questions from the firm's own research library, with citations — retrieval first, generation second. A second tool, Debrief, drafts the notes and follow-up email after a client meeting.</a:t>
+              <a:t>“AI @ Morgan Stanley Assistant”, launched September 2023 on OpenAI's GPT-4. It answers advisor questions from the firm's own research library and cites the source. Retrieval first, generation second. A second tool, Debrief, drafts the notes and the follow-up email after a client meeting.</a:t>
             </a:r>
           </a:p>
         </p:txBody>
@@ -17805,7 +17805,7 @@
                 </a:solidFill>
                 <a:latin typeface="Calibri"/>
               </a:rPr>
-              <a:t>It is grounded, not clever. The model answers from the firm's own documents.</a:t>
+              <a:t>The model answers from the firm's own documents. That is the design.</a:t>
             </a:r>
           </a:p>
         </p:txBody>
@@ -17856,7 +17856,7 @@
                 </a:solidFill>
                 <a:latin typeface="Calibri"/>
               </a:rPr>
-              <a:t>It was pointed at the most repeated, most boring task on the desk — finding things. Not at giving advice.</a:t>
+              <a:t>They aimed it at the most repeated task on the desk, which is finding documents. They did not aim it at giving advice.</a:t>
             </a:r>
           </a:p>
         </p:txBody>
@@ -17907,7 +17907,7 @@
                 </a:solidFill>
                 <a:latin typeface="Calibri"/>
               </a:rPr>
-              <a:t>A human still faces the client. The assistant drafts; the advisor signs.</a:t>
+              <a:t>A human still faces the client. The assistant drafts and the advisor signs.</a:t>
             </a:r>
           </a:p>
         </p:txBody>
@@ -17958,7 +17958,7 @@
                 </a:solidFill>
                 <a:latin typeface="Calibri"/>
               </a:rPr>
-              <a:t>Adoption followed evaluation: answers were tested against expert-written ones first.</a:t>
+              <a:t>Adoption came after evaluation. They tested the answers against expert-written ones before rollout.</a:t>
             </a:r>
           </a:p>
         </p:txBody>
@@ -18009,7 +18009,7 @@
                 </a:solidFill>
                 <a:latin typeface="Calibri"/>
               </a:rPr>
-              <a:t>which single workflow at an Indian bank or GCC would you point this at first — and what would you have to prove before compliance switched it on?    </a:t>
+              <a:t>which workflow at an Indian bank or GCC would you aim this at first, and what would you have to prove before compliance switched it on?    </a:t>
             </a:r>
             <a:r>
               <a:rPr sz="900" b="0">
@@ -18256,7 +18256,7 @@
                 </a:solidFill>
                 <a:latin typeface="Georgia"/>
               </a:rPr>
-              <a:t>Turn raw filing text into numbers you can trust</a:t>
+              <a:t>Our goal: turn raw filing text into numbers you can check</a:t>
             </a:r>
           </a:p>
         </p:txBody>
@@ -19448,7 +19448,7 @@
                 </a:solidFill>
                 <a:latin typeface="Calibri"/>
               </a:rPr>
-              <a:t>Save three P&amp;L pages as .txt. Do not tidy them up — the mess is the test.</a:t>
+              <a:t>Save three P&amp;L pages as .txt. Do not clean them up. The messy formatting is the test.</a:t>
             </a:r>
           </a:p>
         </p:txBody>
@@ -19534,7 +19534,7 @@
                 </a:solidFill>
                 <a:latin typeface="Calibri"/>
               </a:rPr>
-              <a:t>The one rule that makes this hard</a:t>
+              <a:t>The rule for this lab</a:t>
             </a:r>
           </a:p>
           <a:p>
@@ -19553,7 +19553,7 @@
                 </a:solidFill>
                 <a:latin typeface="Calibri"/>
               </a:rPr>
-              <a:t>The model must never produce a number that is not printed in the text. If a field is missing it returns null. A tool that quietly guesses is worse than no tool, because a guess that looks like data travels into a report and out to a client before anyone checks it.</a:t>
+              <a:t>The model must not produce a number that is not printed in the text. If a field is missing, it returns null. A guess that looks like data will travel into a report and out to a client before anyone checks it.</a:t>
             </a:r>
           </a:p>
         </p:txBody>
@@ -19639,7 +19639,7 @@
                 </a:solidFill>
                 <a:latin typeface="Calibri"/>
               </a:rPr>
-              <a:t>Success:  </a:t>
+              <a:t>Done means:  </a:t>
             </a:r>
             <a:r>
               <a:rPr sz="1250" b="0">
@@ -19886,7 +19886,7 @@
                 </a:solidFill>
                 <a:latin typeface="Georgia"/>
               </a:rPr>
-              <a:t>prompt.txt — role, task, schema, rules, then the text</a:t>
+              <a:t>prompt.txt, written with CRAFT</a:t>
             </a:r>
           </a:p>
         </p:txBody>
@@ -20008,13 +20008,32 @@
               </a:spcBef>
             </a:pPr>
             <a:r>
-              <a:rPr sz="1050" b="0">
+              <a:rPr sz="1000" b="0">
+                <a:solidFill>
+                  <a:srgbClr val="C9A227"/>
+                </a:solidFill>
+                <a:latin typeface="Consolas"/>
+              </a:rPr>
+              <a:t>CONTEXT</a:t>
+            </a:r>
+          </a:p>
+          <a:p>
+            <a:pPr algn="l">
+              <a:lnSpc>
+                <a:spcPct val="105000"/>
+              </a:lnSpc>
+              <a:spcBef>
+                <a:spcPts val="250"/>
+              </a:spcBef>
+            </a:pPr>
+            <a:r>
+              <a:rPr sz="1000" b="0">
                 <a:solidFill>
                   <a:srgbClr val="C9D6EE"/>
                 </a:solidFill>
                 <a:latin typeface="Consolas"/>
               </a:rPr>
-              <a:t>You are a financial data extraction engine for an equity</a:t>
+              <a:t>You work on an equity research desk. The text below is copied</a:t>
             </a:r>
           </a:p>
           <a:p>
@@ -20027,13 +20046,13 @@
               </a:spcBef>
             </a:pPr>
             <a:r>
-              <a:rPr sz="1050" b="0">
+              <a:rPr sz="1000" b="0">
                 <a:solidFill>
                   <a:srgbClr val="C9D6EE"/>
                 </a:solidFill>
                 <a:latin typeface="Consolas"/>
               </a:rPr>
-              <a:t>research desk. You do not analyse. You only extract.</a:t>
+              <a:t>straight out of an annual report PDF.</a:t>
             </a:r>
           </a:p>
           <a:p>
@@ -20046,13 +20065,32 @@
               </a:spcBef>
             </a:pPr>
             <a:r>
-              <a:rPr sz="1050" b="0">
+              <a:rPr sz="1000" b="0">
+                <a:solidFill>
+                  <a:srgbClr val="C9A227"/>
+                </a:solidFill>
+                <a:latin typeface="Consolas"/>
+              </a:rPr>
+              <a:t>ROLE</a:t>
+            </a:r>
+          </a:p>
+          <a:p>
+            <a:pPr algn="l">
+              <a:lnSpc>
+                <a:spcPct val="105000"/>
+              </a:lnSpc>
+              <a:spcBef>
+                <a:spcPts val="250"/>
+              </a:spcBef>
+            </a:pPr>
+            <a:r>
+              <a:rPr sz="1000" b="0">
                 <a:solidFill>
                   <a:srgbClr val="C9D6EE"/>
                 </a:solidFill>
                 <a:latin typeface="Consolas"/>
               </a:rPr>
-              <a:t> </a:t>
+              <a:t>You are a financial data extraction engine. You do not analyse.</a:t>
             </a:r>
           </a:p>
           <a:p>
@@ -20065,13 +20103,32 @@
               </a:spcBef>
             </a:pPr>
             <a:r>
-              <a:rPr sz="1050" b="0">
+              <a:rPr sz="1000" b="0">
+                <a:solidFill>
+                  <a:srgbClr val="C9D6EE"/>
+                </a:solidFill>
+                <a:latin typeface="Consolas"/>
+              </a:rPr>
+              <a:t>You only extract.</a:t>
+            </a:r>
+          </a:p>
+          <a:p>
+            <a:pPr algn="l">
+              <a:lnSpc>
+                <a:spcPct val="105000"/>
+              </a:lnSpc>
+              <a:spcBef>
+                <a:spcPts val="250"/>
+              </a:spcBef>
+            </a:pPr>
+            <a:r>
+              <a:rPr sz="1000" b="0">
                 <a:solidFill>
                   <a:srgbClr val="C9A227"/>
                 </a:solidFill>
                 <a:latin typeface="Consolas"/>
               </a:rPr>
-              <a:t>TASK</a:t>
+              <a:t>ACTION</a:t>
             </a:r>
           </a:p>
           <a:p>
@@ -20084,13 +20141,13 @@
               </a:spcBef>
             </a:pPr>
             <a:r>
-              <a:rPr sz="1050" b="0">
+              <a:rPr sz="1000" b="0">
                 <a:solidFill>
                   <a:srgbClr val="C9D6EE"/>
                 </a:solidFill>
                 <a:latin typeface="Consolas"/>
               </a:rPr>
-              <a:t>From the ANNUAL REPORT TEXT below, extract the income</a:t>
+              <a:t>Extract the income statement line items for every period shown.</a:t>
             </a:r>
           </a:p>
           <a:p>
@@ -20103,13 +20160,146 @@
               </a:spcBef>
             </a:pPr>
             <a:r>
-              <a:rPr sz="1050" b="0">
+              <a:rPr sz="1000" b="0">
+                <a:solidFill>
+                  <a:srgbClr val="C9A227"/>
+                </a:solidFill>
+                <a:latin typeface="Consolas"/>
+              </a:rPr>
+              <a:t>FORMAT — return this JSON and nothing else:</a:t>
+            </a:r>
+          </a:p>
+          <a:p>
+            <a:pPr algn="l">
+              <a:lnSpc>
+                <a:spcPct val="105000"/>
+              </a:lnSpc>
+              <a:spcBef>
+                <a:spcPts val="250"/>
+              </a:spcBef>
+            </a:pPr>
+            <a:r>
+              <a:rPr sz="1000" b="0">
+                <a:solidFill>
+                  <a:srgbClr val="FFFFFF"/>
+                </a:solidFill>
+                <a:latin typeface="Consolas"/>
+              </a:rPr>
+              <a:t>{"company": str, "unit": str, "periods": [</a:t>
+            </a:r>
+          </a:p>
+          <a:p>
+            <a:pPr algn="l">
+              <a:lnSpc>
+                <a:spcPct val="105000"/>
+              </a:lnSpc>
+              <a:spcBef>
+                <a:spcPts val="250"/>
+              </a:spcBef>
+            </a:pPr>
+            <a:r>
+              <a:rPr sz="1000" b="0">
+                <a:solidFill>
+                  <a:srgbClr val="FFFFFF"/>
+                </a:solidFill>
+                <a:latin typeface="Consolas"/>
+              </a:rPr>
+              <a:t>  {"period": str, "revenue_from_operations": num|null,</a:t>
+            </a:r>
+          </a:p>
+          <a:p>
+            <a:pPr algn="l">
+              <a:lnSpc>
+                <a:spcPct val="105000"/>
+              </a:lnSpc>
+              <a:spcBef>
+                <a:spcPts val="250"/>
+              </a:spcBef>
+            </a:pPr>
+            <a:r>
+              <a:rPr sz="1000" b="0">
+                <a:solidFill>
+                  <a:srgbClr val="FFFFFF"/>
+                </a:solidFill>
+                <a:latin typeface="Consolas"/>
+              </a:rPr>
+              <a:t>   "other_income": num|null, "total_expenses": num|null,</a:t>
+            </a:r>
+          </a:p>
+          <a:p>
+            <a:pPr algn="l">
+              <a:lnSpc>
+                <a:spcPct val="105000"/>
+              </a:lnSpc>
+              <a:spcBef>
+                <a:spcPts val="250"/>
+              </a:spcBef>
+            </a:pPr>
+            <a:r>
+              <a:rPr sz="1000" b="0">
+                <a:solidFill>
+                  <a:srgbClr val="FFFFFF"/>
+                </a:solidFill>
+                <a:latin typeface="Consolas"/>
+              </a:rPr>
+              <a:t>   "profit_before_tax": num|null, "tax_expense": num|null,</a:t>
+            </a:r>
+          </a:p>
+          <a:p>
+            <a:pPr algn="l">
+              <a:lnSpc>
+                <a:spcPct val="105000"/>
+              </a:lnSpc>
+              <a:spcBef>
+                <a:spcPts val="250"/>
+              </a:spcBef>
+            </a:pPr>
+            <a:r>
+              <a:rPr sz="1000" b="0">
+                <a:solidFill>
+                  <a:srgbClr val="FFFFFF"/>
+                </a:solidFill>
+                <a:latin typeface="Consolas"/>
+              </a:rPr>
+              <a:t>   "profit_after_tax": num|null}]}</a:t>
+            </a:r>
+          </a:p>
+          <a:p>
+            <a:pPr algn="l">
+              <a:lnSpc>
+                <a:spcPct val="105000"/>
+              </a:lnSpc>
+              <a:spcBef>
+                <a:spcPts val="250"/>
+              </a:spcBef>
+            </a:pPr>
+            <a:r>
+              <a:rPr sz="1000" b="0">
+                <a:solidFill>
+                  <a:srgbClr val="C9A227"/>
+                </a:solidFill>
+                <a:latin typeface="Consolas"/>
+              </a:rPr>
+              <a:t>TONE — five rules, no exceptions</a:t>
+            </a:r>
+          </a:p>
+          <a:p>
+            <a:pPr algn="l">
+              <a:lnSpc>
+                <a:spcPct val="105000"/>
+              </a:lnSpc>
+              <a:spcBef>
+                <a:spcPts val="250"/>
+              </a:spcBef>
+            </a:pPr>
+            <a:r>
+              <a:rPr sz="1000" b="0">
                 <a:solidFill>
                   <a:srgbClr val="C9D6EE"/>
                 </a:solidFill>
                 <a:latin typeface="Consolas"/>
               </a:rPr>
-              <a:t>statement line items for the period stated in the text.</a:t>
+              <a:t>1. Copy numbers exactly as printed. Do not compute or convert.</a:t>
             </a:r>
           </a:p>
           <a:p>
@@ -20122,13 +20312,13 @@
               </a:spcBef>
             </a:pPr>
             <a:r>
-              <a:rPr sz="1050" b="0">
+              <a:rPr sz="1000" b="0">
                 <a:solidFill>
                   <a:srgbClr val="C9D6EE"/>
                 </a:solidFill>
                 <a:latin typeface="Consolas"/>
               </a:rPr>
-              <a:t> </a:t>
+              <a:t>2. If a line item is absent, return null. Never guess.</a:t>
             </a:r>
           </a:p>
           <a:p>
@@ -20141,13 +20331,13 @@
               </a:spcBef>
             </a:pPr>
             <a:r>
-              <a:rPr sz="1050" b="0">
-                <a:solidFill>
-                  <a:srgbClr val="C9A227"/>
+              <a:rPr sz="1000" b="0">
+                <a:solidFill>
+                  <a:srgbClr val="C9D6EE"/>
                 </a:solidFill>
                 <a:latin typeface="Consolas"/>
               </a:rPr>
-              <a:t>OUTPUT — return this JSON object and nothing else:</a:t>
+              <a:t>3. Plain digits: 148320, not 1,48,320.</a:t>
             </a:r>
           </a:p>
           <a:p>
@@ -20160,13 +20350,13 @@
               </a:spcBef>
             </a:pPr>
             <a:r>
-              <a:rPr sz="1050" b="0">
-                <a:solidFill>
-                  <a:srgbClr val="FFFFFF"/>
+              <a:rPr sz="1000" b="0">
+                <a:solidFill>
+                  <a:srgbClr val="C9D6EE"/>
                 </a:solidFill>
                 <a:latin typeface="Consolas"/>
               </a:rPr>
-              <a:t>{"company": str, "period": str, "unit": str,</a:t>
+              <a:t>4. Put the printed unit in "unit". Do not convert lakh.</a:t>
             </a:r>
           </a:p>
           <a:p>
@@ -20179,13 +20369,13 @@
               </a:spcBef>
             </a:pPr>
             <a:r>
-              <a:rPr sz="1050" b="0">
-                <a:solidFill>
-                  <a:srgbClr val="FFFFFF"/>
+              <a:rPr sz="1000" b="0">
+                <a:solidFill>
+                  <a:srgbClr val="C9D6EE"/>
                 </a:solidFill>
                 <a:latin typeface="Consolas"/>
               </a:rPr>
-              <a:t> "items": {"revenue_from_operations": num|null,</a:t>
+              <a:t>5. No text before or after the JSON.</a:t>
             </a:r>
           </a:p>
           <a:p>
@@ -20198,298 +20388,13 @@
               </a:spcBef>
             </a:pPr>
             <a:r>
-              <a:rPr sz="1050" b="0">
-                <a:solidFill>
-                  <a:srgbClr val="FFFFFF"/>
+              <a:rPr sz="1000" b="0">
+                <a:solidFill>
+                  <a:srgbClr val="8FA1C4"/>
                 </a:solidFill>
                 <a:latin typeface="Consolas"/>
               </a:rPr>
-              <a:t>           "other_income": num|null,</a:t>
-            </a:r>
-          </a:p>
-          <a:p>
-            <a:pPr algn="l">
-              <a:lnSpc>
-                <a:spcPct val="105000"/>
-              </a:lnSpc>
-              <a:spcBef>
-                <a:spcPts val="250"/>
-              </a:spcBef>
-            </a:pPr>
-            <a:r>
-              <a:rPr sz="1050" b="0">
-                <a:solidFill>
-                  <a:srgbClr val="FFFFFF"/>
-                </a:solidFill>
-                <a:latin typeface="Consolas"/>
-              </a:rPr>
-              <a:t>           "total_expenses": num|null,</a:t>
-            </a:r>
-          </a:p>
-          <a:p>
-            <a:pPr algn="l">
-              <a:lnSpc>
-                <a:spcPct val="105000"/>
-              </a:lnSpc>
-              <a:spcBef>
-                <a:spcPts val="250"/>
-              </a:spcBef>
-            </a:pPr>
-            <a:r>
-              <a:rPr sz="1050" b="0">
-                <a:solidFill>
-                  <a:srgbClr val="FFFFFF"/>
-                </a:solidFill>
-                <a:latin typeface="Consolas"/>
-              </a:rPr>
-              <a:t>           "profit_before_tax": num|null,</a:t>
-            </a:r>
-          </a:p>
-          <a:p>
-            <a:pPr algn="l">
-              <a:lnSpc>
-                <a:spcPct val="105000"/>
-              </a:lnSpc>
-              <a:spcBef>
-                <a:spcPts val="250"/>
-              </a:spcBef>
-            </a:pPr>
-            <a:r>
-              <a:rPr sz="1050" b="0">
-                <a:solidFill>
-                  <a:srgbClr val="FFFFFF"/>
-                </a:solidFill>
-                <a:latin typeface="Consolas"/>
-              </a:rPr>
-              <a:t>           "tax_expense": num|null,</a:t>
-            </a:r>
-          </a:p>
-          <a:p>
-            <a:pPr algn="l">
-              <a:lnSpc>
-                <a:spcPct val="105000"/>
-              </a:lnSpc>
-              <a:spcBef>
-                <a:spcPts val="250"/>
-              </a:spcBef>
-            </a:pPr>
-            <a:r>
-              <a:rPr sz="1050" b="0">
-                <a:solidFill>
-                  <a:srgbClr val="FFFFFF"/>
-                </a:solidFill>
-                <a:latin typeface="Consolas"/>
-              </a:rPr>
-              <a:t>           "profit_after_tax": num|null}}</a:t>
-            </a:r>
-          </a:p>
-          <a:p>
-            <a:pPr algn="l">
-              <a:lnSpc>
-                <a:spcPct val="105000"/>
-              </a:lnSpc>
-              <a:spcBef>
-                <a:spcPts val="250"/>
-              </a:spcBef>
-            </a:pPr>
-            <a:r>
-              <a:rPr sz="1050" b="0">
-                <a:solidFill>
-                  <a:srgbClr val="C9D6EE"/>
-                </a:solidFill>
-                <a:latin typeface="Consolas"/>
-              </a:rPr>
-              <a:t> </a:t>
-            </a:r>
-          </a:p>
-          <a:p>
-            <a:pPr algn="l">
-              <a:lnSpc>
-                <a:spcPct val="105000"/>
-              </a:lnSpc>
-              <a:spcBef>
-                <a:spcPts val="250"/>
-              </a:spcBef>
-            </a:pPr>
-            <a:r>
-              <a:rPr sz="1050" b="0">
-                <a:solidFill>
-                  <a:srgbClr val="C9A227"/>
-                </a:solidFill>
-                <a:latin typeface="Consolas"/>
-              </a:rPr>
-              <a:t>RULES</a:t>
-            </a:r>
-          </a:p>
-          <a:p>
-            <a:pPr algn="l">
-              <a:lnSpc>
-                <a:spcPct val="105000"/>
-              </a:lnSpc>
-              <a:spcBef>
-                <a:spcPts val="250"/>
-              </a:spcBef>
-            </a:pPr>
-            <a:r>
-              <a:rPr sz="1050" b="0">
-                <a:solidFill>
-                  <a:srgbClr val="C9D6EE"/>
-                </a:solidFill>
-                <a:latin typeface="Consolas"/>
-              </a:rPr>
-              <a:t>1. Copy numbers exactly as printed. Do not compute,</a:t>
-            </a:r>
-          </a:p>
-          <a:p>
-            <a:pPr algn="l">
-              <a:lnSpc>
-                <a:spcPct val="105000"/>
-              </a:lnSpc>
-              <a:spcBef>
-                <a:spcPts val="250"/>
-              </a:spcBef>
-            </a:pPr>
-            <a:r>
-              <a:rPr sz="1050" b="0">
-                <a:solidFill>
-                  <a:srgbClr val="C9D6EE"/>
-                </a:solidFill>
-                <a:latin typeface="Consolas"/>
-              </a:rPr>
-              <a:t>   round, convert or infer anything.</a:t>
-            </a:r>
-          </a:p>
-          <a:p>
-            <a:pPr algn="l">
-              <a:lnSpc>
-                <a:spcPct val="105000"/>
-              </a:lnSpc>
-              <a:spcBef>
-                <a:spcPts val="250"/>
-              </a:spcBef>
-            </a:pPr>
-            <a:r>
-              <a:rPr sz="1050" b="0">
-                <a:solidFill>
-                  <a:srgbClr val="C9D6EE"/>
-                </a:solidFill>
-                <a:latin typeface="Consolas"/>
-              </a:rPr>
-              <a:t>2. If a line item is absent, return null. Never guess.</a:t>
-            </a:r>
-          </a:p>
-          <a:p>
-            <a:pPr algn="l">
-              <a:lnSpc>
-                <a:spcPct val="105000"/>
-              </a:lnSpc>
-              <a:spcBef>
-                <a:spcPts val="250"/>
-              </a:spcBef>
-            </a:pPr>
-            <a:r>
-              <a:rPr sz="1050" b="0">
-                <a:solidFill>
-                  <a:srgbClr val="C9D6EE"/>
-                </a:solidFill>
-                <a:latin typeface="Consolas"/>
-              </a:rPr>
-              <a:t>3. Write numbers as plain digits: 148320, not 1,48,320.</a:t>
-            </a:r>
-          </a:p>
-          <a:p>
-            <a:pPr algn="l">
-              <a:lnSpc>
-                <a:spcPct val="105000"/>
-              </a:lnSpc>
-              <a:spcBef>
-                <a:spcPts val="250"/>
-              </a:spcBef>
-            </a:pPr>
-            <a:r>
-              <a:rPr sz="1050" b="0">
-                <a:solidFill>
-                  <a:srgbClr val="C9D6EE"/>
-                </a:solidFill>
-                <a:latin typeface="Consolas"/>
-              </a:rPr>
-              <a:t>4. Put the printed unit in "unit" — e.g. "INR crore".</a:t>
-            </a:r>
-          </a:p>
-          <a:p>
-            <a:pPr algn="l">
-              <a:lnSpc>
-                <a:spcPct val="105000"/>
-              </a:lnSpc>
-              <a:spcBef>
-                <a:spcPts val="250"/>
-              </a:spcBef>
-            </a:pPr>
-            <a:r>
-              <a:rPr sz="1050" b="0">
-                <a:solidFill>
-                  <a:srgbClr val="C9D6EE"/>
-                </a:solidFill>
-                <a:latin typeface="Consolas"/>
-              </a:rPr>
-              <a:t>5. No text before or after the JSON.</a:t>
-            </a:r>
-          </a:p>
-          <a:p>
-            <a:pPr algn="l">
-              <a:lnSpc>
-                <a:spcPct val="105000"/>
-              </a:lnSpc>
-              <a:spcBef>
-                <a:spcPts val="250"/>
-              </a:spcBef>
-            </a:pPr>
-            <a:r>
-              <a:rPr sz="1050" b="0">
-                <a:solidFill>
-                  <a:srgbClr val="C9D6EE"/>
-                </a:solidFill>
-                <a:latin typeface="Consolas"/>
-              </a:rPr>
-              <a:t> </a:t>
-            </a:r>
-          </a:p>
-          <a:p>
-            <a:pPr algn="l">
-              <a:lnSpc>
-                <a:spcPct val="105000"/>
-              </a:lnSpc>
-              <a:spcBef>
-                <a:spcPts val="250"/>
-              </a:spcBef>
-            </a:pPr>
-            <a:r>
-              <a:rPr sz="1050" b="0">
-                <a:solidFill>
-                  <a:srgbClr val="C9A227"/>
-                </a:solidFill>
-                <a:latin typeface="Consolas"/>
-              </a:rPr>
-              <a:t>ANNUAL REPORT TEXT</a:t>
-            </a:r>
-          </a:p>
-          <a:p>
-            <a:pPr algn="l">
-              <a:lnSpc>
-                <a:spcPct val="105000"/>
-              </a:lnSpc>
-              <a:spcBef>
-                <a:spcPts val="250"/>
-              </a:spcBef>
-            </a:pPr>
-            <a:r>
-              <a:rPr sz="1050" b="0">
-                <a:solidFill>
-                  <a:srgbClr val="8FA1C4"/>
-                </a:solidFill>
-                <a:latin typeface="Consolas"/>
-              </a:rPr>
-              <a:t>"""&lt;excerpt goes here&gt;"""</a:t>
+              <a:t>ANNUAL REPORT TEXT   """&lt;excerpt goes here&gt;"""</a:t>
             </a:r>
           </a:p>
         </p:txBody>
@@ -20619,7 +20524,7 @@
                 </a:solidFill>
                 <a:latin typeface="Calibri"/>
               </a:rPr>
-              <a:t>Role first</a:t>
+              <a:t>CRAFT</a:t>
             </a:r>
           </a:p>
           <a:p>
@@ -20638,7 +20543,7 @@
                 </a:solidFill>
                 <a:latin typeface="Calibri"/>
               </a:rPr>
-              <a:t>Naming the job narrows behaviour more than any adjective. “Extraction engine” rules out commentary.</a:t>
+              <a:t>Context, Role, Action, Format, Tone. Use the same five headings on every prompt you write this semester.</a:t>
             </a:r>
           </a:p>
         </p:txBody>
@@ -20768,7 +20673,7 @@
                 </a:solidFill>
                 <a:latin typeface="Calibri"/>
               </a:rPr>
-              <a:t>Schema, not description</a:t>
+              <a:t>Role</a:t>
             </a:r>
           </a:p>
           <a:p>
@@ -20787,7 +20692,7 @@
                 </a:solidFill>
                 <a:latin typeface="Calibri"/>
               </a:rPr>
-              <a:t>Give the exact JSON shape. A described output is a suggestion; a schema is a contract you can test.</a:t>
+              <a:t>Name the job and the model narrows what it does. An extraction engine does not add commentary.</a:t>
             </a:r>
           </a:p>
         </p:txBody>
@@ -20917,7 +20822,7 @@
                 </a:solidFill>
                 <a:latin typeface="Calibri"/>
               </a:rPr>
-              <a:t>null is a real answer</a:t>
+              <a:t>Format</a:t>
             </a:r>
           </a:p>
           <a:p>
@@ -20936,7 +20841,7 @@
                 </a:solidFill>
                 <a:latin typeface="Calibri"/>
               </a:rPr>
-              <a:t>Rule 2 is the most important line here. It turns a hallucination into a visible gap.</a:t>
+              <a:t>Give the exact JSON shape. If you only describe the output, you cannot test it.</a:t>
             </a:r>
           </a:p>
         </p:txBody>
@@ -21066,7 +20971,7 @@
                 </a:solidFill>
                 <a:latin typeface="Calibri"/>
               </a:rPr>
-              <a:t>Plain digits</a:t>
+              <a:t>Rule 2 is the important one</a:t>
             </a:r>
           </a:p>
           <a:p>
@@ -21085,7 +20990,7 @@
                 </a:solidFill>
                 <a:latin typeface="Calibri"/>
               </a:rPr>
-              <a:t>Rule 3 removes the grouping that tokenises badly, and the output parses without cleaning.</a:t>
+              <a:t>It turns an invented number into a visible gap you can see.</a:t>
             </a:r>
           </a:p>
         </p:txBody>
@@ -21215,7 +21120,7 @@
                 </a:solidFill>
                 <a:latin typeface="Calibri"/>
               </a:rPr>
-              <a:t>Unit carried, not converted</a:t>
+              <a:t>Rule 4</a:t>
             </a:r>
           </a:p>
           <a:p>
@@ -21234,7 +21139,7 @@
                 </a:solidFill>
                 <a:latin typeface="Calibri"/>
               </a:rPr>
-              <a:t>Rule 4 keeps the model out of arithmetic. Convert lakh to crore in Python, where it is auditable.</a:t>
+              <a:t>The model does no arithmetic. You convert lakh to crore in Python, where the logic is auditable.</a:t>
             </a:r>
           </a:p>
         </p:txBody>
@@ -21472,7 +21377,7 @@
                 </a:solidFill>
                 <a:latin typeface="Georgia"/>
               </a:rPr>
-              <a:t>extract.py — twenty lines, and one JSON file per filing</a:t>
+              <a:t>extract.py: twenty lines, one JSON file per filing</a:t>
             </a:r>
           </a:p>
         </p:txBody>
@@ -22466,7 +22371,7 @@
                 </a:solidFill>
                 <a:latin typeface="Calibri"/>
               </a:rPr>
-              <a:t>The same filing must give the same answer every run. Creativity is a defect in extraction.</a:t>
+              <a:t>The same filing must give the same answer on every run. You do not want variation in extraction.</a:t>
             </a:r>
           </a:p>
         </p:txBody>
@@ -22764,7 +22669,7 @@
                 </a:solidFill>
                 <a:latin typeface="Calibri"/>
               </a:rPr>
-              <a:t>The loop is the test. A prompt tried on one document has been tested on nothing.</a:t>
+              <a:t>Run the same prompt on all three files. A prompt tested on one document is not tested.</a:t>
             </a:r>
           </a:p>
         </p:txBody>
@@ -23002,7 +22907,7 @@
                 </a:solidFill>
                 <a:latin typeface="Georgia"/>
               </a:rPr>
-              <a:t>Prove it worked — and fix what breaks</a:t>
+              <a:t>What to check, and how to fix it</a:t>
             </a:r>
           </a:p>
         </p:txBody>
@@ -23449,7 +23354,7 @@
                 </a:solidFill>
                 <a:latin typeface="Calibri"/>
               </a:rPr>
-              <a:t>Search the excerpt for each figure. If it is not printed there, the model invented it.</a:t>
+              <a:t>Search the excerpt for each figure. If it is not printed there, the model made it up.</a:t>
             </a:r>
           </a:p>
         </p:txBody>
@@ -23598,7 +23503,7 @@
                 </a:solidFill>
                 <a:latin typeface="Calibri"/>
               </a:rPr>
-              <a:t>Crore, lakh or million. Get this wrong and it is a factor-of-100 error that survives every later check.</a:t>
+              <a:t>Crore, lakh or million. Get this wrong and you carry a factor-of-100 error through every later step.</a:t>
             </a:r>
           </a:p>
         </p:txBody>
@@ -23684,7 +23589,7 @@
                 </a:solidFill>
                 <a:latin typeface="Calibri"/>
               </a:rPr>
-              <a:t>Check 2 is the real one. </a:t>
+              <a:t>Claude is an LLM. </a:t>
             </a:r>
             <a:r>
               <a:rPr sz="1050" b="0">
@@ -23693,7 +23598,7 @@
                 </a:solidFill>
                 <a:latin typeface="Calibri"/>
               </a:rPr>
-              <a:t>An arithmetic identity the model was told not to compute is the cheapest lie detector you will write.</a:t>
+              <a:t>It works on language, not arithmetic. Any number that matters gets a Python validation layer. Check 2 is that layer.</a:t>
             </a:r>
           </a:p>
         </p:txBody>
@@ -24690,7 +24595,7 @@
                 </a:solidFill>
                 <a:latin typeface="Calibri"/>
               </a:rPr>
-              <a:t>Four of those five fixes change the prompt or the schema, not the model. That ratio holds in production too.</a:t>
+              <a:t>Four of these five fixes change the prompt or the schema. Only one is about the model itself.</a:t>
             </a:r>
           </a:p>
         </p:txBody>
@@ -24928,7 +24833,7 @@
                 </a:solidFill>
                 <a:latin typeface="Georgia"/>
               </a:rPr>
-              <a:t>Concepts, asked the way an exam asks them</a:t>
+              <a:t>Practice questions: the concepts</a:t>
             </a:r>
           </a:p>
         </p:txBody>
@@ -25883,7 +25788,7 @@
                 </a:solidFill>
                 <a:latin typeface="Calibri"/>
               </a:rPr>
-              <a:t>Marks come from naming the mechanism, not from length.</a:t>
+              <a:t>Name the mechanism. Length does not earn marks.</a:t>
             </a:r>
           </a:p>
         </p:txBody>
@@ -26121,7 +26026,7 @@
                 </a:solidFill>
                 <a:latin typeface="Georgia"/>
               </a:rPr>
-              <a:t>Agents and the lab, applied to a live desk</a:t>
+              <a:t>Practice questions: agents and the lab</a:t>
             </a:r>
           </a:p>
         </p:txBody>

</xml_diff>

<commit_message>
deck v5 + one Module 1 project: Swiggy in Python, then Codex
Deck: replaces the two transformer slides with one end-to-end flow from
question to answer (tokenize, embed, transformer, predict, loop, stop) carrying
attention and what GPT stands for in a line each. Practice Part B drops to the
two case questions. Lab A now runs on Swiggy: price 280.75, revenue 22,828
crore, and an operating loss that widened from 2,601 to 4,414 crore across
three years.

Project: one folder, not three. swiggy_data.py is the ChatGPT step; codex_app is
the Codex step; the README explains what the second step actually bought, which
is a name-to-ticker lookup that turns a script for one company into a tool for
the market. The old lab bundle and the standalone app zip are removed.

Co-Authored-By: Claude Opus 5 <noreply@anthropic.com>
</commit_message>
<xml_diff>
--- a/slides/Module-01-Foundations-of-Agentic-AI.pptx
+++ b/slides/Module-01-Foundations-of-Agentic-AI.pptx
@@ -13,7 +13,6 @@
     <p:sldId id="262" r:id="rId9"/>
     <p:sldId id="329" r:id="rId79"/>
     <p:sldId id="334" r:id="rId84"/>
-    <p:sldId id="322" r:id="rId72"/>
     <p:sldId id="263" r:id="rId10"/>
     <p:sldId id="335" r:id="rId85"/>
     <p:sldId id="330" r:id="rId80"/>
@@ -4040,7 +4039,7 @@
                 </a:solidFill>
                 <a:latin typeface="Calibri"/>
               </a:rPr>
-              <a:t>MODULE 1  ·  13</a:t>
+              <a:t>MODULE 1  ·  12</a:t>
             </a:r>
           </a:p>
         </p:txBody>
@@ -5308,7 +5307,7 @@
                 </a:solidFill>
                 <a:latin typeface="Calibri"/>
               </a:rPr>
-              <a:t>MODULE 1  ·  14</a:t>
+              <a:t>MODULE 1  ·  13</a:t>
             </a:r>
           </a:p>
         </p:txBody>
@@ -6436,7 +6435,7 @@
                 </a:solidFill>
                 <a:latin typeface="Calibri"/>
               </a:rPr>
-              <a:t>MODULE 1  ·  16</a:t>
+              <a:t>MODULE 1  ·  15</a:t>
             </a:r>
           </a:p>
         </p:txBody>
@@ -12637,7 +12636,7 @@
                 </a:solidFill>
                 <a:latin typeface="Calibri"/>
               </a:rPr>
-              <a:t>MODULE 1  ·  09</a:t>
+              <a:t>MODULE 1  ·  06</a:t>
             </a:r>
           </a:p>
         </p:txBody>
@@ -14437,7 +14436,7 @@
                 </a:solidFill>
                 <a:latin typeface="Calibri"/>
               </a:rPr>
-              <a:t>MODULE 1  ·  15</a:t>
+              <a:t>MODULE 1  ·  14</a:t>
             </a:r>
           </a:p>
         </p:txBody>
@@ -15512,7 +15511,7 @@
                 </a:solidFill>
                 <a:latin typeface="Calibri"/>
               </a:rPr>
-              <a:t>MODULE 1  ·  17</a:t>
+              <a:t>MODULE 1  ·  16</a:t>
             </a:r>
           </a:p>
         </p:txBody>
@@ -17073,7 +17072,7 @@
                 </a:solidFill>
                 <a:latin typeface="Calibri"/>
               </a:rPr>
-              <a:t>MODULE 1  ·  21</a:t>
+              <a:t>MODULE 1  ·  20</a:t>
             </a:r>
           </a:p>
         </p:txBody>
@@ -18108,7 +18107,7 @@
                 </a:solidFill>
                 <a:latin typeface="Calibri"/>
               </a:rPr>
-              <a:t>MODULE 1  ·  20</a:t>
+              <a:t>MODULE 1  ·  19</a:t>
             </a:r>
           </a:p>
         </p:txBody>
@@ -19713,7 +19712,7 @@
                 </a:solidFill>
                 <a:latin typeface="Calibri"/>
               </a:rPr>
-              <a:t>MODULE 1  ·  24</a:t>
+              <a:t>MODULE 1  ·  23</a:t>
             </a:r>
           </a:p>
         </p:txBody>
@@ -21151,7 +21150,7 @@
                 </a:solidFill>
                 <a:latin typeface="Georgia"/>
               </a:rPr>
-              <a:t>What a transformer is</a:t>
+              <a:t>How an LLM works, end to end: “What is the capital of France?”</a:t>
             </a:r>
           </a:p>
         </p:txBody>
@@ -21164,8 +21163,8 @@
         </p:nvSpPr>
         <p:spPr>
           <a:xfrm>
-            <a:off x="548640" y="1572768"/>
-            <a:ext cx="11091672" cy="1051560"/>
+            <a:off x="548640" y="1600200"/>
+            <a:ext cx="2670048" cy="1417320"/>
           </a:xfrm>
           <a:prstGeom prst="rect">
             <a:avLst/>
@@ -21208,8 +21207,581 @@
         </p:nvSpPr>
         <p:spPr>
           <a:xfrm>
-            <a:off x="548640" y="1572768"/>
-            <a:ext cx="64008" cy="1051560"/>
+            <a:off x="548640" y="1600200"/>
+            <a:ext cx="2670048" cy="45720"/>
+          </a:xfrm>
+          <a:prstGeom prst="rect">
+            <a:avLst/>
+          </a:prstGeom>
+          <a:solidFill>
+            <a:srgbClr val="3A5C9E"/>
+          </a:solidFill>
+          <a:ln>
+            <a:noFill/>
+          </a:ln>
+          <a:effectLst/>
+        </p:spPr>
+        <p:style>
+          <a:lnRef idx="1">
+            <a:schemeClr val="accent1"/>
+          </a:lnRef>
+          <a:fillRef idx="3">
+            <a:schemeClr val="accent1"/>
+          </a:fillRef>
+          <a:effectRef idx="2">
+            <a:schemeClr val="accent1"/>
+          </a:effectRef>
+          <a:fontRef idx="minor">
+            <a:schemeClr val="lt1"/>
+          </a:fontRef>
+        </p:style>
+        <p:txBody>
+          <a:bodyPr rtlCol="0" anchor="ctr"/>
+          <a:lstStyle/>
+          <a:p>
+            <a:pPr algn="ctr"/>
+          </a:p>
+        </p:txBody>
+      </p:sp>
+      <p:sp>
+        <p:nvSpPr>
+          <p:cNvPr id="7" name="TextBox 6"/>
+          <p:cNvSpPr txBox="1"/>
+          <p:nvPr/>
+        </p:nvSpPr>
+        <p:spPr>
+          <a:xfrm>
+            <a:off x="749808" y="1764792"/>
+            <a:ext cx="2286000" cy="1188720"/>
+          </a:xfrm>
+          <a:prstGeom prst="rect">
+            <a:avLst/>
+          </a:prstGeom>
+          <a:noFill/>
+        </p:spPr>
+        <p:txBody>
+          <a:bodyPr wrap="square" lIns="0" rIns="0" tIns="0" bIns="0" anchor="t">
+            <a:spAutoFit/>
+          </a:bodyPr>
+          <a:lstStyle/>
+          <a:p>
+            <a:pPr algn="l">
+              <a:lnSpc>
+                <a:spcPct val="105000"/>
+              </a:lnSpc>
+              <a:spcBef>
+                <a:spcPts val="0"/>
+              </a:spcBef>
+            </a:pPr>
+            <a:r>
+              <a:rPr sz="1100" b="1">
+                <a:solidFill>
+                  <a:srgbClr val="0F2145"/>
+                </a:solidFill>
+                <a:latin typeface="Calibri"/>
+              </a:rPr>
+              <a:t>1 · YOUR QUESTION</a:t>
+            </a:r>
+          </a:p>
+          <a:p>
+            <a:pPr algn="l">
+              <a:lnSpc>
+                <a:spcPct val="105000"/>
+              </a:lnSpc>
+              <a:spcBef>
+                <a:spcPts val="400"/>
+              </a:spcBef>
+            </a:pPr>
+            <a:r>
+              <a:rPr sz="1000" b="0">
+                <a:solidFill>
+                  <a:srgbClr val="5D6B7E"/>
+                </a:solidFill>
+                <a:latin typeface="Calibri"/>
+              </a:rPr>
+              <a:t>What is the capital of France?</a:t>
+            </a:r>
+          </a:p>
+        </p:txBody>
+      </p:sp>
+      <p:sp>
+        <p:nvSpPr>
+          <p:cNvPr id="8" name="TextBox 7"/>
+          <p:cNvSpPr txBox="1"/>
+          <p:nvPr/>
+        </p:nvSpPr>
+        <p:spPr>
+          <a:xfrm>
+            <a:off x="3236976" y="2103120"/>
+            <a:ext cx="182880" cy="365760"/>
+          </a:xfrm>
+          <a:prstGeom prst="rect">
+            <a:avLst/>
+          </a:prstGeom>
+          <a:noFill/>
+        </p:spPr>
+        <p:txBody>
+          <a:bodyPr wrap="square" lIns="0" rIns="0" tIns="0" bIns="0" anchor="t">
+            <a:spAutoFit/>
+          </a:bodyPr>
+          <a:lstStyle/>
+          <a:p>
+            <a:pPr algn="l">
+              <a:lnSpc>
+                <a:spcPct val="105000"/>
+              </a:lnSpc>
+              <a:spcBef>
+                <a:spcPts val="0"/>
+              </a:spcBef>
+            </a:pPr>
+            <a:r>
+              <a:rPr sz="1800" b="1">
+                <a:solidFill>
+                  <a:srgbClr val="C9A227"/>
+                </a:solidFill>
+                <a:latin typeface="Georgia"/>
+              </a:rPr>
+              <a:t>›</a:t>
+            </a:r>
+          </a:p>
+        </p:txBody>
+      </p:sp>
+      <p:sp>
+        <p:nvSpPr>
+          <p:cNvPr id="9" name="Rectangle 8"/>
+          <p:cNvSpPr/>
+          <p:nvPr/>
+        </p:nvSpPr>
+        <p:spPr>
+          <a:xfrm>
+            <a:off x="3374136" y="1600200"/>
+            <a:ext cx="2670048" cy="1417320"/>
+          </a:xfrm>
+          <a:prstGeom prst="rect">
+            <a:avLst/>
+          </a:prstGeom>
+          <a:solidFill>
+            <a:srgbClr val="FFFFFF"/>
+          </a:solidFill>
+          <a:ln>
+            <a:noFill/>
+          </a:ln>
+          <a:effectLst/>
+        </p:spPr>
+        <p:style>
+          <a:lnRef idx="1">
+            <a:schemeClr val="accent1"/>
+          </a:lnRef>
+          <a:fillRef idx="3">
+            <a:schemeClr val="accent1"/>
+          </a:fillRef>
+          <a:effectRef idx="2">
+            <a:schemeClr val="accent1"/>
+          </a:effectRef>
+          <a:fontRef idx="minor">
+            <a:schemeClr val="lt1"/>
+          </a:fontRef>
+        </p:style>
+        <p:txBody>
+          <a:bodyPr rtlCol="0" anchor="ctr"/>
+          <a:lstStyle/>
+          <a:p>
+            <a:pPr algn="ctr"/>
+          </a:p>
+        </p:txBody>
+      </p:sp>
+      <p:sp>
+        <p:nvSpPr>
+          <p:cNvPr id="10" name="Rectangle 9"/>
+          <p:cNvSpPr/>
+          <p:nvPr/>
+        </p:nvSpPr>
+        <p:spPr>
+          <a:xfrm>
+            <a:off x="3374136" y="1600200"/>
+            <a:ext cx="2670048" cy="45720"/>
+          </a:xfrm>
+          <a:prstGeom prst="rect">
+            <a:avLst/>
+          </a:prstGeom>
+          <a:solidFill>
+            <a:srgbClr val="3A5C9E"/>
+          </a:solidFill>
+          <a:ln>
+            <a:noFill/>
+          </a:ln>
+          <a:effectLst/>
+        </p:spPr>
+        <p:style>
+          <a:lnRef idx="1">
+            <a:schemeClr val="accent1"/>
+          </a:lnRef>
+          <a:fillRef idx="3">
+            <a:schemeClr val="accent1"/>
+          </a:fillRef>
+          <a:effectRef idx="2">
+            <a:schemeClr val="accent1"/>
+          </a:effectRef>
+          <a:fontRef idx="minor">
+            <a:schemeClr val="lt1"/>
+          </a:fontRef>
+        </p:style>
+        <p:txBody>
+          <a:bodyPr rtlCol="0" anchor="ctr"/>
+          <a:lstStyle/>
+          <a:p>
+            <a:pPr algn="ctr"/>
+          </a:p>
+        </p:txBody>
+      </p:sp>
+      <p:sp>
+        <p:nvSpPr>
+          <p:cNvPr id="11" name="TextBox 10"/>
+          <p:cNvSpPr txBox="1"/>
+          <p:nvPr/>
+        </p:nvSpPr>
+        <p:spPr>
+          <a:xfrm>
+            <a:off x="3575304" y="1764792"/>
+            <a:ext cx="2286000" cy="1188720"/>
+          </a:xfrm>
+          <a:prstGeom prst="rect">
+            <a:avLst/>
+          </a:prstGeom>
+          <a:noFill/>
+        </p:spPr>
+        <p:txBody>
+          <a:bodyPr wrap="square" lIns="0" rIns="0" tIns="0" bIns="0" anchor="t">
+            <a:spAutoFit/>
+          </a:bodyPr>
+          <a:lstStyle/>
+          <a:p>
+            <a:pPr algn="l">
+              <a:lnSpc>
+                <a:spcPct val="105000"/>
+              </a:lnSpc>
+              <a:spcBef>
+                <a:spcPts val="0"/>
+              </a:spcBef>
+            </a:pPr>
+            <a:r>
+              <a:rPr sz="1100" b="1">
+                <a:solidFill>
+                  <a:srgbClr val="0F2145"/>
+                </a:solidFill>
+                <a:latin typeface="Calibri"/>
+              </a:rPr>
+              <a:t>2 · TOKENIZE</a:t>
+            </a:r>
+          </a:p>
+          <a:p>
+            <a:pPr algn="l">
+              <a:lnSpc>
+                <a:spcPct val="105000"/>
+              </a:lnSpc>
+              <a:spcBef>
+                <a:spcPts val="400"/>
+              </a:spcBef>
+            </a:pPr>
+            <a:r>
+              <a:rPr sz="1000" b="0">
+                <a:solidFill>
+                  <a:srgbClr val="5D6B7E"/>
+                </a:solidFill>
+                <a:latin typeface="Calibri"/>
+              </a:rPr>
+              <a:t>Split into pieces: What | is | the | capital | of | France | ?</a:t>
+            </a:r>
+          </a:p>
+        </p:txBody>
+      </p:sp>
+      <p:sp>
+        <p:nvSpPr>
+          <p:cNvPr id="12" name="TextBox 11"/>
+          <p:cNvSpPr txBox="1"/>
+          <p:nvPr/>
+        </p:nvSpPr>
+        <p:spPr>
+          <a:xfrm>
+            <a:off x="6062472" y="2103120"/>
+            <a:ext cx="182880" cy="365760"/>
+          </a:xfrm>
+          <a:prstGeom prst="rect">
+            <a:avLst/>
+          </a:prstGeom>
+          <a:noFill/>
+        </p:spPr>
+        <p:txBody>
+          <a:bodyPr wrap="square" lIns="0" rIns="0" tIns="0" bIns="0" anchor="t">
+            <a:spAutoFit/>
+          </a:bodyPr>
+          <a:lstStyle/>
+          <a:p>
+            <a:pPr algn="l">
+              <a:lnSpc>
+                <a:spcPct val="105000"/>
+              </a:lnSpc>
+              <a:spcBef>
+                <a:spcPts val="0"/>
+              </a:spcBef>
+            </a:pPr>
+            <a:r>
+              <a:rPr sz="1800" b="1">
+                <a:solidFill>
+                  <a:srgbClr val="C9A227"/>
+                </a:solidFill>
+                <a:latin typeface="Georgia"/>
+              </a:rPr>
+              <a:t>›</a:t>
+            </a:r>
+          </a:p>
+        </p:txBody>
+      </p:sp>
+      <p:sp>
+        <p:nvSpPr>
+          <p:cNvPr id="13" name="Rectangle 12"/>
+          <p:cNvSpPr/>
+          <p:nvPr/>
+        </p:nvSpPr>
+        <p:spPr>
+          <a:xfrm>
+            <a:off x="6199631" y="1600200"/>
+            <a:ext cx="2670048" cy="1417320"/>
+          </a:xfrm>
+          <a:prstGeom prst="rect">
+            <a:avLst/>
+          </a:prstGeom>
+          <a:solidFill>
+            <a:srgbClr val="FFFFFF"/>
+          </a:solidFill>
+          <a:ln>
+            <a:noFill/>
+          </a:ln>
+          <a:effectLst/>
+        </p:spPr>
+        <p:style>
+          <a:lnRef idx="1">
+            <a:schemeClr val="accent1"/>
+          </a:lnRef>
+          <a:fillRef idx="3">
+            <a:schemeClr val="accent1"/>
+          </a:fillRef>
+          <a:effectRef idx="2">
+            <a:schemeClr val="accent1"/>
+          </a:effectRef>
+          <a:fontRef idx="minor">
+            <a:schemeClr val="lt1"/>
+          </a:fontRef>
+        </p:style>
+        <p:txBody>
+          <a:bodyPr rtlCol="0" anchor="ctr"/>
+          <a:lstStyle/>
+          <a:p>
+            <a:pPr algn="ctr"/>
+          </a:p>
+        </p:txBody>
+      </p:sp>
+      <p:sp>
+        <p:nvSpPr>
+          <p:cNvPr id="14" name="Rectangle 13"/>
+          <p:cNvSpPr/>
+          <p:nvPr/>
+        </p:nvSpPr>
+        <p:spPr>
+          <a:xfrm>
+            <a:off x="6199631" y="1600200"/>
+            <a:ext cx="2670048" cy="45720"/>
+          </a:xfrm>
+          <a:prstGeom prst="rect">
+            <a:avLst/>
+          </a:prstGeom>
+          <a:solidFill>
+            <a:srgbClr val="3A5C9E"/>
+          </a:solidFill>
+          <a:ln>
+            <a:noFill/>
+          </a:ln>
+          <a:effectLst/>
+        </p:spPr>
+        <p:style>
+          <a:lnRef idx="1">
+            <a:schemeClr val="accent1"/>
+          </a:lnRef>
+          <a:fillRef idx="3">
+            <a:schemeClr val="accent1"/>
+          </a:fillRef>
+          <a:effectRef idx="2">
+            <a:schemeClr val="accent1"/>
+          </a:effectRef>
+          <a:fontRef idx="minor">
+            <a:schemeClr val="lt1"/>
+          </a:fontRef>
+        </p:style>
+        <p:txBody>
+          <a:bodyPr rtlCol="0" anchor="ctr"/>
+          <a:lstStyle/>
+          <a:p>
+            <a:pPr algn="ctr"/>
+          </a:p>
+        </p:txBody>
+      </p:sp>
+      <p:sp>
+        <p:nvSpPr>
+          <p:cNvPr id="15" name="TextBox 14"/>
+          <p:cNvSpPr txBox="1"/>
+          <p:nvPr/>
+        </p:nvSpPr>
+        <p:spPr>
+          <a:xfrm>
+            <a:off x="6400799" y="1764792"/>
+            <a:ext cx="2286000" cy="1188720"/>
+          </a:xfrm>
+          <a:prstGeom prst="rect">
+            <a:avLst/>
+          </a:prstGeom>
+          <a:noFill/>
+        </p:spPr>
+        <p:txBody>
+          <a:bodyPr wrap="square" lIns="0" rIns="0" tIns="0" bIns="0" anchor="t">
+            <a:spAutoFit/>
+          </a:bodyPr>
+          <a:lstStyle/>
+          <a:p>
+            <a:pPr algn="l">
+              <a:lnSpc>
+                <a:spcPct val="105000"/>
+              </a:lnSpc>
+              <a:spcBef>
+                <a:spcPts val="0"/>
+              </a:spcBef>
+            </a:pPr>
+            <a:r>
+              <a:rPr sz="1100" b="1">
+                <a:solidFill>
+                  <a:srgbClr val="0F2145"/>
+                </a:solidFill>
+                <a:latin typeface="Calibri"/>
+              </a:rPr>
+              <a:t>3 · EMBED</a:t>
+            </a:r>
+          </a:p>
+          <a:p>
+            <a:pPr algn="l">
+              <a:lnSpc>
+                <a:spcPct val="105000"/>
+              </a:lnSpc>
+              <a:spcBef>
+                <a:spcPts val="400"/>
+              </a:spcBef>
+            </a:pPr>
+            <a:r>
+              <a:rPr sz="1000" b="0">
+                <a:solidFill>
+                  <a:srgbClr val="5D6B7E"/>
+                </a:solidFill>
+                <a:latin typeface="Calibri"/>
+              </a:rPr>
+              <a:t>Each token becomes a long list of numbers, learned in training.</a:t>
+            </a:r>
+          </a:p>
+        </p:txBody>
+      </p:sp>
+      <p:sp>
+        <p:nvSpPr>
+          <p:cNvPr id="16" name="TextBox 15"/>
+          <p:cNvSpPr txBox="1"/>
+          <p:nvPr/>
+        </p:nvSpPr>
+        <p:spPr>
+          <a:xfrm>
+            <a:off x="8887967" y="2103120"/>
+            <a:ext cx="182880" cy="365760"/>
+          </a:xfrm>
+          <a:prstGeom prst="rect">
+            <a:avLst/>
+          </a:prstGeom>
+          <a:noFill/>
+        </p:spPr>
+        <p:txBody>
+          <a:bodyPr wrap="square" lIns="0" rIns="0" tIns="0" bIns="0" anchor="t">
+            <a:spAutoFit/>
+          </a:bodyPr>
+          <a:lstStyle/>
+          <a:p>
+            <a:pPr algn="l">
+              <a:lnSpc>
+                <a:spcPct val="105000"/>
+              </a:lnSpc>
+              <a:spcBef>
+                <a:spcPts val="0"/>
+              </a:spcBef>
+            </a:pPr>
+            <a:r>
+              <a:rPr sz="1800" b="1">
+                <a:solidFill>
+                  <a:srgbClr val="C9A227"/>
+                </a:solidFill>
+                <a:latin typeface="Georgia"/>
+              </a:rPr>
+              <a:t>›</a:t>
+            </a:r>
+          </a:p>
+        </p:txBody>
+      </p:sp>
+      <p:sp>
+        <p:nvSpPr>
+          <p:cNvPr id="17" name="Rectangle 16"/>
+          <p:cNvSpPr/>
+          <p:nvPr/>
+        </p:nvSpPr>
+        <p:spPr>
+          <a:xfrm>
+            <a:off x="9025128" y="1600200"/>
+            <a:ext cx="2670048" cy="1417320"/>
+          </a:xfrm>
+          <a:prstGeom prst="rect">
+            <a:avLst/>
+          </a:prstGeom>
+          <a:solidFill>
+            <a:srgbClr val="0F2145"/>
+          </a:solidFill>
+          <a:ln>
+            <a:noFill/>
+          </a:ln>
+          <a:effectLst/>
+        </p:spPr>
+        <p:style>
+          <a:lnRef idx="1">
+            <a:schemeClr val="accent1"/>
+          </a:lnRef>
+          <a:fillRef idx="3">
+            <a:schemeClr val="accent1"/>
+          </a:fillRef>
+          <a:effectRef idx="2">
+            <a:schemeClr val="accent1"/>
+          </a:effectRef>
+          <a:fontRef idx="minor">
+            <a:schemeClr val="lt1"/>
+          </a:fontRef>
+        </p:style>
+        <p:txBody>
+          <a:bodyPr rtlCol="0" anchor="ctr"/>
+          <a:lstStyle/>
+          <a:p>
+            <a:pPr algn="ctr"/>
+          </a:p>
+        </p:txBody>
+      </p:sp>
+      <p:sp>
+        <p:nvSpPr>
+          <p:cNvPr id="18" name="Rectangle 17"/>
+          <p:cNvSpPr/>
+          <p:nvPr/>
+        </p:nvSpPr>
+        <p:spPr>
+          <a:xfrm>
+            <a:off x="9025128" y="1600200"/>
+            <a:ext cx="2670048" cy="45720"/>
           </a:xfrm>
           <a:prstGeom prst="rect">
             <a:avLst/>
@@ -21246,14 +21818,14 @@
       </p:sp>
       <p:sp>
         <p:nvSpPr>
-          <p:cNvPr id="7" name="TextBox 6"/>
-          <p:cNvSpPr txBox="1"/>
-          <p:nvPr/>
-        </p:nvSpPr>
-        <p:spPr>
-          <a:xfrm>
-            <a:off x="822960" y="1737360"/>
-            <a:ext cx="10515600" cy="868680"/>
+          <p:cNvPr id="19" name="TextBox 18"/>
+          <p:cNvSpPr txBox="1"/>
+          <p:nvPr/>
+        </p:nvSpPr>
+        <p:spPr>
+          <a:xfrm>
+            <a:off x="9226296" y="1764792"/>
+            <a:ext cx="2286000" cy="1188720"/>
           </a:xfrm>
           <a:prstGeom prst="rect">
             <a:avLst/>
@@ -21275,46 +21847,810 @@
               </a:spcBef>
             </a:pPr>
             <a:r>
-              <a:rPr sz="1000" b="1">
-                <a:solidFill>
-                  <a:srgbClr val="3A5C9E"/>
-                </a:solidFill>
-                <a:latin typeface="Calibri"/>
-              </a:rPr>
-              <a:t>In one sentence</a:t>
-            </a:r>
-          </a:p>
-          <a:p>
-            <a:pPr algn="l">
-              <a:lnSpc>
-                <a:spcPct val="105000"/>
-              </a:lnSpc>
-              <a:spcBef>
-                <a:spcPts val="500"/>
-              </a:spcBef>
-            </a:pPr>
-            <a:r>
-              <a:rPr sz="1150" b="0">
-                <a:solidFill>
-                  <a:srgbClr val="1B2A41"/>
-                </a:solidFill>
-                <a:latin typeface="Calibri"/>
-              </a:rPr>
-              <a:t>A transformer is the design of the neural network inside every model you will use. It reads a whole passage at once instead of word by word, and for each word it works out which other words matter. Google researchers published it in 2017. Every model on the previous slide is built on it.</a:t>
-            </a:r>
-          </a:p>
-        </p:txBody>
-      </p:sp>
-      <p:sp>
-        <p:nvSpPr>
-          <p:cNvPr id="8" name="Rectangle 7"/>
+              <a:rPr sz="1100" b="1">
+                <a:solidFill>
+                  <a:srgbClr val="C9A227"/>
+                </a:solidFill>
+                <a:latin typeface="Calibri"/>
+              </a:rPr>
+              <a:t>4 · TRANSFORMER</a:t>
+            </a:r>
+          </a:p>
+          <a:p>
+            <a:pPr algn="l">
+              <a:lnSpc>
+                <a:spcPct val="105000"/>
+              </a:lnSpc>
+              <a:spcBef>
+                <a:spcPts val="400"/>
+              </a:spcBef>
+            </a:pPr>
+            <a:r>
+              <a:rPr sz="1000" b="0">
+                <a:solidFill>
+                  <a:srgbClr val="C9D6EE"/>
+                </a:solidFill>
+                <a:latin typeface="Calibri"/>
+              </a:rPr>
+              <a:t>Attention weighs which tokens matter to which. Many layers, one after another.</a:t>
+            </a:r>
+          </a:p>
+        </p:txBody>
+      </p:sp>
+      <p:sp>
+        <p:nvSpPr>
+          <p:cNvPr id="20" name="Rectangle 19"/>
           <p:cNvSpPr/>
           <p:nvPr/>
         </p:nvSpPr>
         <p:spPr>
           <a:xfrm>
-            <a:off x="548640" y="2743200"/>
-            <a:ext cx="6766560" cy="1005840"/>
+            <a:off x="548640" y="3200400"/>
+            <a:ext cx="2670048" cy="1417320"/>
+          </a:xfrm>
+          <a:prstGeom prst="rect">
+            <a:avLst/>
+          </a:prstGeom>
+          <a:solidFill>
+            <a:srgbClr val="0F2145"/>
+          </a:solidFill>
+          <a:ln>
+            <a:noFill/>
+          </a:ln>
+          <a:effectLst/>
+        </p:spPr>
+        <p:style>
+          <a:lnRef idx="1">
+            <a:schemeClr val="accent1"/>
+          </a:lnRef>
+          <a:fillRef idx="3">
+            <a:schemeClr val="accent1"/>
+          </a:fillRef>
+          <a:effectRef idx="2">
+            <a:schemeClr val="accent1"/>
+          </a:effectRef>
+          <a:fontRef idx="minor">
+            <a:schemeClr val="lt1"/>
+          </a:fontRef>
+        </p:style>
+        <p:txBody>
+          <a:bodyPr rtlCol="0" anchor="ctr"/>
+          <a:lstStyle/>
+          <a:p>
+            <a:pPr algn="ctr"/>
+          </a:p>
+        </p:txBody>
+      </p:sp>
+      <p:sp>
+        <p:nvSpPr>
+          <p:cNvPr id="21" name="Rectangle 20"/>
+          <p:cNvSpPr/>
+          <p:nvPr/>
+        </p:nvSpPr>
+        <p:spPr>
+          <a:xfrm>
+            <a:off x="548640" y="3200400"/>
+            <a:ext cx="2670048" cy="45720"/>
+          </a:xfrm>
+          <a:prstGeom prst="rect">
+            <a:avLst/>
+          </a:prstGeom>
+          <a:solidFill>
+            <a:srgbClr val="C9A227"/>
+          </a:solidFill>
+          <a:ln>
+            <a:noFill/>
+          </a:ln>
+          <a:effectLst/>
+        </p:spPr>
+        <p:style>
+          <a:lnRef idx="1">
+            <a:schemeClr val="accent1"/>
+          </a:lnRef>
+          <a:fillRef idx="3">
+            <a:schemeClr val="accent1"/>
+          </a:fillRef>
+          <a:effectRef idx="2">
+            <a:schemeClr val="accent1"/>
+          </a:effectRef>
+          <a:fontRef idx="minor">
+            <a:schemeClr val="lt1"/>
+          </a:fontRef>
+        </p:style>
+        <p:txBody>
+          <a:bodyPr rtlCol="0" anchor="ctr"/>
+          <a:lstStyle/>
+          <a:p>
+            <a:pPr algn="ctr"/>
+          </a:p>
+        </p:txBody>
+      </p:sp>
+      <p:sp>
+        <p:nvSpPr>
+          <p:cNvPr id="22" name="TextBox 21"/>
+          <p:cNvSpPr txBox="1"/>
+          <p:nvPr/>
+        </p:nvSpPr>
+        <p:spPr>
+          <a:xfrm>
+            <a:off x="749808" y="3364992"/>
+            <a:ext cx="2286000" cy="1188720"/>
+          </a:xfrm>
+          <a:prstGeom prst="rect">
+            <a:avLst/>
+          </a:prstGeom>
+          <a:noFill/>
+        </p:spPr>
+        <p:txBody>
+          <a:bodyPr wrap="square" lIns="0" rIns="0" tIns="0" bIns="0" anchor="t">
+            <a:spAutoFit/>
+          </a:bodyPr>
+          <a:lstStyle/>
+          <a:p>
+            <a:pPr algn="l">
+              <a:lnSpc>
+                <a:spcPct val="105000"/>
+              </a:lnSpc>
+              <a:spcBef>
+                <a:spcPts val="0"/>
+              </a:spcBef>
+            </a:pPr>
+            <a:r>
+              <a:rPr sz="1100" b="1">
+                <a:solidFill>
+                  <a:srgbClr val="C9A227"/>
+                </a:solidFill>
+                <a:latin typeface="Calibri"/>
+              </a:rPr>
+              <a:t>5 · PREDICT</a:t>
+            </a:r>
+          </a:p>
+          <a:p>
+            <a:pPr algn="l">
+              <a:lnSpc>
+                <a:spcPct val="105000"/>
+              </a:lnSpc>
+              <a:spcBef>
+                <a:spcPts val="400"/>
+              </a:spcBef>
+            </a:pPr>
+            <a:r>
+              <a:rPr sz="1000" b="0">
+                <a:solidFill>
+                  <a:srgbClr val="C9D6EE"/>
+                </a:solidFill>
+                <a:latin typeface="Calibri"/>
+              </a:rPr>
+              <a:t>Paris 99.7% · London 0.2% · Berlin 0.05% · Rome 0.03%</a:t>
+            </a:r>
+          </a:p>
+        </p:txBody>
+      </p:sp>
+      <p:sp>
+        <p:nvSpPr>
+          <p:cNvPr id="23" name="TextBox 22"/>
+          <p:cNvSpPr txBox="1"/>
+          <p:nvPr/>
+        </p:nvSpPr>
+        <p:spPr>
+          <a:xfrm>
+            <a:off x="3236976" y="3703320"/>
+            <a:ext cx="182880" cy="365760"/>
+          </a:xfrm>
+          <a:prstGeom prst="rect">
+            <a:avLst/>
+          </a:prstGeom>
+          <a:noFill/>
+        </p:spPr>
+        <p:txBody>
+          <a:bodyPr wrap="square" lIns="0" rIns="0" tIns="0" bIns="0" anchor="t">
+            <a:spAutoFit/>
+          </a:bodyPr>
+          <a:lstStyle/>
+          <a:p>
+            <a:pPr algn="l">
+              <a:lnSpc>
+                <a:spcPct val="105000"/>
+              </a:lnSpc>
+              <a:spcBef>
+                <a:spcPts val="0"/>
+              </a:spcBef>
+            </a:pPr>
+            <a:r>
+              <a:rPr sz="1800" b="1">
+                <a:solidFill>
+                  <a:srgbClr val="C9A227"/>
+                </a:solidFill>
+                <a:latin typeface="Georgia"/>
+              </a:rPr>
+              <a:t>›</a:t>
+            </a:r>
+          </a:p>
+        </p:txBody>
+      </p:sp>
+      <p:sp>
+        <p:nvSpPr>
+          <p:cNvPr id="24" name="Rectangle 23"/>
+          <p:cNvSpPr/>
+          <p:nvPr/>
+        </p:nvSpPr>
+        <p:spPr>
+          <a:xfrm>
+            <a:off x="3374136" y="3200400"/>
+            <a:ext cx="2670048" cy="1417320"/>
+          </a:xfrm>
+          <a:prstGeom prst="rect">
+            <a:avLst/>
+          </a:prstGeom>
+          <a:solidFill>
+            <a:srgbClr val="FFFFFF"/>
+          </a:solidFill>
+          <a:ln>
+            <a:noFill/>
+          </a:ln>
+          <a:effectLst/>
+        </p:spPr>
+        <p:style>
+          <a:lnRef idx="1">
+            <a:schemeClr val="accent1"/>
+          </a:lnRef>
+          <a:fillRef idx="3">
+            <a:schemeClr val="accent1"/>
+          </a:fillRef>
+          <a:effectRef idx="2">
+            <a:schemeClr val="accent1"/>
+          </a:effectRef>
+          <a:fontRef idx="minor">
+            <a:schemeClr val="lt1"/>
+          </a:fontRef>
+        </p:style>
+        <p:txBody>
+          <a:bodyPr rtlCol="0" anchor="ctr"/>
+          <a:lstStyle/>
+          <a:p>
+            <a:pPr algn="ctr"/>
+          </a:p>
+        </p:txBody>
+      </p:sp>
+      <p:sp>
+        <p:nvSpPr>
+          <p:cNvPr id="25" name="Rectangle 24"/>
+          <p:cNvSpPr/>
+          <p:nvPr/>
+        </p:nvSpPr>
+        <p:spPr>
+          <a:xfrm>
+            <a:off x="3374136" y="3200400"/>
+            <a:ext cx="2670048" cy="45720"/>
+          </a:xfrm>
+          <a:prstGeom prst="rect">
+            <a:avLst/>
+          </a:prstGeom>
+          <a:solidFill>
+            <a:srgbClr val="3A5C9E"/>
+          </a:solidFill>
+          <a:ln>
+            <a:noFill/>
+          </a:ln>
+          <a:effectLst/>
+        </p:spPr>
+        <p:style>
+          <a:lnRef idx="1">
+            <a:schemeClr val="accent1"/>
+          </a:lnRef>
+          <a:fillRef idx="3">
+            <a:schemeClr val="accent1"/>
+          </a:fillRef>
+          <a:effectRef idx="2">
+            <a:schemeClr val="accent1"/>
+          </a:effectRef>
+          <a:fontRef idx="minor">
+            <a:schemeClr val="lt1"/>
+          </a:fontRef>
+        </p:style>
+        <p:txBody>
+          <a:bodyPr rtlCol="0" anchor="ctr"/>
+          <a:lstStyle/>
+          <a:p>
+            <a:pPr algn="ctr"/>
+          </a:p>
+        </p:txBody>
+      </p:sp>
+      <p:sp>
+        <p:nvSpPr>
+          <p:cNvPr id="26" name="TextBox 25"/>
+          <p:cNvSpPr txBox="1"/>
+          <p:nvPr/>
+        </p:nvSpPr>
+        <p:spPr>
+          <a:xfrm>
+            <a:off x="3575304" y="3364992"/>
+            <a:ext cx="2286000" cy="1188720"/>
+          </a:xfrm>
+          <a:prstGeom prst="rect">
+            <a:avLst/>
+          </a:prstGeom>
+          <a:noFill/>
+        </p:spPr>
+        <p:txBody>
+          <a:bodyPr wrap="square" lIns="0" rIns="0" tIns="0" bIns="0" anchor="t">
+            <a:spAutoFit/>
+          </a:bodyPr>
+          <a:lstStyle/>
+          <a:p>
+            <a:pPr algn="l">
+              <a:lnSpc>
+                <a:spcPct val="105000"/>
+              </a:lnSpc>
+              <a:spcBef>
+                <a:spcPts val="0"/>
+              </a:spcBef>
+            </a:pPr>
+            <a:r>
+              <a:rPr sz="1100" b="1">
+                <a:solidFill>
+                  <a:srgbClr val="0F2145"/>
+                </a:solidFill>
+                <a:latin typeface="Calibri"/>
+              </a:rPr>
+              <a:t>6 · PICK AND ADD</a:t>
+            </a:r>
+          </a:p>
+          <a:p>
+            <a:pPr algn="l">
+              <a:lnSpc>
+                <a:spcPct val="105000"/>
+              </a:lnSpc>
+              <a:spcBef>
+                <a:spcPts val="400"/>
+              </a:spcBef>
+            </a:pPr>
+            <a:r>
+              <a:rPr sz="1000" b="0">
+                <a:solidFill>
+                  <a:srgbClr val="5D6B7E"/>
+                </a:solidFill>
+                <a:latin typeface="Calibri"/>
+              </a:rPr>
+              <a:t>The top token joins the answer.  Output so far: Paris</a:t>
+            </a:r>
+          </a:p>
+        </p:txBody>
+      </p:sp>
+      <p:sp>
+        <p:nvSpPr>
+          <p:cNvPr id="27" name="TextBox 26"/>
+          <p:cNvSpPr txBox="1"/>
+          <p:nvPr/>
+        </p:nvSpPr>
+        <p:spPr>
+          <a:xfrm>
+            <a:off x="6062472" y="3703320"/>
+            <a:ext cx="182880" cy="365760"/>
+          </a:xfrm>
+          <a:prstGeom prst="rect">
+            <a:avLst/>
+          </a:prstGeom>
+          <a:noFill/>
+        </p:spPr>
+        <p:txBody>
+          <a:bodyPr wrap="square" lIns="0" rIns="0" tIns="0" bIns="0" anchor="t">
+            <a:spAutoFit/>
+          </a:bodyPr>
+          <a:lstStyle/>
+          <a:p>
+            <a:pPr algn="l">
+              <a:lnSpc>
+                <a:spcPct val="105000"/>
+              </a:lnSpc>
+              <a:spcBef>
+                <a:spcPts val="0"/>
+              </a:spcBef>
+            </a:pPr>
+            <a:r>
+              <a:rPr sz="1800" b="1">
+                <a:solidFill>
+                  <a:srgbClr val="C9A227"/>
+                </a:solidFill>
+                <a:latin typeface="Georgia"/>
+              </a:rPr>
+              <a:t>›</a:t>
+            </a:r>
+          </a:p>
+        </p:txBody>
+      </p:sp>
+      <p:sp>
+        <p:nvSpPr>
+          <p:cNvPr id="28" name="Rectangle 27"/>
+          <p:cNvSpPr/>
+          <p:nvPr/>
+        </p:nvSpPr>
+        <p:spPr>
+          <a:xfrm>
+            <a:off x="6199631" y="3200400"/>
+            <a:ext cx="2670048" cy="1417320"/>
+          </a:xfrm>
+          <a:prstGeom prst="rect">
+            <a:avLst/>
+          </a:prstGeom>
+          <a:solidFill>
+            <a:srgbClr val="FFFFFF"/>
+          </a:solidFill>
+          <a:ln>
+            <a:noFill/>
+          </a:ln>
+          <a:effectLst/>
+        </p:spPr>
+        <p:style>
+          <a:lnRef idx="1">
+            <a:schemeClr val="accent1"/>
+          </a:lnRef>
+          <a:fillRef idx="3">
+            <a:schemeClr val="accent1"/>
+          </a:fillRef>
+          <a:effectRef idx="2">
+            <a:schemeClr val="accent1"/>
+          </a:effectRef>
+          <a:fontRef idx="minor">
+            <a:schemeClr val="lt1"/>
+          </a:fontRef>
+        </p:style>
+        <p:txBody>
+          <a:bodyPr rtlCol="0" anchor="ctr"/>
+          <a:lstStyle/>
+          <a:p>
+            <a:pPr algn="ctr"/>
+          </a:p>
+        </p:txBody>
+      </p:sp>
+      <p:sp>
+        <p:nvSpPr>
+          <p:cNvPr id="29" name="Rectangle 28"/>
+          <p:cNvSpPr/>
+          <p:nvPr/>
+        </p:nvSpPr>
+        <p:spPr>
+          <a:xfrm>
+            <a:off x="6199631" y="3200400"/>
+            <a:ext cx="2670048" cy="45720"/>
+          </a:xfrm>
+          <a:prstGeom prst="rect">
+            <a:avLst/>
+          </a:prstGeom>
+          <a:solidFill>
+            <a:srgbClr val="3A5C9E"/>
+          </a:solidFill>
+          <a:ln>
+            <a:noFill/>
+          </a:ln>
+          <a:effectLst/>
+        </p:spPr>
+        <p:style>
+          <a:lnRef idx="1">
+            <a:schemeClr val="accent1"/>
+          </a:lnRef>
+          <a:fillRef idx="3">
+            <a:schemeClr val="accent1"/>
+          </a:fillRef>
+          <a:effectRef idx="2">
+            <a:schemeClr val="accent1"/>
+          </a:effectRef>
+          <a:fontRef idx="minor">
+            <a:schemeClr val="lt1"/>
+          </a:fontRef>
+        </p:style>
+        <p:txBody>
+          <a:bodyPr rtlCol="0" anchor="ctr"/>
+          <a:lstStyle/>
+          <a:p>
+            <a:pPr algn="ctr"/>
+          </a:p>
+        </p:txBody>
+      </p:sp>
+      <p:sp>
+        <p:nvSpPr>
+          <p:cNvPr id="30" name="TextBox 29"/>
+          <p:cNvSpPr txBox="1"/>
+          <p:nvPr/>
+        </p:nvSpPr>
+        <p:spPr>
+          <a:xfrm>
+            <a:off x="6400799" y="3364992"/>
+            <a:ext cx="2286000" cy="1188720"/>
+          </a:xfrm>
+          <a:prstGeom prst="rect">
+            <a:avLst/>
+          </a:prstGeom>
+          <a:noFill/>
+        </p:spPr>
+        <p:txBody>
+          <a:bodyPr wrap="square" lIns="0" rIns="0" tIns="0" bIns="0" anchor="t">
+            <a:spAutoFit/>
+          </a:bodyPr>
+          <a:lstStyle/>
+          <a:p>
+            <a:pPr algn="l">
+              <a:lnSpc>
+                <a:spcPct val="105000"/>
+              </a:lnSpc>
+              <a:spcBef>
+                <a:spcPts val="0"/>
+              </a:spcBef>
+            </a:pPr>
+            <a:r>
+              <a:rPr sz="1100" b="1">
+                <a:solidFill>
+                  <a:srgbClr val="0F2145"/>
+                </a:solidFill>
+                <a:latin typeface="Calibri"/>
+              </a:rPr>
+              <a:t>7 · REPEAT</a:t>
+            </a:r>
+          </a:p>
+          <a:p>
+            <a:pPr algn="l">
+              <a:lnSpc>
+                <a:spcPct val="105000"/>
+              </a:lnSpc>
+              <a:spcBef>
+                <a:spcPts val="400"/>
+              </a:spcBef>
+            </a:pPr>
+            <a:r>
+              <a:rPr sz="1000" b="0">
+                <a:solidFill>
+                  <a:srgbClr val="5D6B7E"/>
+                </a:solidFill>
+                <a:latin typeface="Calibri"/>
+              </a:rPr>
+              <a:t>Feed the answer back in and predict the next token.</a:t>
+            </a:r>
+          </a:p>
+        </p:txBody>
+      </p:sp>
+      <p:sp>
+        <p:nvSpPr>
+          <p:cNvPr id="31" name="TextBox 30"/>
+          <p:cNvSpPr txBox="1"/>
+          <p:nvPr/>
+        </p:nvSpPr>
+        <p:spPr>
+          <a:xfrm>
+            <a:off x="8887967" y="3703320"/>
+            <a:ext cx="182880" cy="365760"/>
+          </a:xfrm>
+          <a:prstGeom prst="rect">
+            <a:avLst/>
+          </a:prstGeom>
+          <a:noFill/>
+        </p:spPr>
+        <p:txBody>
+          <a:bodyPr wrap="square" lIns="0" rIns="0" tIns="0" bIns="0" anchor="t">
+            <a:spAutoFit/>
+          </a:bodyPr>
+          <a:lstStyle/>
+          <a:p>
+            <a:pPr algn="l">
+              <a:lnSpc>
+                <a:spcPct val="105000"/>
+              </a:lnSpc>
+              <a:spcBef>
+                <a:spcPts val="0"/>
+              </a:spcBef>
+            </a:pPr>
+            <a:r>
+              <a:rPr sz="1800" b="1">
+                <a:solidFill>
+                  <a:srgbClr val="C9A227"/>
+                </a:solidFill>
+                <a:latin typeface="Georgia"/>
+              </a:rPr>
+              <a:t>›</a:t>
+            </a:r>
+          </a:p>
+        </p:txBody>
+      </p:sp>
+      <p:sp>
+        <p:nvSpPr>
+          <p:cNvPr id="32" name="Rectangle 31"/>
+          <p:cNvSpPr/>
+          <p:nvPr/>
+        </p:nvSpPr>
+        <p:spPr>
+          <a:xfrm>
+            <a:off x="9025128" y="3200400"/>
+            <a:ext cx="2670048" cy="1417320"/>
+          </a:xfrm>
+          <a:prstGeom prst="rect">
+            <a:avLst/>
+          </a:prstGeom>
+          <a:solidFill>
+            <a:srgbClr val="FFFFFF"/>
+          </a:solidFill>
+          <a:ln>
+            <a:noFill/>
+          </a:ln>
+          <a:effectLst/>
+        </p:spPr>
+        <p:style>
+          <a:lnRef idx="1">
+            <a:schemeClr val="accent1"/>
+          </a:lnRef>
+          <a:fillRef idx="3">
+            <a:schemeClr val="accent1"/>
+          </a:fillRef>
+          <a:effectRef idx="2">
+            <a:schemeClr val="accent1"/>
+          </a:effectRef>
+          <a:fontRef idx="minor">
+            <a:schemeClr val="lt1"/>
+          </a:fontRef>
+        </p:style>
+        <p:txBody>
+          <a:bodyPr rtlCol="0" anchor="ctr"/>
+          <a:lstStyle/>
+          <a:p>
+            <a:pPr algn="ctr"/>
+          </a:p>
+        </p:txBody>
+      </p:sp>
+      <p:sp>
+        <p:nvSpPr>
+          <p:cNvPr id="33" name="Rectangle 32"/>
+          <p:cNvSpPr/>
+          <p:nvPr/>
+        </p:nvSpPr>
+        <p:spPr>
+          <a:xfrm>
+            <a:off x="9025128" y="3200400"/>
+            <a:ext cx="2670048" cy="45720"/>
+          </a:xfrm>
+          <a:prstGeom prst="rect">
+            <a:avLst/>
+          </a:prstGeom>
+          <a:solidFill>
+            <a:srgbClr val="3A5C9E"/>
+          </a:solidFill>
+          <a:ln>
+            <a:noFill/>
+          </a:ln>
+          <a:effectLst/>
+        </p:spPr>
+        <p:style>
+          <a:lnRef idx="1">
+            <a:schemeClr val="accent1"/>
+          </a:lnRef>
+          <a:fillRef idx="3">
+            <a:schemeClr val="accent1"/>
+          </a:fillRef>
+          <a:effectRef idx="2">
+            <a:schemeClr val="accent1"/>
+          </a:effectRef>
+          <a:fontRef idx="minor">
+            <a:schemeClr val="lt1"/>
+          </a:fontRef>
+        </p:style>
+        <p:txBody>
+          <a:bodyPr rtlCol="0" anchor="ctr"/>
+          <a:lstStyle/>
+          <a:p>
+            <a:pPr algn="ctr"/>
+          </a:p>
+        </p:txBody>
+      </p:sp>
+      <p:sp>
+        <p:nvSpPr>
+          <p:cNvPr id="34" name="TextBox 33"/>
+          <p:cNvSpPr txBox="1"/>
+          <p:nvPr/>
+        </p:nvSpPr>
+        <p:spPr>
+          <a:xfrm>
+            <a:off x="9226296" y="3364992"/>
+            <a:ext cx="2286000" cy="1188720"/>
+          </a:xfrm>
+          <a:prstGeom prst="rect">
+            <a:avLst/>
+          </a:prstGeom>
+          <a:noFill/>
+        </p:spPr>
+        <p:txBody>
+          <a:bodyPr wrap="square" lIns="0" rIns="0" tIns="0" bIns="0" anchor="t">
+            <a:spAutoFit/>
+          </a:bodyPr>
+          <a:lstStyle/>
+          <a:p>
+            <a:pPr algn="l">
+              <a:lnSpc>
+                <a:spcPct val="105000"/>
+              </a:lnSpc>
+              <a:spcBef>
+                <a:spcPts val="0"/>
+              </a:spcBef>
+            </a:pPr>
+            <a:r>
+              <a:rPr sz="1100" b="1">
+                <a:solidFill>
+                  <a:srgbClr val="0F2145"/>
+                </a:solidFill>
+                <a:latin typeface="Calibri"/>
+              </a:rPr>
+              <a:t>8 · STOP</a:t>
+            </a:r>
+          </a:p>
+          <a:p>
+            <a:pPr algn="l">
+              <a:lnSpc>
+                <a:spcPct val="105000"/>
+              </a:lnSpc>
+              <a:spcBef>
+                <a:spcPts val="400"/>
+              </a:spcBef>
+            </a:pPr>
+            <a:r>
+              <a:rPr sz="1000" b="0">
+                <a:solidFill>
+                  <a:srgbClr val="5D6B7E"/>
+                </a:solidFill>
+                <a:latin typeface="Calibri"/>
+              </a:rPr>
+              <a:t>It stops at an end token.  “Paris is the capital of France.”</a:t>
+            </a:r>
+          </a:p>
+        </p:txBody>
+      </p:sp>
+      <p:sp>
+        <p:nvSpPr>
+          <p:cNvPr id="35" name="TextBox 34"/>
+          <p:cNvSpPr txBox="1"/>
+          <p:nvPr/>
+        </p:nvSpPr>
+        <p:spPr>
+          <a:xfrm>
+            <a:off x="548640" y="4846320"/>
+            <a:ext cx="11091672" cy="274320"/>
+          </a:xfrm>
+          <a:prstGeom prst="rect">
+            <a:avLst/>
+          </a:prstGeom>
+          <a:noFill/>
+        </p:spPr>
+        <p:txBody>
+          <a:bodyPr wrap="square" lIns="0" rIns="0" tIns="0" bIns="0" anchor="t">
+            <a:spAutoFit/>
+          </a:bodyPr>
+          <a:lstStyle/>
+          <a:p>
+            <a:pPr algn="l">
+              <a:lnSpc>
+                <a:spcPct val="105000"/>
+              </a:lnSpc>
+              <a:spcBef>
+                <a:spcPts val="0"/>
+              </a:spcBef>
+            </a:pPr>
+            <a:r>
+              <a:rPr sz="1150" b="1">
+                <a:solidFill>
+                  <a:srgbClr val="0F2145"/>
+                </a:solidFill>
+                <a:latin typeface="Calibri"/>
+              </a:rPr>
+              <a:t>↺  Steps 4 to 7 repeat, one token at a time, until the answer is complete. Each pass takes milliseconds.</a:t>
+            </a:r>
+          </a:p>
+        </p:txBody>
+      </p:sp>
+      <p:sp>
+        <p:nvSpPr>
+          <p:cNvPr id="36" name="Rectangle 35"/>
+          <p:cNvSpPr/>
+          <p:nvPr/>
+        </p:nvSpPr>
+        <p:spPr>
+          <a:xfrm>
+            <a:off x="548640" y="5212080"/>
+            <a:ext cx="5577840" cy="868680"/>
           </a:xfrm>
           <a:prstGeom prst="rect">
             <a:avLst/>
@@ -21351,14 +22687,14 @@
       </p:sp>
       <p:sp>
         <p:nvSpPr>
-          <p:cNvPr id="9" name="TextBox 8"/>
-          <p:cNvSpPr txBox="1"/>
-          <p:nvPr/>
-        </p:nvSpPr>
-        <p:spPr>
-          <a:xfrm>
-            <a:off x="804672" y="2880360"/>
-            <a:ext cx="6309360" cy="777240"/>
+          <p:cNvPr id="37" name="TextBox 36"/>
+          <p:cNvSpPr txBox="1"/>
+          <p:nvPr/>
+        </p:nvSpPr>
+        <p:spPr>
+          <a:xfrm>
+            <a:off x="804672" y="5349240"/>
+            <a:ext cx="5120640" cy="731520"/>
           </a:xfrm>
           <a:prstGeom prst="rect">
             <a:avLst/>
@@ -21386,7 +22722,7 @@
                 </a:solidFill>
                 <a:latin typeface="Calibri"/>
               </a:rPr>
-              <a:t>1 · IT READS EVERYTHING AT ONCE</a:t>
+              <a:t>Attention, in one line</a:t>
             </a:r>
           </a:p>
           <a:p>
@@ -21399,237 +22735,27 @@
               </a:spcBef>
             </a:pPr>
             <a:r>
-              <a:rPr sz="1050" b="0">
+              <a:rPr sz="1000" b="0">
                 <a:solidFill>
                   <a:srgbClr val="1B2A41"/>
                 </a:solidFill>
                 <a:latin typeface="Calibri"/>
               </a:rPr>
-              <a:t>Older models read left to right, one word at a time, and forgot the start of a long paragraph. A transformer takes the whole passage together. This is why a model can answer about page 180 of a filing while remembering page 4.</a:t>
-            </a:r>
-          </a:p>
-        </p:txBody>
-      </p:sp>
-      <p:sp>
-        <p:nvSpPr>
-          <p:cNvPr id="10" name="Rectangle 9"/>
+              <a:t>For every token the model scores every other token for relevance. That scoring is attention, and the transformer is the machine that runs it across the whole passage at once.</a:t>
+            </a:r>
+          </a:p>
+        </p:txBody>
+      </p:sp>
+      <p:sp>
+        <p:nvSpPr>
+          <p:cNvPr id="38" name="Rectangle 37"/>
           <p:cNvSpPr/>
           <p:nvPr/>
         </p:nvSpPr>
         <p:spPr>
           <a:xfrm>
-            <a:off x="548640" y="3840480"/>
-            <a:ext cx="6766560" cy="1005840"/>
-          </a:xfrm>
-          <a:prstGeom prst="rect">
-            <a:avLst/>
-          </a:prstGeom>
-          <a:solidFill>
-            <a:srgbClr val="E9EFF8"/>
-          </a:solidFill>
-          <a:ln>
-            <a:noFill/>
-          </a:ln>
-          <a:effectLst/>
-        </p:spPr>
-        <p:style>
-          <a:lnRef idx="1">
-            <a:schemeClr val="accent1"/>
-          </a:lnRef>
-          <a:fillRef idx="3">
-            <a:schemeClr val="accent1"/>
-          </a:fillRef>
-          <a:effectRef idx="2">
-            <a:schemeClr val="accent1"/>
-          </a:effectRef>
-          <a:fontRef idx="minor">
-            <a:schemeClr val="lt1"/>
-          </a:fontRef>
-        </p:style>
-        <p:txBody>
-          <a:bodyPr rtlCol="0" anchor="ctr"/>
-          <a:lstStyle/>
-          <a:p>
-            <a:pPr algn="ctr"/>
-          </a:p>
-        </p:txBody>
-      </p:sp>
-      <p:sp>
-        <p:nvSpPr>
-          <p:cNvPr id="11" name="TextBox 10"/>
-          <p:cNvSpPr txBox="1"/>
-          <p:nvPr/>
-        </p:nvSpPr>
-        <p:spPr>
-          <a:xfrm>
-            <a:off x="804672" y="3977640"/>
-            <a:ext cx="6309360" cy="777240"/>
-          </a:xfrm>
-          <a:prstGeom prst="rect">
-            <a:avLst/>
-          </a:prstGeom>
-          <a:noFill/>
-        </p:spPr>
-        <p:txBody>
-          <a:bodyPr wrap="square" lIns="0" rIns="0" tIns="0" bIns="0" anchor="t">
-            <a:spAutoFit/>
-          </a:bodyPr>
-          <a:lstStyle/>
-          <a:p>
-            <a:pPr algn="l">
-              <a:lnSpc>
-                <a:spcPct val="105000"/>
-              </a:lnSpc>
-              <a:spcBef>
-                <a:spcPts val="0"/>
-              </a:spcBef>
-            </a:pPr>
-            <a:r>
-              <a:rPr sz="1100" b="1">
-                <a:solidFill>
-                  <a:srgbClr val="0F2145"/>
-                </a:solidFill>
-                <a:latin typeface="Calibri"/>
-              </a:rPr>
-              <a:t>2 · ATTENTION DECIDES WHAT MATTERS</a:t>
-            </a:r>
-          </a:p>
-          <a:p>
-            <a:pPr algn="l">
-              <a:lnSpc>
-                <a:spcPct val="105000"/>
-              </a:lnSpc>
-              <a:spcBef>
-                <a:spcPts val="400"/>
-              </a:spcBef>
-            </a:pPr>
-            <a:r>
-              <a:rPr sz="1050" b="0">
-                <a:solidFill>
-                  <a:srgbClr val="1B2A41"/>
-                </a:solidFill>
-                <a:latin typeface="Calibri"/>
-              </a:rPr>
-              <a:t>For each word the model scores every other word for relevance. In “the company said its margin fell because input costs rose”, the word “its” is scored against “the company”, and “fell” against “margin”. Those scores are attention.</a:t>
-            </a:r>
-          </a:p>
-        </p:txBody>
-      </p:sp>
-      <p:sp>
-        <p:nvSpPr>
-          <p:cNvPr id="12" name="Rectangle 11"/>
-          <p:cNvSpPr/>
-          <p:nvPr/>
-        </p:nvSpPr>
-        <p:spPr>
-          <a:xfrm>
-            <a:off x="548640" y="4937760"/>
-            <a:ext cx="6766560" cy="1005840"/>
-          </a:xfrm>
-          <a:prstGeom prst="rect">
-            <a:avLst/>
-          </a:prstGeom>
-          <a:solidFill>
-            <a:srgbClr val="E9EFF8"/>
-          </a:solidFill>
-          <a:ln>
-            <a:noFill/>
-          </a:ln>
-          <a:effectLst/>
-        </p:spPr>
-        <p:style>
-          <a:lnRef idx="1">
-            <a:schemeClr val="accent1"/>
-          </a:lnRef>
-          <a:fillRef idx="3">
-            <a:schemeClr val="accent1"/>
-          </a:fillRef>
-          <a:effectRef idx="2">
-            <a:schemeClr val="accent1"/>
-          </a:effectRef>
-          <a:fontRef idx="minor">
-            <a:schemeClr val="lt1"/>
-          </a:fontRef>
-        </p:style>
-        <p:txBody>
-          <a:bodyPr rtlCol="0" anchor="ctr"/>
-          <a:lstStyle/>
-          <a:p>
-            <a:pPr algn="ctr"/>
-          </a:p>
-        </p:txBody>
-      </p:sp>
-      <p:sp>
-        <p:nvSpPr>
-          <p:cNvPr id="13" name="TextBox 12"/>
-          <p:cNvSpPr txBox="1"/>
-          <p:nvPr/>
-        </p:nvSpPr>
-        <p:spPr>
-          <a:xfrm>
-            <a:off x="804672" y="5074920"/>
-            <a:ext cx="6309360" cy="777240"/>
-          </a:xfrm>
-          <a:prstGeom prst="rect">
-            <a:avLst/>
-          </a:prstGeom>
-          <a:noFill/>
-        </p:spPr>
-        <p:txBody>
-          <a:bodyPr wrap="square" lIns="0" rIns="0" tIns="0" bIns="0" anchor="t">
-            <a:spAutoFit/>
-          </a:bodyPr>
-          <a:lstStyle/>
-          <a:p>
-            <a:pPr algn="l">
-              <a:lnSpc>
-                <a:spcPct val="105000"/>
-              </a:lnSpc>
-              <a:spcBef>
-                <a:spcPts val="0"/>
-              </a:spcBef>
-            </a:pPr>
-            <a:r>
-              <a:rPr sz="1100" b="1">
-                <a:solidFill>
-                  <a:srgbClr val="0F2145"/>
-                </a:solidFill>
-                <a:latin typeface="Calibri"/>
-              </a:rPr>
-              <a:t>3 · LAYERS STACK THE UNDERSTANDING</a:t>
-            </a:r>
-          </a:p>
-          <a:p>
-            <a:pPr algn="l">
-              <a:lnSpc>
-                <a:spcPct val="105000"/>
-              </a:lnSpc>
-              <a:spcBef>
-                <a:spcPts val="400"/>
-              </a:spcBef>
-            </a:pPr>
-            <a:r>
-              <a:rPr sz="1050" b="0">
-                <a:solidFill>
-                  <a:srgbClr val="1B2A41"/>
-                </a:solidFill>
-                <a:latin typeface="Calibri"/>
-              </a:rPr>
-              <a:t>The same step repeats through dozens of layers. Early layers catch grammar. Later layers catch meaning, such as the fact that “margin fell” and “profitability declined” are the same event.</a:t>
-            </a:r>
-          </a:p>
-        </p:txBody>
-      </p:sp>
-      <p:sp>
-        <p:nvSpPr>
-          <p:cNvPr id="14" name="Rectangle 13"/>
-          <p:cNvSpPr/>
-          <p:nvPr/>
-        </p:nvSpPr>
-        <p:spPr>
-          <a:xfrm>
-            <a:off x="7680960" y="2743200"/>
-            <a:ext cx="3959352" cy="3017520"/>
+            <a:off x="6492240" y="5212080"/>
+            <a:ext cx="5148072" cy="868680"/>
           </a:xfrm>
           <a:prstGeom prst="rect">
             <a:avLst/>
@@ -21666,14 +22792,14 @@
       </p:sp>
       <p:sp>
         <p:nvSpPr>
-          <p:cNvPr id="15" name="TextBox 14"/>
-          <p:cNvSpPr txBox="1"/>
-          <p:nvPr/>
-        </p:nvSpPr>
-        <p:spPr>
-          <a:xfrm>
-            <a:off x="7955279" y="2926080"/>
-            <a:ext cx="3474720" cy="2743200"/>
+          <p:cNvPr id="39" name="TextBox 38"/>
+          <p:cNvSpPr txBox="1"/>
+          <p:nvPr/>
+        </p:nvSpPr>
+        <p:spPr>
+          <a:xfrm>
+            <a:off x="6748272" y="5349240"/>
+            <a:ext cx="4663440" cy="731520"/>
           </a:xfrm>
           <a:prstGeom prst="rect">
             <a:avLst/>
@@ -21695,96 +22821,39 @@
               </a:spcBef>
             </a:pPr>
             <a:r>
-              <a:rPr sz="1400" b="1">
+              <a:rPr sz="1100" b="1">
                 <a:solidFill>
                   <a:srgbClr val="C9A227"/>
                 </a:solidFill>
-                <a:latin typeface="Georgia"/>
-              </a:rPr>
-              <a:t>So what is ChatGPT?</a:t>
-            </a:r>
-          </a:p>
-          <a:p>
-            <a:pPr algn="l">
-              <a:lnSpc>
-                <a:spcPct val="105000"/>
-              </a:lnSpc>
-              <a:spcBef>
-                <a:spcPts val="800"/>
-              </a:spcBef>
-            </a:pPr>
-            <a:r>
-              <a:rPr sz="1050" b="0">
+                <a:latin typeface="Calibri"/>
+              </a:rPr>
+              <a:t>And that is what GPT stands for</a:t>
+            </a:r>
+          </a:p>
+          <a:p>
+            <a:pPr algn="l">
+              <a:lnSpc>
+                <a:spcPct val="105000"/>
+              </a:lnSpc>
+              <a:spcBef>
+                <a:spcPts val="400"/>
+              </a:spcBef>
+            </a:pPr>
+            <a:r>
+              <a:rPr sz="1000" b="0">
                 <a:solidFill>
                   <a:srgbClr val="C9D6EE"/>
                 </a:solidFill>
                 <a:latin typeface="Calibri"/>
               </a:rPr>
-              <a:t>GPT stands for Generative Pre-trained Transformer. Generative: it writes. Pre-trained: it learned from an enormous amount of text before you typed anything. Transformer: the design above. ChatGPT is that model wrapped in a chat window, and Claude and Gemini are the same three ideas trained differently.</a:t>
-            </a:r>
-          </a:p>
-          <a:p>
-            <a:pPr algn="l">
-              <a:lnSpc>
-                <a:spcPct val="105000"/>
-              </a:lnSpc>
-              <a:spcBef>
-                <a:spcPts val="1000"/>
-              </a:spcBef>
-            </a:pPr>
-            <a:r>
-              <a:rPr sz="1300" b="1">
-                <a:solidFill>
-                  <a:srgbClr val="C9A227"/>
-                </a:solidFill>
-                <a:latin typeface="Georgia"/>
-              </a:rPr>
-              <a:t>Why you should care</a:t>
-            </a:r>
-          </a:p>
-          <a:p>
-            <a:pPr algn="l">
-              <a:lnSpc>
-                <a:spcPct val="105000"/>
-              </a:lnSpc>
-              <a:spcBef>
-                <a:spcPts val="800"/>
-              </a:spcBef>
-            </a:pPr>
-            <a:r>
-              <a:rPr sz="1050" b="0">
-                <a:solidFill>
-                  <a:srgbClr val="C9D6EE"/>
-                </a:solidFill>
-                <a:latin typeface="Calibri"/>
-              </a:rPr>
-              <a:t>The transformer is why long documents became usable. A prospectus, a 10-K, a Basel disclosure, an earnings call transcript: all of it fits in one pass now.</a:t>
-            </a:r>
-          </a:p>
-          <a:p>
-            <a:pPr algn="l">
-              <a:lnSpc>
-                <a:spcPct val="105000"/>
-              </a:lnSpc>
-              <a:spcBef>
-                <a:spcPts val="600"/>
-              </a:spcBef>
-            </a:pPr>
-            <a:r>
-              <a:rPr sz="1050" b="0">
-                <a:solidFill>
-                  <a:srgbClr val="C9D6EE"/>
-                </a:solidFill>
-                <a:latin typeface="Calibri"/>
-              </a:rPr>
-              <a:t>Attention is a weighting, not a lookup. Nothing in it guarantees a correct number.</a:t>
-            </a:r>
-          </a:p>
-        </p:txBody>
-      </p:sp>
-      <p:sp>
-        <p:nvSpPr>
-          <p:cNvPr id="16" name="TextBox 15"/>
+              <a:t>Generative Pre-trained Transformer. It writes, it learned from an enormous amount of text first, and this is the design. ChatGPT is that model in a chat window.</a:t>
+            </a:r>
+          </a:p>
+        </p:txBody>
+      </p:sp>
+      <p:sp>
+        <p:nvSpPr>
+          <p:cNvPr id="40" name="TextBox 39"/>
           <p:cNvSpPr txBox="1"/>
           <p:nvPr/>
         </p:nvSpPr>
@@ -21826,7 +22895,7 @@
       </p:sp>
       <p:sp>
         <p:nvSpPr>
-          <p:cNvPr id="17" name="TextBox 16"/>
+          <p:cNvPr id="41" name="TextBox 40"/>
           <p:cNvSpPr txBox="1"/>
           <p:nvPr/>
         </p:nvSpPr>
@@ -22754,7 +23823,7 @@
                 </a:solidFill>
                 <a:latin typeface="Calibri"/>
               </a:rPr>
-              <a:t>MODULE 1  ·  12</a:t>
+              <a:t>MODULE 1  ·  11</a:t>
             </a:r>
           </a:p>
         </p:txBody>
@@ -24674,7 +25743,7 @@
                 </a:solidFill>
                 <a:latin typeface="Calibri"/>
               </a:rPr>
-              <a:t>MODULE 1  ·  19</a:t>
+              <a:t>MODULE 1  ·  18</a:t>
             </a:r>
           </a:p>
         </p:txBody>
@@ -24870,7 +25939,7 @@
                 </a:solidFill>
                 <a:latin typeface="Calibri"/>
               </a:rPr>
-              <a:t>Our goal: the latest price, last year's revenue and the profit and loss lines for any listed company. Eight lines of Python and one free library.</a:t>
+              <a:t>Our goal: Swiggy's share price, its revenue and three years of its profit and loss. Thirty lines of Python and one free library.</a:t>
             </a:r>
           </a:p>
         </p:txBody>
@@ -25036,7 +26105,7 @@
                 </a:solidFill>
                 <a:latin typeface="Consolas"/>
               </a:rPr>
-              <a:t>t = yf.Ticker("RELIANCE.NS")</a:t>
+              <a:t>t = yf.Ticker("SWIGGY.NS")</a:t>
             </a:r>
           </a:p>
           <a:p>
@@ -25337,7 +26406,7 @@
                 </a:solidFill>
                 <a:latin typeface="Calibri"/>
               </a:rPr>
-              <a:t>Reliance Industries   RELIANCE.NS</a:t>
+              <a:t>Swiggy Limited   SWIGGY.NS</a:t>
             </a:r>
           </a:p>
           <a:p>
@@ -25356,7 +26425,7 @@
                 </a:solidFill>
                 <a:latin typeface="Georgia"/>
               </a:rPr>
-              <a:t>INR 1,334.80</a:t>
+              <a:t>INR 280.75</a:t>
             </a:r>
           </a:p>
           <a:p>
@@ -25375,7 +26444,7 @@
                 </a:solidFill>
                 <a:latin typeface="Calibri"/>
               </a:rPr>
-              <a:t>Revenue INR 10.57T for the year to 31 Mar 2026. Correct.</a:t>
+              <a:t>Revenue INR 22,828 crore for the year to 31 Mar 2026. Revenue doubled in two years, and the operating loss widened every year: 2,601 to 3,392 to 4,414 crore.</a:t>
             </a:r>
           </a:p>
         </p:txBody>
@@ -25709,7 +26778,7 @@
                 </a:solidFill>
                 <a:latin typeface="Calibri"/>
               </a:rPr>
-              <a:t>A working lookup for any listed company, the full profit and loss table, and one number you already know not to trust. No subscription and no data licence.</a:t>
+              <a:t>Swiggy's full profit and loss on your screen, three years side by side, and a company you can actually argue about. No subscription and no data licence.</a:t>
             </a:r>
           </a:p>
           <a:p>
@@ -25812,7 +26881,7 @@
                 </a:solidFill>
                 <a:latin typeface="Calibri"/>
               </a:rPr>
-              <a:t>MODULE 1  ·  22</a:t>
+              <a:t>MODULE 1  ·  21</a:t>
             </a:r>
           </a:p>
         </p:txBody>
@@ -27272,7 +28341,7 @@
                 </a:solidFill>
                 <a:latin typeface="Calibri"/>
               </a:rPr>
-              <a:t>What it changes for you</a:t>
+              <a:t>How it scales to any name</a:t>
             </a:r>
           </a:p>
           <a:p>
@@ -27291,7 +28360,7 @@
                 </a:solidFill>
                 <a:latin typeface="Calibri"/>
               </a:rPr>
-              <a:t>You stop being the person who types the code. You become the person who specifies the job and verifies the answer. That is a promotion, and it is what a GCC is hiring for.</a:t>
+              <a:t>The script only did Swiggy, because the ticker was typed into it. The app takes any name, asks Yahoo's search for the matching symbol, prefers the NSE listing, then fetches. That one lookup is the whole difference between a script and a tool.</a:t>
             </a:r>
           </a:p>
         </p:txBody>
@@ -27480,7 +28549,7 @@
                 </a:solidFill>
                 <a:latin typeface="Calibri"/>
               </a:rPr>
-              <a:t>MODULE 1  ·  23</a:t>
+              <a:t>MODULE 1  ·  22</a:t>
             </a:r>
           </a:p>
         </p:txBody>
@@ -30079,7 +31148,7 @@
                 </a:solidFill>
                 <a:latin typeface="Calibri"/>
               </a:rPr>
-              <a:t>MODULE 1  ·  11</a:t>
+              <a:t>MODULE 1  ·  10</a:t>
             </a:r>
           </a:p>
         </p:txBody>
@@ -32889,7 +33958,7 @@
                 </a:solidFill>
                 <a:latin typeface="Calibri"/>
               </a:rPr>
-              <a:t>MODULE 1  ·  18</a:t>
+              <a:t>MODULE 1  ·  17</a:t>
             </a:r>
           </a:p>
         </p:txBody>
@@ -34254,7 +35323,7 @@
                 </a:solidFill>
                 <a:latin typeface="Calibri"/>
               </a:rPr>
-              <a:t>MODULE 1  ·  25</a:t>
+              <a:t>MODULE 1  ·  24</a:t>
             </a:r>
           </a:p>
         </p:txBody>
@@ -34408,7 +35477,7 @@
                 </a:solidFill>
                 <a:latin typeface="Georgia"/>
               </a:rPr>
-              <a:t>Four questions on the cases and the lab</a:t>
+              <a:t>Two questions on the cases</a:t>
             </a:r>
           </a:p>
         </p:txBody>
@@ -34421,8 +35490,8 @@
         </p:nvSpPr>
         <p:spPr>
           <a:xfrm>
-            <a:off x="548640" y="1737360"/>
-            <a:ext cx="11091672" cy="960120"/>
+            <a:off x="548640" y="1828800"/>
+            <a:ext cx="11091672" cy="1371600"/>
           </a:xfrm>
           <a:prstGeom prst="rect">
             <a:avLst/>
@@ -34465,8 +35534,8 @@
         </p:nvSpPr>
         <p:spPr>
           <a:xfrm>
-            <a:off x="548640" y="1737360"/>
-            <a:ext cx="64008" cy="960120"/>
+            <a:off x="548640" y="1828800"/>
+            <a:ext cx="64008" cy="1371600"/>
           </a:xfrm>
           <a:prstGeom prst="rect">
             <a:avLst/>
@@ -34509,8 +35578,8 @@
         </p:nvSpPr>
         <p:spPr>
           <a:xfrm>
-            <a:off x="822960" y="1901952"/>
-            <a:ext cx="640080" cy="457200"/>
+            <a:off x="822960" y="2103120"/>
+            <a:ext cx="822960" cy="548640"/>
           </a:xfrm>
           <a:prstGeom prst="rect">
             <a:avLst/>
@@ -34532,7 +35601,7 @@
               </a:spcBef>
             </a:pPr>
             <a:r>
-              <a:rPr sz="1500" b="1">
+              <a:rPr sz="2000" b="1">
                 <a:solidFill>
                   <a:srgbClr val="3A5C9E"/>
                 </a:solidFill>
@@ -34551,8 +35620,8 @@
         </p:nvSpPr>
         <p:spPr>
           <a:xfrm>
-            <a:off x="1600200" y="1892807"/>
-            <a:ext cx="9784080" cy="777240"/>
+            <a:off x="1737360" y="2084832"/>
+            <a:ext cx="9601200" cy="1005840"/>
           </a:xfrm>
           <a:prstGeom prst="rect">
             <a:avLst/>
@@ -34574,7 +35643,7 @@
               </a:spcBef>
             </a:pPr>
             <a:r>
-              <a:rPr sz="1150" b="0">
+              <a:rPr sz="1300" b="0">
                 <a:solidFill>
                   <a:srgbClr val="1B2A41"/>
                 </a:solidFill>
@@ -34593,8 +35662,8 @@
         </p:nvSpPr>
         <p:spPr>
           <a:xfrm>
-            <a:off x="548640" y="2788920"/>
-            <a:ext cx="11091672" cy="960120"/>
+            <a:off x="548640" y="3429000"/>
+            <a:ext cx="11091672" cy="1371600"/>
           </a:xfrm>
           <a:prstGeom prst="rect">
             <a:avLst/>
@@ -34637,8 +35706,8 @@
         </p:nvSpPr>
         <p:spPr>
           <a:xfrm>
-            <a:off x="548640" y="2788920"/>
-            <a:ext cx="64008" cy="960120"/>
+            <a:off x="548640" y="3429000"/>
+            <a:ext cx="64008" cy="1371600"/>
           </a:xfrm>
           <a:prstGeom prst="rect">
             <a:avLst/>
@@ -34681,8 +35750,8 @@
         </p:nvSpPr>
         <p:spPr>
           <a:xfrm>
-            <a:off x="822960" y="2953512"/>
-            <a:ext cx="640080" cy="457200"/>
+            <a:off x="822960" y="3703320"/>
+            <a:ext cx="822960" cy="548640"/>
           </a:xfrm>
           <a:prstGeom prst="rect">
             <a:avLst/>
@@ -34704,7 +35773,7 @@
               </a:spcBef>
             </a:pPr>
             <a:r>
-              <a:rPr sz="1500" b="1">
+              <a:rPr sz="2000" b="1">
                 <a:solidFill>
                   <a:srgbClr val="3A5C9E"/>
                 </a:solidFill>
@@ -34723,8 +35792,8 @@
         </p:nvSpPr>
         <p:spPr>
           <a:xfrm>
-            <a:off x="1600200" y="2944368"/>
-            <a:ext cx="9784080" cy="777240"/>
+            <a:off x="1737360" y="3685032"/>
+            <a:ext cx="9601200" cy="1005840"/>
           </a:xfrm>
           <a:prstGeom prst="rect">
             <a:avLst/>
@@ -34746,7 +35815,7 @@
               </a:spcBef>
             </a:pPr>
             <a:r>
-              <a:rPr sz="1150" b="0">
+              <a:rPr sz="1300" b="0">
                 <a:solidFill>
                   <a:srgbClr val="1B2A41"/>
                 </a:solidFill>
@@ -34765,352 +35834,8 @@
         </p:nvSpPr>
         <p:spPr>
           <a:xfrm>
-            <a:off x="548640" y="3840479"/>
-            <a:ext cx="11091672" cy="960120"/>
-          </a:xfrm>
-          <a:prstGeom prst="rect">
-            <a:avLst/>
-          </a:prstGeom>
-          <a:solidFill>
-            <a:srgbClr val="FFFFFF"/>
-          </a:solidFill>
-          <a:ln>
-            <a:noFill/>
-          </a:ln>
-          <a:effectLst/>
-        </p:spPr>
-        <p:style>
-          <a:lnRef idx="1">
-            <a:schemeClr val="accent1"/>
-          </a:lnRef>
-          <a:fillRef idx="3">
-            <a:schemeClr val="accent1"/>
-          </a:fillRef>
-          <a:effectRef idx="2">
-            <a:schemeClr val="accent1"/>
-          </a:effectRef>
-          <a:fontRef idx="minor">
-            <a:schemeClr val="lt1"/>
-          </a:fontRef>
-        </p:style>
-        <p:txBody>
-          <a:bodyPr rtlCol="0" anchor="ctr"/>
-          <a:lstStyle/>
-          <a:p>
-            <a:pPr algn="ctr"/>
-          </a:p>
-        </p:txBody>
-      </p:sp>
-      <p:sp>
-        <p:nvSpPr>
-          <p:cNvPr id="14" name="Rectangle 13"/>
-          <p:cNvSpPr/>
-          <p:nvPr/>
-        </p:nvSpPr>
-        <p:spPr>
-          <a:xfrm>
-            <a:off x="548640" y="3840479"/>
-            <a:ext cx="64008" cy="960120"/>
-          </a:xfrm>
-          <a:prstGeom prst="rect">
-            <a:avLst/>
-          </a:prstGeom>
-          <a:solidFill>
-            <a:srgbClr val="C9A227"/>
-          </a:solidFill>
-          <a:ln>
-            <a:noFill/>
-          </a:ln>
-          <a:effectLst/>
-        </p:spPr>
-        <p:style>
-          <a:lnRef idx="1">
-            <a:schemeClr val="accent1"/>
-          </a:lnRef>
-          <a:fillRef idx="3">
-            <a:schemeClr val="accent1"/>
-          </a:fillRef>
-          <a:effectRef idx="2">
-            <a:schemeClr val="accent1"/>
-          </a:effectRef>
-          <a:fontRef idx="minor">
-            <a:schemeClr val="lt1"/>
-          </a:fontRef>
-        </p:style>
-        <p:txBody>
-          <a:bodyPr rtlCol="0" anchor="ctr"/>
-          <a:lstStyle/>
-          <a:p>
-            <a:pPr algn="ctr"/>
-          </a:p>
-        </p:txBody>
-      </p:sp>
-      <p:sp>
-        <p:nvSpPr>
-          <p:cNvPr id="15" name="TextBox 14"/>
-          <p:cNvSpPr txBox="1"/>
-          <p:nvPr/>
-        </p:nvSpPr>
-        <p:spPr>
-          <a:xfrm>
-            <a:off x="822960" y="4005071"/>
-            <a:ext cx="640080" cy="457200"/>
-          </a:xfrm>
-          <a:prstGeom prst="rect">
-            <a:avLst/>
-          </a:prstGeom>
-          <a:noFill/>
-        </p:spPr>
-        <p:txBody>
-          <a:bodyPr wrap="square" lIns="0" rIns="0" tIns="0" bIns="0" anchor="t">
-            <a:spAutoFit/>
-          </a:bodyPr>
-          <a:lstStyle/>
-          <a:p>
-            <a:pPr algn="l">
-              <a:lnSpc>
-                <a:spcPct val="105000"/>
-              </a:lnSpc>
-              <a:spcBef>
-                <a:spcPts val="0"/>
-              </a:spcBef>
-            </a:pPr>
-            <a:r>
-              <a:rPr sz="1500" b="1">
-                <a:solidFill>
-                  <a:srgbClr val="3A5C9E"/>
-                </a:solidFill>
-                <a:latin typeface="Georgia"/>
-              </a:rPr>
-              <a:t>Q9</a:t>
-            </a:r>
-          </a:p>
-        </p:txBody>
-      </p:sp>
-      <p:sp>
-        <p:nvSpPr>
-          <p:cNvPr id="16" name="TextBox 15"/>
-          <p:cNvSpPr txBox="1"/>
-          <p:nvPr/>
-        </p:nvSpPr>
-        <p:spPr>
-          <a:xfrm>
-            <a:off x="1600200" y="3995927"/>
-            <a:ext cx="9784080" cy="777240"/>
-          </a:xfrm>
-          <a:prstGeom prst="rect">
-            <a:avLst/>
-          </a:prstGeom>
-          <a:noFill/>
-        </p:spPr>
-        <p:txBody>
-          <a:bodyPr wrap="square" lIns="0" rIns="0" tIns="0" bIns="0" anchor="t">
-            <a:spAutoFit/>
-          </a:bodyPr>
-          <a:lstStyle/>
-          <a:p>
-            <a:pPr algn="l">
-              <a:lnSpc>
-                <a:spcPct val="105000"/>
-              </a:lnSpc>
-              <a:spcBef>
-                <a:spcPts val="0"/>
-              </a:spcBef>
-            </a:pPr>
-            <a:r>
-              <a:rPr sz="1150" b="0">
-                <a:solidFill>
-                  <a:srgbClr val="1B2A41"/>
-                </a:solidFill>
-                <a:latin typeface="Calibri"/>
-              </a:rPr>
-              <a:t>The app we built returned Reliance correctly and Infosys wrongly. What was wrong with the Infosys figure, and which single check would have caught it?</a:t>
-            </a:r>
-          </a:p>
-        </p:txBody>
-      </p:sp>
-      <p:sp>
-        <p:nvSpPr>
-          <p:cNvPr id="17" name="Rectangle 16"/>
-          <p:cNvSpPr/>
-          <p:nvPr/>
-        </p:nvSpPr>
-        <p:spPr>
-          <a:xfrm>
-            <a:off x="548640" y="4892040"/>
-            <a:ext cx="11091672" cy="960120"/>
-          </a:xfrm>
-          <a:prstGeom prst="rect">
-            <a:avLst/>
-          </a:prstGeom>
-          <a:solidFill>
-            <a:srgbClr val="FFFFFF"/>
-          </a:solidFill>
-          <a:ln>
-            <a:noFill/>
-          </a:ln>
-          <a:effectLst/>
-        </p:spPr>
-        <p:style>
-          <a:lnRef idx="1">
-            <a:schemeClr val="accent1"/>
-          </a:lnRef>
-          <a:fillRef idx="3">
-            <a:schemeClr val="accent1"/>
-          </a:fillRef>
-          <a:effectRef idx="2">
-            <a:schemeClr val="accent1"/>
-          </a:effectRef>
-          <a:fontRef idx="minor">
-            <a:schemeClr val="lt1"/>
-          </a:fontRef>
-        </p:style>
-        <p:txBody>
-          <a:bodyPr rtlCol="0" anchor="ctr"/>
-          <a:lstStyle/>
-          <a:p>
-            <a:pPr algn="ctr"/>
-          </a:p>
-        </p:txBody>
-      </p:sp>
-      <p:sp>
-        <p:nvSpPr>
-          <p:cNvPr id="18" name="Rectangle 17"/>
-          <p:cNvSpPr/>
-          <p:nvPr/>
-        </p:nvSpPr>
-        <p:spPr>
-          <a:xfrm>
-            <a:off x="548640" y="4892040"/>
-            <a:ext cx="64008" cy="960120"/>
-          </a:xfrm>
-          <a:prstGeom prst="rect">
-            <a:avLst/>
-          </a:prstGeom>
-          <a:solidFill>
-            <a:srgbClr val="C9A227"/>
-          </a:solidFill>
-          <a:ln>
-            <a:noFill/>
-          </a:ln>
-          <a:effectLst/>
-        </p:spPr>
-        <p:style>
-          <a:lnRef idx="1">
-            <a:schemeClr val="accent1"/>
-          </a:lnRef>
-          <a:fillRef idx="3">
-            <a:schemeClr val="accent1"/>
-          </a:fillRef>
-          <a:effectRef idx="2">
-            <a:schemeClr val="accent1"/>
-          </a:effectRef>
-          <a:fontRef idx="minor">
-            <a:schemeClr val="lt1"/>
-          </a:fontRef>
-        </p:style>
-        <p:txBody>
-          <a:bodyPr rtlCol="0" anchor="ctr"/>
-          <a:lstStyle/>
-          <a:p>
-            <a:pPr algn="ctr"/>
-          </a:p>
-        </p:txBody>
-      </p:sp>
-      <p:sp>
-        <p:nvSpPr>
-          <p:cNvPr id="19" name="TextBox 18"/>
-          <p:cNvSpPr txBox="1"/>
-          <p:nvPr/>
-        </p:nvSpPr>
-        <p:spPr>
-          <a:xfrm>
-            <a:off x="822960" y="5056631"/>
-            <a:ext cx="640080" cy="457200"/>
-          </a:xfrm>
-          <a:prstGeom prst="rect">
-            <a:avLst/>
-          </a:prstGeom>
-          <a:noFill/>
-        </p:spPr>
-        <p:txBody>
-          <a:bodyPr wrap="square" lIns="0" rIns="0" tIns="0" bIns="0" anchor="t">
-            <a:spAutoFit/>
-          </a:bodyPr>
-          <a:lstStyle/>
-          <a:p>
-            <a:pPr algn="l">
-              <a:lnSpc>
-                <a:spcPct val="105000"/>
-              </a:lnSpc>
-              <a:spcBef>
-                <a:spcPts val="0"/>
-              </a:spcBef>
-            </a:pPr>
-            <a:r>
-              <a:rPr sz="1500" b="1">
-                <a:solidFill>
-                  <a:srgbClr val="3A5C9E"/>
-                </a:solidFill>
-                <a:latin typeface="Georgia"/>
-              </a:rPr>
-              <a:t>Q10</a:t>
-            </a:r>
-          </a:p>
-        </p:txBody>
-      </p:sp>
-      <p:sp>
-        <p:nvSpPr>
-          <p:cNvPr id="20" name="TextBox 19"/>
-          <p:cNvSpPr txBox="1"/>
-          <p:nvPr/>
-        </p:nvSpPr>
-        <p:spPr>
-          <a:xfrm>
-            <a:off x="1600200" y="5047488"/>
-            <a:ext cx="9784080" cy="777240"/>
-          </a:xfrm>
-          <a:prstGeom prst="rect">
-            <a:avLst/>
-          </a:prstGeom>
-          <a:noFill/>
-        </p:spPr>
-        <p:txBody>
-          <a:bodyPr wrap="square" lIns="0" rIns="0" tIns="0" bIns="0" anchor="t">
-            <a:spAutoFit/>
-          </a:bodyPr>
-          <a:lstStyle/>
-          <a:p>
-            <a:pPr algn="l">
-              <a:lnSpc>
-                <a:spcPct val="105000"/>
-              </a:lnSpc>
-              <a:spcBef>
-                <a:spcPts val="0"/>
-              </a:spcBef>
-            </a:pPr>
-            <a:r>
-              <a:rPr sz="1150" b="0">
-                <a:solidFill>
-                  <a:srgbClr val="1B2A41"/>
-                </a:solidFill>
-                <a:latin typeface="Calibri"/>
-              </a:rPr>
-              <a:t>Your team wants to let an agent email clients directly. Name two controls you would insist on first, and say what each one prevents.</a:t>
-            </a:r>
-          </a:p>
-        </p:txBody>
-      </p:sp>
-      <p:sp>
-        <p:nvSpPr>
-          <p:cNvPr id="21" name="Rectangle 20"/>
-          <p:cNvSpPr/>
-          <p:nvPr/>
-        </p:nvSpPr>
-        <p:spPr>
-          <a:xfrm>
-            <a:off x="548640" y="5989320"/>
-            <a:ext cx="11091672" cy="457200"/>
+            <a:off x="548640" y="5394960"/>
+            <a:ext cx="11091672" cy="685800"/>
           </a:xfrm>
           <a:prstGeom prst="rect">
             <a:avLst/>
@@ -35147,14 +35872,14 @@
       </p:sp>
       <p:sp>
         <p:nvSpPr>
-          <p:cNvPr id="22" name="TextBox 21"/>
-          <p:cNvSpPr txBox="1"/>
-          <p:nvPr/>
-        </p:nvSpPr>
-        <p:spPr>
-          <a:xfrm>
-            <a:off x="822960" y="5989320"/>
-            <a:ext cx="10515600" cy="457200"/>
+          <p:cNvPr id="14" name="TextBox 13"/>
+          <p:cNvSpPr txBox="1"/>
+          <p:nvPr/>
+        </p:nvSpPr>
+        <p:spPr>
+          <a:xfrm>
+            <a:off x="822960" y="5394960"/>
+            <a:ext cx="10515600" cy="685800"/>
           </a:xfrm>
           <a:prstGeom prst="rect">
             <a:avLst/>
@@ -35198,7 +35923,7 @@
       </p:sp>
       <p:sp>
         <p:nvSpPr>
-          <p:cNvPr id="23" name="TextBox 22"/>
+          <p:cNvPr id="15" name="TextBox 14"/>
           <p:cNvSpPr txBox="1"/>
           <p:nvPr/>
         </p:nvSpPr>
@@ -35240,7 +35965,7 @@
       </p:sp>
       <p:sp>
         <p:nvSpPr>
-          <p:cNvPr id="24" name="TextBox 23"/>
+          <p:cNvPr id="16" name="TextBox 15"/>
           <p:cNvSpPr txBox="1"/>
           <p:nvPr/>
         </p:nvSpPr>
@@ -35275,7 +36000,7 @@
                 </a:solidFill>
                 <a:latin typeface="Calibri"/>
               </a:rPr>
-              <a:t>MODULE 1  ·  26</a:t>
+              <a:t>MODULE 1  ·  25</a:t>
             </a:r>
           </a:p>
         </p:txBody>
@@ -36472,7 +37197,7 @@
                 </a:solidFill>
                 <a:latin typeface="Calibri"/>
               </a:rPr>
-              <a:t>MODULE 1  ·  10</a:t>
+              <a:t>MODULE 1  ·  09</a:t>
             </a:r>
           </a:p>
         </p:txBody>

</xml_diff>

<commit_message>
Modules 1-3: add more practice questions to the question slides and correct the card counts
Co-Authored-By: Claude Fable 5.1 <noreply@anthropic.com>
</commit_message>
<xml_diff>
--- a/slides/Module-01-Foundations-of-Agentic-AI.pptx
+++ b/slides/Module-01-Foundations-of-Agentic-AI.pptx
@@ -31,6 +31,7 @@
     <p:sldId id="276" r:id="rId28"/>
     <p:sldId id="277" r:id="rId29"/>
     <p:sldId id="278" r:id="rId30"/>
+    <p:sldId id="280" r:id="rId32"/>
     <p:sldId id="279" r:id="rId31"/>
   </p:sldIdLst>
   <p:sldSz cx="12192000" cy="6858000"/>
@@ -24726,7 +24727,7 @@
                 </a:solidFill>
                 <a:latin typeface="Georgia"/>
               </a:rPr>
-              <a:t>Q7</a:t>
+              <a:t>Q9</a:t>
             </a:r>
           </a:p>
         </p:txBody>
@@ -24926,7 +24927,7 @@
                 </a:solidFill>
                 <a:latin typeface="Georgia"/>
               </a:rPr>
-              <a:t>Q8</a:t>
+              <a:t>Q10</a:t>
             </a:r>
           </a:p>
         </p:txBody>
@@ -25175,7 +25176,7 @@
                 </a:solidFill>
                 <a:latin typeface="Calibri"/>
               </a:rPr>
-              <a:t>MODULE 1  ·  24</a:t>
+              <a:t>MODULE 1  ·  25</a:t>
             </a:r>
           </a:p>
         </p:txBody>
@@ -25186,6 +25187,643 @@
     <a:masterClrMapping/>
   </p:clrMapOvr>
   <p:transition xmlns:p14="http://schemas.microsoft.com/office/powerpoint/2010/main" spd="med" advClick="1"/>
+</p:sld>
+</file>
+
+<file path=ppt/slides/slide25.xml><?xml version="1.0" encoding="utf-8"?>
+<p:sld xmlns:a="http://schemas.openxmlformats.org/drawingml/2006/main" xmlns:p="http://schemas.openxmlformats.org/presentationml/2006/main" xmlns:r="http://schemas.openxmlformats.org/officeDocument/2006/relationships">
+  <p:cSld>
+    <p:bg>
+      <p:bgPr>
+        <a:solidFill>
+          <a:srgbClr val="F7F8FA"/>
+        </a:solidFill>
+      </p:bgPr>
+    </p:bg>
+    <p:spTree>
+      <p:nvGrpSpPr>
+        <p:cNvPr id="1" name=""/>
+        <p:cNvGrpSpPr/>
+        <p:nvPr/>
+      </p:nvGrpSpPr>
+      <p:grpSpPr/>
+      <p:sp>
+        <p:nvSpPr>
+          <p:cNvPr id="2" name="Rectangle 1"/>
+          <p:cNvSpPr/>
+          <p:nvPr/>
+        </p:nvSpPr>
+        <p:spPr>
+          <a:xfrm>
+            <a:off x="548640" y="402336"/>
+            <a:ext cx="118872" cy="118872"/>
+          </a:xfrm>
+          <a:prstGeom prst="rect">
+            <a:avLst/>
+          </a:prstGeom>
+          <a:solidFill>
+            <a:srgbClr val="C9A227"/>
+          </a:solidFill>
+          <a:ln>
+            <a:noFill/>
+          </a:ln>
+          <a:effectLst/>
+        </p:spPr>
+        <p:style>
+          <a:lnRef idx="1">
+            <a:schemeClr val="accent1"/>
+          </a:lnRef>
+          <a:fillRef idx="3">
+            <a:schemeClr val="accent1"/>
+          </a:fillRef>
+          <a:effectRef idx="2">
+            <a:schemeClr val="accent1"/>
+          </a:effectRef>
+          <a:fontRef idx="minor">
+            <a:schemeClr val="lt1"/>
+          </a:fontRef>
+        </p:style>
+        <p:txBody>
+          <a:bodyPr rtlCol="0" anchor="ctr"/>
+          <a:lstStyle/>
+          <a:p>
+            <a:pPr algn="ctr"/>
+          </a:p>
+        </p:txBody>
+      </p:sp>
+      <p:sp>
+        <p:nvSpPr>
+          <p:cNvPr id="3" name="TextBox 2"/>
+          <p:cNvSpPr txBox="1"/>
+          <p:nvPr/>
+        </p:nvSpPr>
+        <p:spPr>
+          <a:xfrm>
+            <a:off x="786384" y="310896"/>
+            <a:ext cx="10817352" cy="292608"/>
+          </a:xfrm>
+          <a:prstGeom prst="rect">
+            <a:avLst/>
+          </a:prstGeom>
+          <a:noFill/>
+        </p:spPr>
+        <p:txBody>
+          <a:bodyPr wrap="square" lIns="0" rIns="0" tIns="0" bIns="0" anchor="t">
+            <a:spAutoFit/>
+          </a:bodyPr>
+          <a:lstStyle/>
+          <a:p>
+            <a:pPr algn="l">
+              <a:lnSpc>
+                <a:spcPct val="105000"/>
+              </a:lnSpc>
+              <a:spcBef>
+                <a:spcPts val="0"/>
+              </a:spcBef>
+            </a:pPr>
+            <a:r>
+              <a:rPr sz="1100" b="1">
+                <a:solidFill>
+                  <a:srgbClr val="C9A227"/>
+                </a:solidFill>
+                <a:latin typeface="Calibri"/>
+              </a:rPr>
+              <a:t>PRACTICE QUESTIONS · PART A, CONTINUED</a:t>
+            </a:r>
+          </a:p>
+        </p:txBody>
+      </p:sp>
+      <p:sp>
+        <p:nvSpPr>
+          <p:cNvPr id="4" name="TextBox 3"/>
+          <p:cNvSpPr txBox="1"/>
+          <p:nvPr/>
+        </p:nvSpPr>
+        <p:spPr>
+          <a:xfrm>
+            <a:off x="548640" y="621792"/>
+            <a:ext cx="11091672" cy="685800"/>
+          </a:xfrm>
+          <a:prstGeom prst="rect">
+            <a:avLst/>
+          </a:prstGeom>
+          <a:noFill/>
+        </p:spPr>
+        <p:txBody>
+          <a:bodyPr wrap="square" lIns="0" rIns="0" tIns="0" bIns="0" anchor="t">
+            <a:spAutoFit/>
+          </a:bodyPr>
+          <a:lstStyle/>
+          <a:p>
+            <a:pPr algn="l">
+              <a:lnSpc>
+                <a:spcPct val="105000"/>
+              </a:lnSpc>
+              <a:spcBef>
+                <a:spcPts val="0"/>
+              </a:spcBef>
+            </a:pPr>
+            <a:r>
+              <a:rPr sz="2900" b="1">
+                <a:solidFill>
+                  <a:srgbClr val="0F2145"/>
+                </a:solidFill>
+                <a:latin typeface="Georgia"/>
+              </a:rPr>
+              <a:t>Two more from the mid-term paper</a:t>
+            </a:r>
+          </a:p>
+        </p:txBody>
+      </p:sp>
+      <p:sp>
+        <p:nvSpPr>
+          <p:cNvPr id="5" name="Rectangle 4"/>
+          <p:cNvSpPr/>
+          <p:nvPr/>
+        </p:nvSpPr>
+        <p:spPr>
+          <a:xfrm>
+            <a:off x="548640" y="1572768"/>
+            <a:ext cx="11091672" cy="731520"/>
+          </a:xfrm>
+          <a:prstGeom prst="rect">
+            <a:avLst/>
+          </a:prstGeom>
+          <a:solidFill>
+            <a:srgbClr val="FFFFFF"/>
+          </a:solidFill>
+          <a:ln>
+            <a:noFill/>
+          </a:ln>
+          <a:effectLst/>
+        </p:spPr>
+        <p:style>
+          <a:lnRef idx="1">
+            <a:schemeClr val="accent1"/>
+          </a:lnRef>
+          <a:fillRef idx="3">
+            <a:schemeClr val="accent1"/>
+          </a:fillRef>
+          <a:effectRef idx="2">
+            <a:schemeClr val="accent1"/>
+          </a:effectRef>
+          <a:fontRef idx="minor">
+            <a:schemeClr val="lt1"/>
+          </a:fontRef>
+        </p:style>
+        <p:txBody>
+          <a:bodyPr rtlCol="0" anchor="ctr"/>
+          <a:lstStyle/>
+          <a:p>
+            <a:pPr algn="ctr"/>
+          </a:p>
+        </p:txBody>
+      </p:sp>
+      <p:sp>
+        <p:nvSpPr>
+          <p:cNvPr id="6" name="Rectangle 5"/>
+          <p:cNvSpPr/>
+          <p:nvPr/>
+        </p:nvSpPr>
+        <p:spPr>
+          <a:xfrm>
+            <a:off x="548640" y="1572768"/>
+            <a:ext cx="64008" cy="731520"/>
+          </a:xfrm>
+          <a:prstGeom prst="rect">
+            <a:avLst/>
+          </a:prstGeom>
+          <a:solidFill>
+            <a:srgbClr val="C9A227"/>
+          </a:solidFill>
+          <a:ln>
+            <a:noFill/>
+          </a:ln>
+          <a:effectLst/>
+        </p:spPr>
+        <p:style>
+          <a:lnRef idx="1">
+            <a:schemeClr val="accent1"/>
+          </a:lnRef>
+          <a:fillRef idx="3">
+            <a:schemeClr val="accent1"/>
+          </a:fillRef>
+          <a:effectRef idx="2">
+            <a:schemeClr val="accent1"/>
+          </a:effectRef>
+          <a:fontRef idx="minor">
+            <a:schemeClr val="lt1"/>
+          </a:fontRef>
+        </p:style>
+        <p:txBody>
+          <a:bodyPr rtlCol="0" anchor="ctr"/>
+          <a:lstStyle/>
+          <a:p>
+            <a:pPr algn="ctr"/>
+          </a:p>
+        </p:txBody>
+      </p:sp>
+      <p:sp>
+        <p:nvSpPr>
+          <p:cNvPr id="7" name="TextBox 6"/>
+          <p:cNvSpPr txBox="1"/>
+          <p:nvPr/>
+        </p:nvSpPr>
+        <p:spPr>
+          <a:xfrm>
+            <a:off x="822960" y="1655064"/>
+            <a:ext cx="640080" cy="365760"/>
+          </a:xfrm>
+          <a:prstGeom prst="rect">
+            <a:avLst/>
+          </a:prstGeom>
+          <a:noFill/>
+        </p:spPr>
+        <p:txBody>
+          <a:bodyPr wrap="square" lIns="0" rIns="0" tIns="0" bIns="0" anchor="t">
+            <a:spAutoFit/>
+          </a:bodyPr>
+          <a:lstStyle/>
+          <a:p>
+            <a:pPr algn="l">
+              <a:lnSpc>
+                <a:spcPct val="105000"/>
+              </a:lnSpc>
+              <a:spcBef>
+                <a:spcPts val="0"/>
+              </a:spcBef>
+            </a:pPr>
+            <a:r>
+              <a:rPr sz="1400" b="1">
+                <a:solidFill>
+                  <a:srgbClr val="3A5C9E"/>
+                </a:solidFill>
+                <a:latin typeface="Georgia"/>
+              </a:rPr>
+              <a:t>Q7</a:t>
+            </a:r>
+          </a:p>
+        </p:txBody>
+      </p:sp>
+      <p:sp>
+        <p:nvSpPr>
+          <p:cNvPr id="8" name="TextBox 7"/>
+          <p:cNvSpPr txBox="1"/>
+          <p:nvPr/>
+        </p:nvSpPr>
+        <p:spPr>
+          <a:xfrm>
+            <a:off x="1554480" y="1636776"/>
+            <a:ext cx="9875520" cy="603504"/>
+          </a:xfrm>
+          <a:prstGeom prst="rect">
+            <a:avLst/>
+          </a:prstGeom>
+          <a:noFill/>
+        </p:spPr>
+        <p:txBody>
+          <a:bodyPr wrap="square" lIns="0" rIns="0" tIns="0" bIns="0" anchor="t">
+            <a:spAutoFit/>
+          </a:bodyPr>
+          <a:lstStyle/>
+          <a:p>
+            <a:pPr algn="l">
+              <a:lnSpc>
+                <a:spcPct val="105000"/>
+              </a:lnSpc>
+              <a:spcBef>
+                <a:spcPts val="0"/>
+              </a:spcBef>
+            </a:pPr>
+            <a:r>
+              <a:rPr sz="1100" b="0">
+                <a:solidFill>
+                  <a:srgbClr val="1B2A41"/>
+                </a:solidFill>
+                <a:latin typeface="Calibri"/>
+              </a:rPr>
+              <a:t>What is an AI harness? Use the human analogy: what is the brain, and what are the tools?</a:t>
+            </a:r>
+          </a:p>
+          <a:p>
+            <a:pPr algn="l">
+              <a:lnSpc>
+                <a:spcPct val="105000"/>
+              </a:lnSpc>
+              <a:spcBef>
+                <a:spcPts val="200"/>
+              </a:spcBef>
+            </a:pPr>
+            <a:r>
+              <a:rPr sz="900" b="1">
+                <a:solidFill>
+                  <a:srgbClr val="C9A227"/>
+                </a:solidFill>
+                <a:latin typeface="Calibri"/>
+              </a:rPr>
+              <a:t>TIP  </a:t>
+            </a:r>
+            <a:r>
+              <a:rPr sz="900" b="0">
+                <a:solidFill>
+                  <a:srgbClr val="5D6B7E"/>
+                </a:solidFill>
+                <a:latin typeface="Calibri"/>
+              </a:rPr>
+              <a:t>The LLM is the brain. The harness gives it hands: it reads your files, runs commands, sees the error and tries again. Claude Code and Codex are harnesses.</a:t>
+            </a:r>
+          </a:p>
+        </p:txBody>
+      </p:sp>
+      <p:sp>
+        <p:nvSpPr>
+          <p:cNvPr id="9" name="Rectangle 8"/>
+          <p:cNvSpPr/>
+          <p:nvPr/>
+        </p:nvSpPr>
+        <p:spPr>
+          <a:xfrm>
+            <a:off x="548640" y="2377440"/>
+            <a:ext cx="11091672" cy="731520"/>
+          </a:xfrm>
+          <a:prstGeom prst="rect">
+            <a:avLst/>
+          </a:prstGeom>
+          <a:solidFill>
+            <a:srgbClr val="FFFFFF"/>
+          </a:solidFill>
+          <a:ln>
+            <a:noFill/>
+          </a:ln>
+          <a:effectLst/>
+        </p:spPr>
+        <p:style>
+          <a:lnRef idx="1">
+            <a:schemeClr val="accent1"/>
+          </a:lnRef>
+          <a:fillRef idx="3">
+            <a:schemeClr val="accent1"/>
+          </a:fillRef>
+          <a:effectRef idx="2">
+            <a:schemeClr val="accent1"/>
+          </a:effectRef>
+          <a:fontRef idx="minor">
+            <a:schemeClr val="lt1"/>
+          </a:fontRef>
+        </p:style>
+        <p:txBody>
+          <a:bodyPr rtlCol="0" anchor="ctr"/>
+          <a:lstStyle/>
+          <a:p>
+            <a:pPr algn="ctr"/>
+          </a:p>
+        </p:txBody>
+      </p:sp>
+      <p:sp>
+        <p:nvSpPr>
+          <p:cNvPr id="10" name="Rectangle 9"/>
+          <p:cNvSpPr/>
+          <p:nvPr/>
+        </p:nvSpPr>
+        <p:spPr>
+          <a:xfrm>
+            <a:off x="548640" y="2377440"/>
+            <a:ext cx="64008" cy="731520"/>
+          </a:xfrm>
+          <a:prstGeom prst="rect">
+            <a:avLst/>
+          </a:prstGeom>
+          <a:solidFill>
+            <a:srgbClr val="C9A227"/>
+          </a:solidFill>
+          <a:ln>
+            <a:noFill/>
+          </a:ln>
+          <a:effectLst/>
+        </p:spPr>
+        <p:style>
+          <a:lnRef idx="1">
+            <a:schemeClr val="accent1"/>
+          </a:lnRef>
+          <a:fillRef idx="3">
+            <a:schemeClr val="accent1"/>
+          </a:fillRef>
+          <a:effectRef idx="2">
+            <a:schemeClr val="accent1"/>
+          </a:effectRef>
+          <a:fontRef idx="minor">
+            <a:schemeClr val="lt1"/>
+          </a:fontRef>
+        </p:style>
+        <p:txBody>
+          <a:bodyPr rtlCol="0" anchor="ctr"/>
+          <a:lstStyle/>
+          <a:p>
+            <a:pPr algn="ctr"/>
+          </a:p>
+        </p:txBody>
+      </p:sp>
+      <p:sp>
+        <p:nvSpPr>
+          <p:cNvPr id="11" name="TextBox 10"/>
+          <p:cNvSpPr txBox="1"/>
+          <p:nvPr/>
+        </p:nvSpPr>
+        <p:spPr>
+          <a:xfrm>
+            <a:off x="822960" y="2459736"/>
+            <a:ext cx="640080" cy="365760"/>
+          </a:xfrm>
+          <a:prstGeom prst="rect">
+            <a:avLst/>
+          </a:prstGeom>
+          <a:noFill/>
+        </p:spPr>
+        <p:txBody>
+          <a:bodyPr wrap="square" lIns="0" rIns="0" tIns="0" bIns="0" anchor="t">
+            <a:spAutoFit/>
+          </a:bodyPr>
+          <a:lstStyle/>
+          <a:p>
+            <a:pPr algn="l">
+              <a:lnSpc>
+                <a:spcPct val="105000"/>
+              </a:lnSpc>
+              <a:spcBef>
+                <a:spcPts val="0"/>
+              </a:spcBef>
+            </a:pPr>
+            <a:r>
+              <a:rPr sz="1400" b="1">
+                <a:solidFill>
+                  <a:srgbClr val="3A5C9E"/>
+                </a:solidFill>
+                <a:latin typeface="Georgia"/>
+              </a:rPr>
+              <a:t>Q8</a:t>
+            </a:r>
+          </a:p>
+        </p:txBody>
+      </p:sp>
+      <p:sp>
+        <p:nvSpPr>
+          <p:cNvPr id="12" name="TextBox 11"/>
+          <p:cNvSpPr txBox="1"/>
+          <p:nvPr/>
+        </p:nvSpPr>
+        <p:spPr>
+          <a:xfrm>
+            <a:off x="1554480" y="2441448"/>
+            <a:ext cx="9875520" cy="603504"/>
+          </a:xfrm>
+          <a:prstGeom prst="rect">
+            <a:avLst/>
+          </a:prstGeom>
+          <a:noFill/>
+        </p:spPr>
+        <p:txBody>
+          <a:bodyPr wrap="square" lIns="0" rIns="0" tIns="0" bIns="0" anchor="t">
+            <a:spAutoFit/>
+          </a:bodyPr>
+          <a:lstStyle/>
+          <a:p>
+            <a:pPr algn="l">
+              <a:lnSpc>
+                <a:spcPct val="105000"/>
+              </a:lnSpc>
+              <a:spcBef>
+                <a:spcPts val="0"/>
+              </a:spcBef>
+            </a:pPr>
+            <a:r>
+              <a:rPr sz="1100" b="0">
+                <a:solidFill>
+                  <a:srgbClr val="1B2A41"/>
+                </a:solidFill>
+                <a:latin typeface="Calibri"/>
+              </a:rPr>
+              <a:t>What is the difference between an LLM and a harness? Name one LLM and one harness.</a:t>
+            </a:r>
+          </a:p>
+          <a:p>
+            <a:pPr algn="l">
+              <a:lnSpc>
+                <a:spcPct val="105000"/>
+              </a:lnSpc>
+              <a:spcBef>
+                <a:spcPts val="200"/>
+              </a:spcBef>
+            </a:pPr>
+            <a:r>
+              <a:rPr sz="900" b="1">
+                <a:solidFill>
+                  <a:srgbClr val="C9A227"/>
+                </a:solidFill>
+                <a:latin typeface="Calibri"/>
+              </a:rPr>
+              <a:t>TIP  </a:t>
+            </a:r>
+            <a:r>
+              <a:rPr sz="900" b="0">
+                <a:solidFill>
+                  <a:srgbClr val="5D6B7E"/>
+                </a:solidFill>
+                <a:latin typeface="Calibri"/>
+              </a:rPr>
+              <a:t>The LLM predicts text. The harness lets it act in your files and terminal. LLM: Claude. Harness: Claude Code, the app you installed on the desktop.</a:t>
+            </a:r>
+          </a:p>
+        </p:txBody>
+      </p:sp>
+      <p:sp>
+        <p:nvSpPr>
+          <p:cNvPr id="29" name="TextBox 28"/>
+          <p:cNvSpPr txBox="1"/>
+          <p:nvPr/>
+        </p:nvSpPr>
+        <p:spPr>
+          <a:xfrm>
+            <a:off x="548640" y="6446520"/>
+            <a:ext cx="8229600" cy="274320"/>
+          </a:xfrm>
+          <a:prstGeom prst="rect">
+            <a:avLst/>
+          </a:prstGeom>
+          <a:noFill/>
+        </p:spPr>
+        <p:txBody>
+          <a:bodyPr wrap="square" lIns="0" rIns="0" tIns="0" bIns="0" anchor="t">
+            <a:spAutoFit/>
+          </a:bodyPr>
+          <a:lstStyle/>
+          <a:p>
+            <a:pPr algn="l">
+              <a:lnSpc>
+                <a:spcPct val="105000"/>
+              </a:lnSpc>
+              <a:spcBef>
+                <a:spcPts val="0"/>
+              </a:spcBef>
+            </a:pPr>
+            <a:r>
+              <a:rPr sz="900" b="0">
+                <a:solidFill>
+                  <a:srgbClr val="5D6B7E"/>
+                </a:solidFill>
+                <a:latin typeface="Calibri"/>
+              </a:rPr>
+              <a:t>The tip is the shape of the answer, not the whole answer. Two or three sentences each in the exam.</a:t>
+            </a:r>
+          </a:p>
+        </p:txBody>
+      </p:sp>
+      <p:sp>
+        <p:nvSpPr>
+          <p:cNvPr id="30" name="TextBox 29"/>
+          <p:cNvSpPr txBox="1"/>
+          <p:nvPr/>
+        </p:nvSpPr>
+        <p:spPr>
+          <a:xfrm>
+            <a:off x="9262872" y="6446520"/>
+            <a:ext cx="2377440" cy="274320"/>
+          </a:xfrm>
+          <a:prstGeom prst="rect">
+            <a:avLst/>
+          </a:prstGeom>
+          <a:noFill/>
+        </p:spPr>
+        <p:txBody>
+          <a:bodyPr wrap="square" lIns="0" rIns="0" tIns="0" bIns="0" anchor="t">
+            <a:spAutoFit/>
+          </a:bodyPr>
+          <a:lstStyle/>
+          <a:p>
+            <a:pPr algn="r">
+              <a:lnSpc>
+                <a:spcPct val="105000"/>
+              </a:lnSpc>
+              <a:spcBef>
+                <a:spcPts val="0"/>
+              </a:spcBef>
+            </a:pPr>
+            <a:r>
+              <a:rPr sz="850" b="0">
+                <a:solidFill>
+                  <a:srgbClr val="5D6B7E"/>
+                </a:solidFill>
+                <a:latin typeface="Calibri"/>
+              </a:rPr>
+              <a:t>MODULE 1  ·  24</a:t>
+            </a:r>
+          </a:p>
+        </p:txBody>
+      </p:sp>
+    </p:spTree>
+  </p:cSld>
+  <p:clrMapOvr>
+    <a:masterClrMapping/>
+  </p:clrMapOvr>
 </p:sld>
 </file>
 

</xml_diff>

<commit_message>
Modules 1-3: neutral titles on the extra practice-question slides
Co-Authored-By: Claude Fable 5.1 <noreply@anthropic.com>
</commit_message>
<xml_diff>
--- a/slides/Module-01-Foundations-of-Agentic-AI.pptx
+++ b/slides/Module-01-Foundations-of-Agentic-AI.pptx
@@ -24451,6 +24451,643 @@
 </file>
 
 <file path=ppt/slides/slide24.xml><?xml version="1.0" encoding="utf-8"?>
+<p:sld xmlns:a="http://schemas.openxmlformats.org/drawingml/2006/main" xmlns:p="http://schemas.openxmlformats.org/presentationml/2006/main" xmlns:r="http://schemas.openxmlformats.org/officeDocument/2006/relationships">
+  <p:cSld>
+    <p:bg>
+      <p:bgPr>
+        <a:solidFill>
+          <a:srgbClr val="F7F8FA"/>
+        </a:solidFill>
+      </p:bgPr>
+    </p:bg>
+    <p:spTree>
+      <p:nvGrpSpPr>
+        <p:cNvPr id="1" name=""/>
+        <p:cNvGrpSpPr/>
+        <p:nvPr/>
+      </p:nvGrpSpPr>
+      <p:grpSpPr/>
+      <p:sp>
+        <p:nvSpPr>
+          <p:cNvPr id="2" name="Rectangle 1"/>
+          <p:cNvSpPr/>
+          <p:nvPr/>
+        </p:nvSpPr>
+        <p:spPr>
+          <a:xfrm>
+            <a:off x="548640" y="402336"/>
+            <a:ext cx="118872" cy="118872"/>
+          </a:xfrm>
+          <a:prstGeom prst="rect">
+            <a:avLst/>
+          </a:prstGeom>
+          <a:solidFill>
+            <a:srgbClr val="C9A227"/>
+          </a:solidFill>
+          <a:ln>
+            <a:noFill/>
+          </a:ln>
+          <a:effectLst/>
+        </p:spPr>
+        <p:style>
+          <a:lnRef idx="1">
+            <a:schemeClr val="accent1"/>
+          </a:lnRef>
+          <a:fillRef idx="3">
+            <a:schemeClr val="accent1"/>
+          </a:fillRef>
+          <a:effectRef idx="2">
+            <a:schemeClr val="accent1"/>
+          </a:effectRef>
+          <a:fontRef idx="minor">
+            <a:schemeClr val="lt1"/>
+          </a:fontRef>
+        </p:style>
+        <p:txBody>
+          <a:bodyPr rtlCol="0" anchor="ctr"/>
+          <a:lstStyle/>
+          <a:p>
+            <a:pPr algn="ctr"/>
+          </a:p>
+        </p:txBody>
+      </p:sp>
+      <p:sp>
+        <p:nvSpPr>
+          <p:cNvPr id="3" name="TextBox 2"/>
+          <p:cNvSpPr txBox="1"/>
+          <p:nvPr/>
+        </p:nvSpPr>
+        <p:spPr>
+          <a:xfrm>
+            <a:off x="786384" y="310896"/>
+            <a:ext cx="10817352" cy="292608"/>
+          </a:xfrm>
+          <a:prstGeom prst="rect">
+            <a:avLst/>
+          </a:prstGeom>
+          <a:noFill/>
+        </p:spPr>
+        <p:txBody>
+          <a:bodyPr wrap="square" lIns="0" rIns="0" tIns="0" bIns="0" anchor="t">
+            <a:spAutoFit/>
+          </a:bodyPr>
+          <a:lstStyle/>
+          <a:p>
+            <a:pPr algn="l">
+              <a:lnSpc>
+                <a:spcPct val="105000"/>
+              </a:lnSpc>
+              <a:spcBef>
+                <a:spcPts val="0"/>
+              </a:spcBef>
+            </a:pPr>
+            <a:r>
+              <a:rPr sz="1100" b="1">
+                <a:solidFill>
+                  <a:srgbClr val="C9A227"/>
+                </a:solidFill>
+                <a:latin typeface="Calibri"/>
+              </a:rPr>
+              <a:t>PRACTICE QUESTIONS · PART A, CONTINUED</a:t>
+            </a:r>
+          </a:p>
+        </p:txBody>
+      </p:sp>
+      <p:sp>
+        <p:nvSpPr>
+          <p:cNvPr id="4" name="TextBox 3"/>
+          <p:cNvSpPr txBox="1"/>
+          <p:nvPr/>
+        </p:nvSpPr>
+        <p:spPr>
+          <a:xfrm>
+            <a:off x="548640" y="621792"/>
+            <a:ext cx="11091672" cy="685800"/>
+          </a:xfrm>
+          <a:prstGeom prst="rect">
+            <a:avLst/>
+          </a:prstGeom>
+          <a:noFill/>
+        </p:spPr>
+        <p:txBody>
+          <a:bodyPr wrap="square" lIns="0" rIns="0" tIns="0" bIns="0" anchor="t">
+            <a:spAutoFit/>
+          </a:bodyPr>
+          <a:lstStyle/>
+          <a:p>
+            <a:pPr algn="l">
+              <a:lnSpc>
+                <a:spcPct val="105000"/>
+              </a:lnSpc>
+              <a:spcBef>
+                <a:spcPts val="0"/>
+              </a:spcBef>
+            </a:pPr>
+            <a:r>
+              <a:rPr sz="2900" b="1">
+                <a:solidFill>
+                  <a:srgbClr val="0F2145"/>
+                </a:solidFill>
+                <a:latin typeface="Georgia"/>
+              </a:rPr>
+              <a:t>Two more on today's basics</a:t>
+            </a:r>
+          </a:p>
+        </p:txBody>
+      </p:sp>
+      <p:sp>
+        <p:nvSpPr>
+          <p:cNvPr id="5" name="Rectangle 4"/>
+          <p:cNvSpPr/>
+          <p:nvPr/>
+        </p:nvSpPr>
+        <p:spPr>
+          <a:xfrm>
+            <a:off x="548640" y="1572768"/>
+            <a:ext cx="11091672" cy="731520"/>
+          </a:xfrm>
+          <a:prstGeom prst="rect">
+            <a:avLst/>
+          </a:prstGeom>
+          <a:solidFill>
+            <a:srgbClr val="FFFFFF"/>
+          </a:solidFill>
+          <a:ln>
+            <a:noFill/>
+          </a:ln>
+          <a:effectLst/>
+        </p:spPr>
+        <p:style>
+          <a:lnRef idx="1">
+            <a:schemeClr val="accent1"/>
+          </a:lnRef>
+          <a:fillRef idx="3">
+            <a:schemeClr val="accent1"/>
+          </a:fillRef>
+          <a:effectRef idx="2">
+            <a:schemeClr val="accent1"/>
+          </a:effectRef>
+          <a:fontRef idx="minor">
+            <a:schemeClr val="lt1"/>
+          </a:fontRef>
+        </p:style>
+        <p:txBody>
+          <a:bodyPr rtlCol="0" anchor="ctr"/>
+          <a:lstStyle/>
+          <a:p>
+            <a:pPr algn="ctr"/>
+          </a:p>
+        </p:txBody>
+      </p:sp>
+      <p:sp>
+        <p:nvSpPr>
+          <p:cNvPr id="6" name="Rectangle 5"/>
+          <p:cNvSpPr/>
+          <p:nvPr/>
+        </p:nvSpPr>
+        <p:spPr>
+          <a:xfrm>
+            <a:off x="548640" y="1572768"/>
+            <a:ext cx="64008" cy="731520"/>
+          </a:xfrm>
+          <a:prstGeom prst="rect">
+            <a:avLst/>
+          </a:prstGeom>
+          <a:solidFill>
+            <a:srgbClr val="C9A227"/>
+          </a:solidFill>
+          <a:ln>
+            <a:noFill/>
+          </a:ln>
+          <a:effectLst/>
+        </p:spPr>
+        <p:style>
+          <a:lnRef idx="1">
+            <a:schemeClr val="accent1"/>
+          </a:lnRef>
+          <a:fillRef idx="3">
+            <a:schemeClr val="accent1"/>
+          </a:fillRef>
+          <a:effectRef idx="2">
+            <a:schemeClr val="accent1"/>
+          </a:effectRef>
+          <a:fontRef idx="minor">
+            <a:schemeClr val="lt1"/>
+          </a:fontRef>
+        </p:style>
+        <p:txBody>
+          <a:bodyPr rtlCol="0" anchor="ctr"/>
+          <a:lstStyle/>
+          <a:p>
+            <a:pPr algn="ctr"/>
+          </a:p>
+        </p:txBody>
+      </p:sp>
+      <p:sp>
+        <p:nvSpPr>
+          <p:cNvPr id="7" name="TextBox 6"/>
+          <p:cNvSpPr txBox="1"/>
+          <p:nvPr/>
+        </p:nvSpPr>
+        <p:spPr>
+          <a:xfrm>
+            <a:off x="822960" y="1655064"/>
+            <a:ext cx="640080" cy="365760"/>
+          </a:xfrm>
+          <a:prstGeom prst="rect">
+            <a:avLst/>
+          </a:prstGeom>
+          <a:noFill/>
+        </p:spPr>
+        <p:txBody>
+          <a:bodyPr wrap="square" lIns="0" rIns="0" tIns="0" bIns="0" anchor="t">
+            <a:spAutoFit/>
+          </a:bodyPr>
+          <a:lstStyle/>
+          <a:p>
+            <a:pPr algn="l">
+              <a:lnSpc>
+                <a:spcPct val="105000"/>
+              </a:lnSpc>
+              <a:spcBef>
+                <a:spcPts val="0"/>
+              </a:spcBef>
+            </a:pPr>
+            <a:r>
+              <a:rPr sz="1400" b="1">
+                <a:solidFill>
+                  <a:srgbClr val="3A5C9E"/>
+                </a:solidFill>
+                <a:latin typeface="Georgia"/>
+              </a:rPr>
+              <a:t>Q7</a:t>
+            </a:r>
+          </a:p>
+        </p:txBody>
+      </p:sp>
+      <p:sp>
+        <p:nvSpPr>
+          <p:cNvPr id="8" name="TextBox 7"/>
+          <p:cNvSpPr txBox="1"/>
+          <p:nvPr/>
+        </p:nvSpPr>
+        <p:spPr>
+          <a:xfrm>
+            <a:off x="1554480" y="1636776"/>
+            <a:ext cx="9875520" cy="603504"/>
+          </a:xfrm>
+          <a:prstGeom prst="rect">
+            <a:avLst/>
+          </a:prstGeom>
+          <a:noFill/>
+        </p:spPr>
+        <p:txBody>
+          <a:bodyPr wrap="square" lIns="0" rIns="0" tIns="0" bIns="0" anchor="t">
+            <a:spAutoFit/>
+          </a:bodyPr>
+          <a:lstStyle/>
+          <a:p>
+            <a:pPr algn="l">
+              <a:lnSpc>
+                <a:spcPct val="105000"/>
+              </a:lnSpc>
+              <a:spcBef>
+                <a:spcPts val="0"/>
+              </a:spcBef>
+            </a:pPr>
+            <a:r>
+              <a:rPr sz="1100" b="0">
+                <a:solidFill>
+                  <a:srgbClr val="1B2A41"/>
+                </a:solidFill>
+                <a:latin typeface="Calibri"/>
+              </a:rPr>
+              <a:t>What is an AI harness? Use the human analogy: what is the brain, and what are the tools?</a:t>
+            </a:r>
+          </a:p>
+          <a:p>
+            <a:pPr algn="l">
+              <a:lnSpc>
+                <a:spcPct val="105000"/>
+              </a:lnSpc>
+              <a:spcBef>
+                <a:spcPts val="200"/>
+              </a:spcBef>
+            </a:pPr>
+            <a:r>
+              <a:rPr sz="900" b="1">
+                <a:solidFill>
+                  <a:srgbClr val="C9A227"/>
+                </a:solidFill>
+                <a:latin typeface="Calibri"/>
+              </a:rPr>
+              <a:t>TIP  </a:t>
+            </a:r>
+            <a:r>
+              <a:rPr sz="900" b="0">
+                <a:solidFill>
+                  <a:srgbClr val="5D6B7E"/>
+                </a:solidFill>
+                <a:latin typeface="Calibri"/>
+              </a:rPr>
+              <a:t>The LLM is the brain. The harness gives it hands: it reads your files, runs commands, sees the error and tries again. Claude Code and Codex are harnesses.</a:t>
+            </a:r>
+          </a:p>
+        </p:txBody>
+      </p:sp>
+      <p:sp>
+        <p:nvSpPr>
+          <p:cNvPr id="9" name="Rectangle 8"/>
+          <p:cNvSpPr/>
+          <p:nvPr/>
+        </p:nvSpPr>
+        <p:spPr>
+          <a:xfrm>
+            <a:off x="548640" y="2377440"/>
+            <a:ext cx="11091672" cy="731520"/>
+          </a:xfrm>
+          <a:prstGeom prst="rect">
+            <a:avLst/>
+          </a:prstGeom>
+          <a:solidFill>
+            <a:srgbClr val="FFFFFF"/>
+          </a:solidFill>
+          <a:ln>
+            <a:noFill/>
+          </a:ln>
+          <a:effectLst/>
+        </p:spPr>
+        <p:style>
+          <a:lnRef idx="1">
+            <a:schemeClr val="accent1"/>
+          </a:lnRef>
+          <a:fillRef idx="3">
+            <a:schemeClr val="accent1"/>
+          </a:fillRef>
+          <a:effectRef idx="2">
+            <a:schemeClr val="accent1"/>
+          </a:effectRef>
+          <a:fontRef idx="minor">
+            <a:schemeClr val="lt1"/>
+          </a:fontRef>
+        </p:style>
+        <p:txBody>
+          <a:bodyPr rtlCol="0" anchor="ctr"/>
+          <a:lstStyle/>
+          <a:p>
+            <a:pPr algn="ctr"/>
+          </a:p>
+        </p:txBody>
+      </p:sp>
+      <p:sp>
+        <p:nvSpPr>
+          <p:cNvPr id="10" name="Rectangle 9"/>
+          <p:cNvSpPr/>
+          <p:nvPr/>
+        </p:nvSpPr>
+        <p:spPr>
+          <a:xfrm>
+            <a:off x="548640" y="2377440"/>
+            <a:ext cx="64008" cy="731520"/>
+          </a:xfrm>
+          <a:prstGeom prst="rect">
+            <a:avLst/>
+          </a:prstGeom>
+          <a:solidFill>
+            <a:srgbClr val="C9A227"/>
+          </a:solidFill>
+          <a:ln>
+            <a:noFill/>
+          </a:ln>
+          <a:effectLst/>
+        </p:spPr>
+        <p:style>
+          <a:lnRef idx="1">
+            <a:schemeClr val="accent1"/>
+          </a:lnRef>
+          <a:fillRef idx="3">
+            <a:schemeClr val="accent1"/>
+          </a:fillRef>
+          <a:effectRef idx="2">
+            <a:schemeClr val="accent1"/>
+          </a:effectRef>
+          <a:fontRef idx="minor">
+            <a:schemeClr val="lt1"/>
+          </a:fontRef>
+        </p:style>
+        <p:txBody>
+          <a:bodyPr rtlCol="0" anchor="ctr"/>
+          <a:lstStyle/>
+          <a:p>
+            <a:pPr algn="ctr"/>
+          </a:p>
+        </p:txBody>
+      </p:sp>
+      <p:sp>
+        <p:nvSpPr>
+          <p:cNvPr id="11" name="TextBox 10"/>
+          <p:cNvSpPr txBox="1"/>
+          <p:nvPr/>
+        </p:nvSpPr>
+        <p:spPr>
+          <a:xfrm>
+            <a:off x="822960" y="2459736"/>
+            <a:ext cx="640080" cy="365760"/>
+          </a:xfrm>
+          <a:prstGeom prst="rect">
+            <a:avLst/>
+          </a:prstGeom>
+          <a:noFill/>
+        </p:spPr>
+        <p:txBody>
+          <a:bodyPr wrap="square" lIns="0" rIns="0" tIns="0" bIns="0" anchor="t">
+            <a:spAutoFit/>
+          </a:bodyPr>
+          <a:lstStyle/>
+          <a:p>
+            <a:pPr algn="l">
+              <a:lnSpc>
+                <a:spcPct val="105000"/>
+              </a:lnSpc>
+              <a:spcBef>
+                <a:spcPts val="0"/>
+              </a:spcBef>
+            </a:pPr>
+            <a:r>
+              <a:rPr sz="1400" b="1">
+                <a:solidFill>
+                  <a:srgbClr val="3A5C9E"/>
+                </a:solidFill>
+                <a:latin typeface="Georgia"/>
+              </a:rPr>
+              <a:t>Q8</a:t>
+            </a:r>
+          </a:p>
+        </p:txBody>
+      </p:sp>
+      <p:sp>
+        <p:nvSpPr>
+          <p:cNvPr id="12" name="TextBox 11"/>
+          <p:cNvSpPr txBox="1"/>
+          <p:nvPr/>
+        </p:nvSpPr>
+        <p:spPr>
+          <a:xfrm>
+            <a:off x="1554480" y="2441448"/>
+            <a:ext cx="9875520" cy="603504"/>
+          </a:xfrm>
+          <a:prstGeom prst="rect">
+            <a:avLst/>
+          </a:prstGeom>
+          <a:noFill/>
+        </p:spPr>
+        <p:txBody>
+          <a:bodyPr wrap="square" lIns="0" rIns="0" tIns="0" bIns="0" anchor="t">
+            <a:spAutoFit/>
+          </a:bodyPr>
+          <a:lstStyle/>
+          <a:p>
+            <a:pPr algn="l">
+              <a:lnSpc>
+                <a:spcPct val="105000"/>
+              </a:lnSpc>
+              <a:spcBef>
+                <a:spcPts val="0"/>
+              </a:spcBef>
+            </a:pPr>
+            <a:r>
+              <a:rPr sz="1100" b="0">
+                <a:solidFill>
+                  <a:srgbClr val="1B2A41"/>
+                </a:solidFill>
+                <a:latin typeface="Calibri"/>
+              </a:rPr>
+              <a:t>What is the difference between an LLM and a harness? Name one LLM and one harness.</a:t>
+            </a:r>
+          </a:p>
+          <a:p>
+            <a:pPr algn="l">
+              <a:lnSpc>
+                <a:spcPct val="105000"/>
+              </a:lnSpc>
+              <a:spcBef>
+                <a:spcPts val="200"/>
+              </a:spcBef>
+            </a:pPr>
+            <a:r>
+              <a:rPr sz="900" b="1">
+                <a:solidFill>
+                  <a:srgbClr val="C9A227"/>
+                </a:solidFill>
+                <a:latin typeface="Calibri"/>
+              </a:rPr>
+              <a:t>TIP  </a:t>
+            </a:r>
+            <a:r>
+              <a:rPr sz="900" b="0">
+                <a:solidFill>
+                  <a:srgbClr val="5D6B7E"/>
+                </a:solidFill>
+                <a:latin typeface="Calibri"/>
+              </a:rPr>
+              <a:t>The LLM predicts text. The harness lets it act in your files and terminal. LLM: Claude. Harness: Claude Code, the app you installed on the desktop.</a:t>
+            </a:r>
+          </a:p>
+        </p:txBody>
+      </p:sp>
+      <p:sp>
+        <p:nvSpPr>
+          <p:cNvPr id="29" name="TextBox 28"/>
+          <p:cNvSpPr txBox="1"/>
+          <p:nvPr/>
+        </p:nvSpPr>
+        <p:spPr>
+          <a:xfrm>
+            <a:off x="548640" y="6446520"/>
+            <a:ext cx="8229600" cy="274320"/>
+          </a:xfrm>
+          <a:prstGeom prst="rect">
+            <a:avLst/>
+          </a:prstGeom>
+          <a:noFill/>
+        </p:spPr>
+        <p:txBody>
+          <a:bodyPr wrap="square" lIns="0" rIns="0" tIns="0" bIns="0" anchor="t">
+            <a:spAutoFit/>
+          </a:bodyPr>
+          <a:lstStyle/>
+          <a:p>
+            <a:pPr algn="l">
+              <a:lnSpc>
+                <a:spcPct val="105000"/>
+              </a:lnSpc>
+              <a:spcBef>
+                <a:spcPts val="0"/>
+              </a:spcBef>
+            </a:pPr>
+            <a:r>
+              <a:rPr sz="900" b="0">
+                <a:solidFill>
+                  <a:srgbClr val="5D6B7E"/>
+                </a:solidFill>
+                <a:latin typeface="Calibri"/>
+              </a:rPr>
+              <a:t>The tip is the shape of the answer, not the whole answer. Two or three sentences each in the exam.</a:t>
+            </a:r>
+          </a:p>
+        </p:txBody>
+      </p:sp>
+      <p:sp>
+        <p:nvSpPr>
+          <p:cNvPr id="30" name="TextBox 29"/>
+          <p:cNvSpPr txBox="1"/>
+          <p:nvPr/>
+        </p:nvSpPr>
+        <p:spPr>
+          <a:xfrm>
+            <a:off x="9262872" y="6446520"/>
+            <a:ext cx="2377440" cy="274320"/>
+          </a:xfrm>
+          <a:prstGeom prst="rect">
+            <a:avLst/>
+          </a:prstGeom>
+          <a:noFill/>
+        </p:spPr>
+        <p:txBody>
+          <a:bodyPr wrap="square" lIns="0" rIns="0" tIns="0" bIns="0" anchor="t">
+            <a:spAutoFit/>
+          </a:bodyPr>
+          <a:lstStyle/>
+          <a:p>
+            <a:pPr algn="r">
+              <a:lnSpc>
+                <a:spcPct val="105000"/>
+              </a:lnSpc>
+              <a:spcBef>
+                <a:spcPts val="0"/>
+              </a:spcBef>
+            </a:pPr>
+            <a:r>
+              <a:rPr sz="850" b="0">
+                <a:solidFill>
+                  <a:srgbClr val="5D6B7E"/>
+                </a:solidFill>
+                <a:latin typeface="Calibri"/>
+              </a:rPr>
+              <a:t>MODULE 1  ·  24</a:t>
+            </a:r>
+          </a:p>
+        </p:txBody>
+      </p:sp>
+    </p:spTree>
+  </p:cSld>
+  <p:clrMapOvr>
+    <a:masterClrMapping/>
+  </p:clrMapOvr>
+</p:sld>
+</file>
+
+<file path=ppt/slides/slide25.xml><?xml version="1.0" encoding="utf-8"?>
 <p:sld xmlns:a="http://schemas.openxmlformats.org/drawingml/2006/main" xmlns:r="http://schemas.openxmlformats.org/officeDocument/2006/relationships" xmlns:p="http://schemas.openxmlformats.org/presentationml/2006/main" xmlns:m="http://schemas.openxmlformats.org/officeDocument/2006/math" xmlns:a14="http://schemas.microsoft.com/office/drawing/2010/main" showMasterSp="1" showMasterPhAnim="1">
   <p:cSld>
     <p:bg>
@@ -25187,643 +25824,6 @@
     <a:masterClrMapping/>
   </p:clrMapOvr>
   <p:transition xmlns:p14="http://schemas.microsoft.com/office/powerpoint/2010/main" spd="med" advClick="1"/>
-</p:sld>
-</file>
-
-<file path=ppt/slides/slide25.xml><?xml version="1.0" encoding="utf-8"?>
-<p:sld xmlns:a="http://schemas.openxmlformats.org/drawingml/2006/main" xmlns:p="http://schemas.openxmlformats.org/presentationml/2006/main" xmlns:r="http://schemas.openxmlformats.org/officeDocument/2006/relationships">
-  <p:cSld>
-    <p:bg>
-      <p:bgPr>
-        <a:solidFill>
-          <a:srgbClr val="F7F8FA"/>
-        </a:solidFill>
-      </p:bgPr>
-    </p:bg>
-    <p:spTree>
-      <p:nvGrpSpPr>
-        <p:cNvPr id="1" name=""/>
-        <p:cNvGrpSpPr/>
-        <p:nvPr/>
-      </p:nvGrpSpPr>
-      <p:grpSpPr/>
-      <p:sp>
-        <p:nvSpPr>
-          <p:cNvPr id="2" name="Rectangle 1"/>
-          <p:cNvSpPr/>
-          <p:nvPr/>
-        </p:nvSpPr>
-        <p:spPr>
-          <a:xfrm>
-            <a:off x="548640" y="402336"/>
-            <a:ext cx="118872" cy="118872"/>
-          </a:xfrm>
-          <a:prstGeom prst="rect">
-            <a:avLst/>
-          </a:prstGeom>
-          <a:solidFill>
-            <a:srgbClr val="C9A227"/>
-          </a:solidFill>
-          <a:ln>
-            <a:noFill/>
-          </a:ln>
-          <a:effectLst/>
-        </p:spPr>
-        <p:style>
-          <a:lnRef idx="1">
-            <a:schemeClr val="accent1"/>
-          </a:lnRef>
-          <a:fillRef idx="3">
-            <a:schemeClr val="accent1"/>
-          </a:fillRef>
-          <a:effectRef idx="2">
-            <a:schemeClr val="accent1"/>
-          </a:effectRef>
-          <a:fontRef idx="minor">
-            <a:schemeClr val="lt1"/>
-          </a:fontRef>
-        </p:style>
-        <p:txBody>
-          <a:bodyPr rtlCol="0" anchor="ctr"/>
-          <a:lstStyle/>
-          <a:p>
-            <a:pPr algn="ctr"/>
-          </a:p>
-        </p:txBody>
-      </p:sp>
-      <p:sp>
-        <p:nvSpPr>
-          <p:cNvPr id="3" name="TextBox 2"/>
-          <p:cNvSpPr txBox="1"/>
-          <p:nvPr/>
-        </p:nvSpPr>
-        <p:spPr>
-          <a:xfrm>
-            <a:off x="786384" y="310896"/>
-            <a:ext cx="10817352" cy="292608"/>
-          </a:xfrm>
-          <a:prstGeom prst="rect">
-            <a:avLst/>
-          </a:prstGeom>
-          <a:noFill/>
-        </p:spPr>
-        <p:txBody>
-          <a:bodyPr wrap="square" lIns="0" rIns="0" tIns="0" bIns="0" anchor="t">
-            <a:spAutoFit/>
-          </a:bodyPr>
-          <a:lstStyle/>
-          <a:p>
-            <a:pPr algn="l">
-              <a:lnSpc>
-                <a:spcPct val="105000"/>
-              </a:lnSpc>
-              <a:spcBef>
-                <a:spcPts val="0"/>
-              </a:spcBef>
-            </a:pPr>
-            <a:r>
-              <a:rPr sz="1100" b="1">
-                <a:solidFill>
-                  <a:srgbClr val="C9A227"/>
-                </a:solidFill>
-                <a:latin typeface="Calibri"/>
-              </a:rPr>
-              <a:t>PRACTICE QUESTIONS · PART A, CONTINUED</a:t>
-            </a:r>
-          </a:p>
-        </p:txBody>
-      </p:sp>
-      <p:sp>
-        <p:nvSpPr>
-          <p:cNvPr id="4" name="TextBox 3"/>
-          <p:cNvSpPr txBox="1"/>
-          <p:nvPr/>
-        </p:nvSpPr>
-        <p:spPr>
-          <a:xfrm>
-            <a:off x="548640" y="621792"/>
-            <a:ext cx="11091672" cy="685800"/>
-          </a:xfrm>
-          <a:prstGeom prst="rect">
-            <a:avLst/>
-          </a:prstGeom>
-          <a:noFill/>
-        </p:spPr>
-        <p:txBody>
-          <a:bodyPr wrap="square" lIns="0" rIns="0" tIns="0" bIns="0" anchor="t">
-            <a:spAutoFit/>
-          </a:bodyPr>
-          <a:lstStyle/>
-          <a:p>
-            <a:pPr algn="l">
-              <a:lnSpc>
-                <a:spcPct val="105000"/>
-              </a:lnSpc>
-              <a:spcBef>
-                <a:spcPts val="0"/>
-              </a:spcBef>
-            </a:pPr>
-            <a:r>
-              <a:rPr sz="2900" b="1">
-                <a:solidFill>
-                  <a:srgbClr val="0F2145"/>
-                </a:solidFill>
-                <a:latin typeface="Georgia"/>
-              </a:rPr>
-              <a:t>Two more from the mid-term paper</a:t>
-            </a:r>
-          </a:p>
-        </p:txBody>
-      </p:sp>
-      <p:sp>
-        <p:nvSpPr>
-          <p:cNvPr id="5" name="Rectangle 4"/>
-          <p:cNvSpPr/>
-          <p:nvPr/>
-        </p:nvSpPr>
-        <p:spPr>
-          <a:xfrm>
-            <a:off x="548640" y="1572768"/>
-            <a:ext cx="11091672" cy="731520"/>
-          </a:xfrm>
-          <a:prstGeom prst="rect">
-            <a:avLst/>
-          </a:prstGeom>
-          <a:solidFill>
-            <a:srgbClr val="FFFFFF"/>
-          </a:solidFill>
-          <a:ln>
-            <a:noFill/>
-          </a:ln>
-          <a:effectLst/>
-        </p:spPr>
-        <p:style>
-          <a:lnRef idx="1">
-            <a:schemeClr val="accent1"/>
-          </a:lnRef>
-          <a:fillRef idx="3">
-            <a:schemeClr val="accent1"/>
-          </a:fillRef>
-          <a:effectRef idx="2">
-            <a:schemeClr val="accent1"/>
-          </a:effectRef>
-          <a:fontRef idx="minor">
-            <a:schemeClr val="lt1"/>
-          </a:fontRef>
-        </p:style>
-        <p:txBody>
-          <a:bodyPr rtlCol="0" anchor="ctr"/>
-          <a:lstStyle/>
-          <a:p>
-            <a:pPr algn="ctr"/>
-          </a:p>
-        </p:txBody>
-      </p:sp>
-      <p:sp>
-        <p:nvSpPr>
-          <p:cNvPr id="6" name="Rectangle 5"/>
-          <p:cNvSpPr/>
-          <p:nvPr/>
-        </p:nvSpPr>
-        <p:spPr>
-          <a:xfrm>
-            <a:off x="548640" y="1572768"/>
-            <a:ext cx="64008" cy="731520"/>
-          </a:xfrm>
-          <a:prstGeom prst="rect">
-            <a:avLst/>
-          </a:prstGeom>
-          <a:solidFill>
-            <a:srgbClr val="C9A227"/>
-          </a:solidFill>
-          <a:ln>
-            <a:noFill/>
-          </a:ln>
-          <a:effectLst/>
-        </p:spPr>
-        <p:style>
-          <a:lnRef idx="1">
-            <a:schemeClr val="accent1"/>
-          </a:lnRef>
-          <a:fillRef idx="3">
-            <a:schemeClr val="accent1"/>
-          </a:fillRef>
-          <a:effectRef idx="2">
-            <a:schemeClr val="accent1"/>
-          </a:effectRef>
-          <a:fontRef idx="minor">
-            <a:schemeClr val="lt1"/>
-          </a:fontRef>
-        </p:style>
-        <p:txBody>
-          <a:bodyPr rtlCol="0" anchor="ctr"/>
-          <a:lstStyle/>
-          <a:p>
-            <a:pPr algn="ctr"/>
-          </a:p>
-        </p:txBody>
-      </p:sp>
-      <p:sp>
-        <p:nvSpPr>
-          <p:cNvPr id="7" name="TextBox 6"/>
-          <p:cNvSpPr txBox="1"/>
-          <p:nvPr/>
-        </p:nvSpPr>
-        <p:spPr>
-          <a:xfrm>
-            <a:off x="822960" y="1655064"/>
-            <a:ext cx="640080" cy="365760"/>
-          </a:xfrm>
-          <a:prstGeom prst="rect">
-            <a:avLst/>
-          </a:prstGeom>
-          <a:noFill/>
-        </p:spPr>
-        <p:txBody>
-          <a:bodyPr wrap="square" lIns="0" rIns="0" tIns="0" bIns="0" anchor="t">
-            <a:spAutoFit/>
-          </a:bodyPr>
-          <a:lstStyle/>
-          <a:p>
-            <a:pPr algn="l">
-              <a:lnSpc>
-                <a:spcPct val="105000"/>
-              </a:lnSpc>
-              <a:spcBef>
-                <a:spcPts val="0"/>
-              </a:spcBef>
-            </a:pPr>
-            <a:r>
-              <a:rPr sz="1400" b="1">
-                <a:solidFill>
-                  <a:srgbClr val="3A5C9E"/>
-                </a:solidFill>
-                <a:latin typeface="Georgia"/>
-              </a:rPr>
-              <a:t>Q7</a:t>
-            </a:r>
-          </a:p>
-        </p:txBody>
-      </p:sp>
-      <p:sp>
-        <p:nvSpPr>
-          <p:cNvPr id="8" name="TextBox 7"/>
-          <p:cNvSpPr txBox="1"/>
-          <p:nvPr/>
-        </p:nvSpPr>
-        <p:spPr>
-          <a:xfrm>
-            <a:off x="1554480" y="1636776"/>
-            <a:ext cx="9875520" cy="603504"/>
-          </a:xfrm>
-          <a:prstGeom prst="rect">
-            <a:avLst/>
-          </a:prstGeom>
-          <a:noFill/>
-        </p:spPr>
-        <p:txBody>
-          <a:bodyPr wrap="square" lIns="0" rIns="0" tIns="0" bIns="0" anchor="t">
-            <a:spAutoFit/>
-          </a:bodyPr>
-          <a:lstStyle/>
-          <a:p>
-            <a:pPr algn="l">
-              <a:lnSpc>
-                <a:spcPct val="105000"/>
-              </a:lnSpc>
-              <a:spcBef>
-                <a:spcPts val="0"/>
-              </a:spcBef>
-            </a:pPr>
-            <a:r>
-              <a:rPr sz="1100" b="0">
-                <a:solidFill>
-                  <a:srgbClr val="1B2A41"/>
-                </a:solidFill>
-                <a:latin typeface="Calibri"/>
-              </a:rPr>
-              <a:t>What is an AI harness? Use the human analogy: what is the brain, and what are the tools?</a:t>
-            </a:r>
-          </a:p>
-          <a:p>
-            <a:pPr algn="l">
-              <a:lnSpc>
-                <a:spcPct val="105000"/>
-              </a:lnSpc>
-              <a:spcBef>
-                <a:spcPts val="200"/>
-              </a:spcBef>
-            </a:pPr>
-            <a:r>
-              <a:rPr sz="900" b="1">
-                <a:solidFill>
-                  <a:srgbClr val="C9A227"/>
-                </a:solidFill>
-                <a:latin typeface="Calibri"/>
-              </a:rPr>
-              <a:t>TIP  </a:t>
-            </a:r>
-            <a:r>
-              <a:rPr sz="900" b="0">
-                <a:solidFill>
-                  <a:srgbClr val="5D6B7E"/>
-                </a:solidFill>
-                <a:latin typeface="Calibri"/>
-              </a:rPr>
-              <a:t>The LLM is the brain. The harness gives it hands: it reads your files, runs commands, sees the error and tries again. Claude Code and Codex are harnesses.</a:t>
-            </a:r>
-          </a:p>
-        </p:txBody>
-      </p:sp>
-      <p:sp>
-        <p:nvSpPr>
-          <p:cNvPr id="9" name="Rectangle 8"/>
-          <p:cNvSpPr/>
-          <p:nvPr/>
-        </p:nvSpPr>
-        <p:spPr>
-          <a:xfrm>
-            <a:off x="548640" y="2377440"/>
-            <a:ext cx="11091672" cy="731520"/>
-          </a:xfrm>
-          <a:prstGeom prst="rect">
-            <a:avLst/>
-          </a:prstGeom>
-          <a:solidFill>
-            <a:srgbClr val="FFFFFF"/>
-          </a:solidFill>
-          <a:ln>
-            <a:noFill/>
-          </a:ln>
-          <a:effectLst/>
-        </p:spPr>
-        <p:style>
-          <a:lnRef idx="1">
-            <a:schemeClr val="accent1"/>
-          </a:lnRef>
-          <a:fillRef idx="3">
-            <a:schemeClr val="accent1"/>
-          </a:fillRef>
-          <a:effectRef idx="2">
-            <a:schemeClr val="accent1"/>
-          </a:effectRef>
-          <a:fontRef idx="minor">
-            <a:schemeClr val="lt1"/>
-          </a:fontRef>
-        </p:style>
-        <p:txBody>
-          <a:bodyPr rtlCol="0" anchor="ctr"/>
-          <a:lstStyle/>
-          <a:p>
-            <a:pPr algn="ctr"/>
-          </a:p>
-        </p:txBody>
-      </p:sp>
-      <p:sp>
-        <p:nvSpPr>
-          <p:cNvPr id="10" name="Rectangle 9"/>
-          <p:cNvSpPr/>
-          <p:nvPr/>
-        </p:nvSpPr>
-        <p:spPr>
-          <a:xfrm>
-            <a:off x="548640" y="2377440"/>
-            <a:ext cx="64008" cy="731520"/>
-          </a:xfrm>
-          <a:prstGeom prst="rect">
-            <a:avLst/>
-          </a:prstGeom>
-          <a:solidFill>
-            <a:srgbClr val="C9A227"/>
-          </a:solidFill>
-          <a:ln>
-            <a:noFill/>
-          </a:ln>
-          <a:effectLst/>
-        </p:spPr>
-        <p:style>
-          <a:lnRef idx="1">
-            <a:schemeClr val="accent1"/>
-          </a:lnRef>
-          <a:fillRef idx="3">
-            <a:schemeClr val="accent1"/>
-          </a:fillRef>
-          <a:effectRef idx="2">
-            <a:schemeClr val="accent1"/>
-          </a:effectRef>
-          <a:fontRef idx="minor">
-            <a:schemeClr val="lt1"/>
-          </a:fontRef>
-        </p:style>
-        <p:txBody>
-          <a:bodyPr rtlCol="0" anchor="ctr"/>
-          <a:lstStyle/>
-          <a:p>
-            <a:pPr algn="ctr"/>
-          </a:p>
-        </p:txBody>
-      </p:sp>
-      <p:sp>
-        <p:nvSpPr>
-          <p:cNvPr id="11" name="TextBox 10"/>
-          <p:cNvSpPr txBox="1"/>
-          <p:nvPr/>
-        </p:nvSpPr>
-        <p:spPr>
-          <a:xfrm>
-            <a:off x="822960" y="2459736"/>
-            <a:ext cx="640080" cy="365760"/>
-          </a:xfrm>
-          <a:prstGeom prst="rect">
-            <a:avLst/>
-          </a:prstGeom>
-          <a:noFill/>
-        </p:spPr>
-        <p:txBody>
-          <a:bodyPr wrap="square" lIns="0" rIns="0" tIns="0" bIns="0" anchor="t">
-            <a:spAutoFit/>
-          </a:bodyPr>
-          <a:lstStyle/>
-          <a:p>
-            <a:pPr algn="l">
-              <a:lnSpc>
-                <a:spcPct val="105000"/>
-              </a:lnSpc>
-              <a:spcBef>
-                <a:spcPts val="0"/>
-              </a:spcBef>
-            </a:pPr>
-            <a:r>
-              <a:rPr sz="1400" b="1">
-                <a:solidFill>
-                  <a:srgbClr val="3A5C9E"/>
-                </a:solidFill>
-                <a:latin typeface="Georgia"/>
-              </a:rPr>
-              <a:t>Q8</a:t>
-            </a:r>
-          </a:p>
-        </p:txBody>
-      </p:sp>
-      <p:sp>
-        <p:nvSpPr>
-          <p:cNvPr id="12" name="TextBox 11"/>
-          <p:cNvSpPr txBox="1"/>
-          <p:nvPr/>
-        </p:nvSpPr>
-        <p:spPr>
-          <a:xfrm>
-            <a:off x="1554480" y="2441448"/>
-            <a:ext cx="9875520" cy="603504"/>
-          </a:xfrm>
-          <a:prstGeom prst="rect">
-            <a:avLst/>
-          </a:prstGeom>
-          <a:noFill/>
-        </p:spPr>
-        <p:txBody>
-          <a:bodyPr wrap="square" lIns="0" rIns="0" tIns="0" bIns="0" anchor="t">
-            <a:spAutoFit/>
-          </a:bodyPr>
-          <a:lstStyle/>
-          <a:p>
-            <a:pPr algn="l">
-              <a:lnSpc>
-                <a:spcPct val="105000"/>
-              </a:lnSpc>
-              <a:spcBef>
-                <a:spcPts val="0"/>
-              </a:spcBef>
-            </a:pPr>
-            <a:r>
-              <a:rPr sz="1100" b="0">
-                <a:solidFill>
-                  <a:srgbClr val="1B2A41"/>
-                </a:solidFill>
-                <a:latin typeface="Calibri"/>
-              </a:rPr>
-              <a:t>What is the difference between an LLM and a harness? Name one LLM and one harness.</a:t>
-            </a:r>
-          </a:p>
-          <a:p>
-            <a:pPr algn="l">
-              <a:lnSpc>
-                <a:spcPct val="105000"/>
-              </a:lnSpc>
-              <a:spcBef>
-                <a:spcPts val="200"/>
-              </a:spcBef>
-            </a:pPr>
-            <a:r>
-              <a:rPr sz="900" b="1">
-                <a:solidFill>
-                  <a:srgbClr val="C9A227"/>
-                </a:solidFill>
-                <a:latin typeface="Calibri"/>
-              </a:rPr>
-              <a:t>TIP  </a:t>
-            </a:r>
-            <a:r>
-              <a:rPr sz="900" b="0">
-                <a:solidFill>
-                  <a:srgbClr val="5D6B7E"/>
-                </a:solidFill>
-                <a:latin typeface="Calibri"/>
-              </a:rPr>
-              <a:t>The LLM predicts text. The harness lets it act in your files and terminal. LLM: Claude. Harness: Claude Code, the app you installed on the desktop.</a:t>
-            </a:r>
-          </a:p>
-        </p:txBody>
-      </p:sp>
-      <p:sp>
-        <p:nvSpPr>
-          <p:cNvPr id="29" name="TextBox 28"/>
-          <p:cNvSpPr txBox="1"/>
-          <p:nvPr/>
-        </p:nvSpPr>
-        <p:spPr>
-          <a:xfrm>
-            <a:off x="548640" y="6446520"/>
-            <a:ext cx="8229600" cy="274320"/>
-          </a:xfrm>
-          <a:prstGeom prst="rect">
-            <a:avLst/>
-          </a:prstGeom>
-          <a:noFill/>
-        </p:spPr>
-        <p:txBody>
-          <a:bodyPr wrap="square" lIns="0" rIns="0" tIns="0" bIns="0" anchor="t">
-            <a:spAutoFit/>
-          </a:bodyPr>
-          <a:lstStyle/>
-          <a:p>
-            <a:pPr algn="l">
-              <a:lnSpc>
-                <a:spcPct val="105000"/>
-              </a:lnSpc>
-              <a:spcBef>
-                <a:spcPts val="0"/>
-              </a:spcBef>
-            </a:pPr>
-            <a:r>
-              <a:rPr sz="900" b="0">
-                <a:solidFill>
-                  <a:srgbClr val="5D6B7E"/>
-                </a:solidFill>
-                <a:latin typeface="Calibri"/>
-              </a:rPr>
-              <a:t>The tip is the shape of the answer, not the whole answer. Two or three sentences each in the exam.</a:t>
-            </a:r>
-          </a:p>
-        </p:txBody>
-      </p:sp>
-      <p:sp>
-        <p:nvSpPr>
-          <p:cNvPr id="30" name="TextBox 29"/>
-          <p:cNvSpPr txBox="1"/>
-          <p:nvPr/>
-        </p:nvSpPr>
-        <p:spPr>
-          <a:xfrm>
-            <a:off x="9262872" y="6446520"/>
-            <a:ext cx="2377440" cy="274320"/>
-          </a:xfrm>
-          <a:prstGeom prst="rect">
-            <a:avLst/>
-          </a:prstGeom>
-          <a:noFill/>
-        </p:spPr>
-        <p:txBody>
-          <a:bodyPr wrap="square" lIns="0" rIns="0" tIns="0" bIns="0" anchor="t">
-            <a:spAutoFit/>
-          </a:bodyPr>
-          <a:lstStyle/>
-          <a:p>
-            <a:pPr algn="r">
-              <a:lnSpc>
-                <a:spcPct val="105000"/>
-              </a:lnSpc>
-              <a:spcBef>
-                <a:spcPts val="0"/>
-              </a:spcBef>
-            </a:pPr>
-            <a:r>
-              <a:rPr sz="850" b="0">
-                <a:solidFill>
-                  <a:srgbClr val="5D6B7E"/>
-                </a:solidFill>
-                <a:latin typeface="Calibri"/>
-              </a:rPr>
-              <a:t>MODULE 1  ·  24</a:t>
-            </a:r>
-          </a:p>
-        </p:txBody>
-      </p:sp>
-    </p:spTree>
-  </p:cSld>
-  <p:clrMapOvr>
-    <a:masterClrMapping/>
-  </p:clrMapOvr>
 </p:sld>
 </file>
 

</xml_diff>

<commit_message>
Modules 1-3: continuation question slides run on without a heading
Co-Authored-By: Claude Fable 5.1 <noreply@anthropic.com>
</commit_message>
<xml_diff>
--- a/slides/Module-01-Foundations-of-Agentic-AI.pptx
+++ b/slides/Module-01-Foundations-of-Agentic-AI.pptx
@@ -24548,49 +24548,7 @@
                 </a:solidFill>
                 <a:latin typeface="Calibri"/>
               </a:rPr>
-              <a:t>PRACTICE QUESTIONS · PART A, CONTINUED</a:t>
-            </a:r>
-          </a:p>
-        </p:txBody>
-      </p:sp>
-      <p:sp>
-        <p:nvSpPr>
-          <p:cNvPr id="4" name="TextBox 3"/>
-          <p:cNvSpPr txBox="1"/>
-          <p:nvPr/>
-        </p:nvSpPr>
-        <p:spPr>
-          <a:xfrm>
-            <a:off x="548640" y="621792"/>
-            <a:ext cx="11091672" cy="685800"/>
-          </a:xfrm>
-          <a:prstGeom prst="rect">
-            <a:avLst/>
-          </a:prstGeom>
-          <a:noFill/>
-        </p:spPr>
-        <p:txBody>
-          <a:bodyPr wrap="square" lIns="0" rIns="0" tIns="0" bIns="0" anchor="t">
-            <a:spAutoFit/>
-          </a:bodyPr>
-          <a:lstStyle/>
-          <a:p>
-            <a:pPr algn="l">
-              <a:lnSpc>
-                <a:spcPct val="105000"/>
-              </a:lnSpc>
-              <a:spcBef>
-                <a:spcPts val="0"/>
-              </a:spcBef>
-            </a:pPr>
-            <a:r>
-              <a:rPr sz="2900" b="1">
-                <a:solidFill>
-                  <a:srgbClr val="0F2145"/>
-                </a:solidFill>
-                <a:latin typeface="Georgia"/>
-              </a:rPr>
-              <a:t>Two more on today's basics</a:t>
+              <a:t>PRACTICE QUESTIONS · PART A</a:t>
             </a:r>
           </a:p>
         </p:txBody>
@@ -24603,7 +24561,7 @@
         </p:nvSpPr>
         <p:spPr>
           <a:xfrm>
-            <a:off x="548640" y="1572768"/>
+            <a:off x="548640" y="914400"/>
             <a:ext cx="11091672" cy="731520"/>
           </a:xfrm>
           <a:prstGeom prst="rect">
@@ -24647,7 +24605,7 @@
         </p:nvSpPr>
         <p:spPr>
           <a:xfrm>
-            <a:off x="548640" y="1572768"/>
+            <a:off x="548640" y="914400"/>
             <a:ext cx="64008" cy="731520"/>
           </a:xfrm>
           <a:prstGeom prst="rect">
@@ -24691,7 +24649,7 @@
         </p:nvSpPr>
         <p:spPr>
           <a:xfrm>
-            <a:off x="822960" y="1655064"/>
+            <a:off x="822960" y="996696"/>
             <a:ext cx="640080" cy="365760"/>
           </a:xfrm>
           <a:prstGeom prst="rect">
@@ -24733,7 +24691,7 @@
         </p:nvSpPr>
         <p:spPr>
           <a:xfrm>
-            <a:off x="1554480" y="1636776"/>
+            <a:off x="1554480" y="978408"/>
             <a:ext cx="9875520" cy="603504"/>
           </a:xfrm>
           <a:prstGeom prst="rect">
@@ -24803,7 +24761,7 @@
         </p:nvSpPr>
         <p:spPr>
           <a:xfrm>
-            <a:off x="548640" y="2377440"/>
+            <a:off x="548640" y="1719072"/>
             <a:ext cx="11091672" cy="731520"/>
           </a:xfrm>
           <a:prstGeom prst="rect">
@@ -24847,7 +24805,7 @@
         </p:nvSpPr>
         <p:spPr>
           <a:xfrm>
-            <a:off x="548640" y="2377440"/>
+            <a:off x="548640" y="1719072"/>
             <a:ext cx="64008" cy="731520"/>
           </a:xfrm>
           <a:prstGeom prst="rect">
@@ -24891,7 +24849,7 @@
         </p:nvSpPr>
         <p:spPr>
           <a:xfrm>
-            <a:off x="822960" y="2459736"/>
+            <a:off x="822960" y="1801368"/>
             <a:ext cx="640080" cy="365760"/>
           </a:xfrm>
           <a:prstGeom prst="rect">
@@ -24933,7 +24891,7 @@
         </p:nvSpPr>
         <p:spPr>
           <a:xfrm>
-            <a:off x="1554480" y="2441448"/>
+            <a:off x="1554480" y="1783080"/>
             <a:ext cx="9875520" cy="603504"/>
           </a:xfrm>
           <a:prstGeom prst="rect">

</xml_diff>